<commit_message>
docs: focus presentation and manuals on current product usage
</commit_message>
<xml_diff>
--- a/frontend/public/documentacao/apresentacao.pptx
+++ b/frontend/public/documentacao/apresentacao.pptx
@@ -521,7 +521,7 @@
           <a:lstStyle/>
           <a:p>
             <a:r>
-              <a:t>Apresente a jornada integrada: cadastro, planejamento, venda, operação e análise. Os recursos descritos correspondem à implementação atual; módulos futuros aparecem ao final.</a:t>
+              <a:t>Nexus Rotafy Painel web para gestão e atendimento Android para motorista e guia Bilhete individual para o passageiro</a:t>
             </a:r>
           </a:p>
         </p:txBody>
@@ -591,7 +591,7 @@
           <a:lstStyle/>
           <a:p>
             <a:r>
-              <a:t>Uma consulta não bloqueia vagas. O backend confere a capacidade novamente no salvamento. A família não é dividida automaticamente entre ônibus.</a:t>
+              <a:t>Um responsável, um telefone e vários passageiros. Menu Vender bilhete, sem abrir o cadastro da viagem. Disponibilidade por segmento e sugestão de veículo para o grupo. Bloqueios de 15 minutos, confirmação, cancelamento e realocação. Importação CSV/XLSX com prévia e validação do lote.</a:t>
             </a:r>
           </a:p>
         </p:txBody>
@@ -661,7 +661,7 @@
           <a:lstStyle/>
           <a:p>
             <a:r>
-              <a:t>O passageiro usa o navegador, sem aplicativo próprio. Reemitir invalida os links anteriores e exige preparar novamente os manifestos offline.</a:t>
+              <a:t>O mesmo bilhete em todos os trechos contratados. Página privada com etapas, pontos, horários e veículos. Impressão/PDF, download do QR e compartilhamento do link. Envio do link pelo WhatsApp ao telefone da reserva. Reemissão e revogação para todos os trechos do passageiro.</a:t>
             </a:r>
           </a:p>
         </p:txBody>
@@ -731,7 +731,7 @@
           <a:lstStyle/>
           <a:p>
             <a:r>
-              <a:t>As integrações dependem de configuração e sessão conectada. Envios incertos do OpenWA não são repetidos automaticamente; homologação real ocorre com telefone autorizado.</a:t>
+              <a:t>WhatsApp e e-mail aproximam sua equipe dos clientes. Confirmação, cancelamento e registro de pagamento por WhatsApp. Resumo da reserva e link do bilhete enviados pelo atendimento. Convites da equipe por WhatsApp, e-mail ou ambos. Histórico de mensagens para acompanhar o atendimento.</a:t>
             </a:r>
           </a:p>
         </p:txBody>
@@ -801,7 +801,7 @@
           <a:lstStyle/>
           <a:p>
             <a:r>
-              <a:t>Biometria forte protege o acesso salvo em Android compatível. Ela não elimina a validação de permissões pelo backend. Não há versão iOS homologada nesta entrega.</a:t>
+              <a:t>A viagem na mão de quem executa a operação. Viagens atribuídas e agenda dos próximos sete dias. QR pela câmera, lista e filtros de passageiros. Iniciar viagem, desembarcar todos e registrar chegada. Login biométrico opcional em aparelhos compatíveis.</a:t>
             </a:r>
           </a:p>
         </p:txBody>
@@ -871,7 +871,7 @@
           <a:lstStyle/>
           <a:p>
             <a:r>
-              <a:t>Validade de até oito horas, limitada também pela sessão. Não apagar dados ou desinstalar para resolver pendências. Mudanças de outros aparelhos podem exigir revisão.</a:t>
+              <a:t>Lista de passageiros disponível durante o percurso. Prepare a lista do veículo antes de sair. Registre embarques e desembarques mesmo sem conexão. Sincronize os registros ao recuperar a internet. Inicie e finalize o deslocamento com conexão disponível.</a:t>
             </a:r>
           </a:p>
         </p:txBody>
@@ -941,7 +941,7 @@
           <a:lstStyle/>
           <a:p>
             <a:r>
-              <a:t>O fechamento exige desembarques e sincronização. Encerramento administrativo não é apresentado como chegada física se não houver registro de chegada.</a:t>
+              <a:t>Finalização consultável por veículo e trecho. Saída, chegada, responsável e horários registrados. GPS pontual: coordenadas, precisão e horário da captura. Link para consultar o ponto da chegada no Maps. Conclusão geral após todos os veículos e etapas previstos.</a:t>
             </a:r>
           </a:p>
         </p:txBody>
@@ -1011,7 +1011,7 @@
           <a:lstStyle/>
           <a:p>
             <a:r>
-              <a:t>Não confundir deslocamentos com consumo comercial. Pacotes não duplicam famílias por etapa. O gráfico diário permite consultar os valores do dia.</a:t>
+              <a:t>Período, situação, veículo e viagem em uma visão integrada. Deslocamentos diários e viagens comerciais iniciadas. Ocupação máxima confirmada por veículo/deslocamento. Valores confirmados, PAGO, ticket médio e produtos vendidos. Baixa ocupação, presença, franquia e exportação CSV.</a:t>
             </a:r>
           </a:p>
         </p:txBody>
@@ -1081,7 +1081,7 @@
           <a:lstStyle/>
           <a:p>
             <a:r>
-              <a:t>O superadmin cadastra API-keys e remetente pelo painel. Planos são versionados; os demonstrativos não emitem cobrança nem integram pagamentos.</a:t>
+              <a:t>Empresas, planos e assinaturas em um só painel. Basic, Professional, Enterprise e planos adicionais configuráveis. Franquia mensal, mensalidade e valor da unidade extra. Uma viagem simples = uma unidade; pacote = destinos comerciais. Cancelamento estorna o consumo no ciclo original.</a:t>
             </a:r>
           </a:p>
         </p:txBody>
@@ -1151,7 +1151,7 @@
           <a:lstStyle/>
           <a:p>
             <a:r>
-              <a:t>Recomende homologar a primeira jornada com usuários e telefones autorizados antes de ampliar a operação. Acesse a central de documentação sem precisar de login.</a:t>
+              <a:t>Um roteiro simples para colocar a equipe em funcionamento. 1 · Empresa, plano, equipe e veículo cadastrados. 2 · Rota criada e viagem agendada com equipe atribuída. 3 · Reserva confirmada, PAGO conferido e bilhete enviado. 4 · Manifesto preparado, embarque realizado e chegada registrada.</a:t>
             </a:r>
           </a:p>
         </p:txBody>
@@ -1221,7 +1221,7 @@
           <a:lstStyle/>
           <a:p>
             <a:r>
-              <a:t>A página pública possui código implementado, mas seu menu está desabilitado. Não apresentar como nova oferta disponível sem orientação da Nexus. O passageiro atual consulta o bilhete web.</a:t>
+              <a:t>Da preparação do roteiro à análise dos resultados. Reutilize rotas e pacotes para organizar novas saídas. Centralize passageiros, reservas e disponibilidade de lugares. Conecte atendimento, motorista e guia na mesma operação. Acompanhe ocupação, vendas e execução das viagens.</a:t>
             </a:r>
           </a:p>
         </p:txBody>
@@ -1291,7 +1291,7 @@
           <a:lstStyle/>
           <a:p>
             <a:r>
-              <a:t>Demonstre o fluxo em vez de apresentar apenas menus. O atendimento prepara a viagem e a equipe registra sua execução.</a:t>
+              <a:t>Planejar → vender → embarcar → concluir → analisar Rotas e pacotes reutilizáveis reduzem o recadastro. Reservas conectam famílias, lugares e deslocamentos. QR e manifestos ligam o atendimento à equipe na estrada. Chegadas e relatórios dão visibilidade ao gestor.</a:t>
             </a:r>
           </a:p>
         </p:txBody>
@@ -1361,7 +1361,7 @@
           <a:lstStyle/>
           <a:p>
             <a:r>
-              <a:t>Encerre abrindo uma demonstração da jornada adequada ao perfil da empresa. A central de documentação pode ser acessada no login ou no menu lateral do painel.</a:t>
+              <a:t>Planejamento, atendimento e equipe conectados. Conheça o sistema: frotafy.nexusdataanalytics.tech Manual e downloads: /ajuda Central com HTML, PDF e apresentação editável</a:t>
             </a:r>
           </a:p>
         </p:txBody>
@@ -1431,7 +1431,7 @@
           <a:lstStyle/>
           <a:p>
             <a:r>
-              <a:t>Explique a diferença entre conta Nexus e conta da empresa. O superadmin não representa uma empresa operacional padrão.</a:t>
+              <a:t>Uma plataforma compartilhada, com operação segregada. Cadastros, viagens, reservas e históricos pertencem à empresa. Acesso definido pelo identificador da empresa e pelo perfil do usuário. Um profissional de várias empresas possui um cadastro em cada uma. Nexus administra empresas, planos e configurações da plataforma.</a:t>
             </a:r>
           </a:p>
         </p:txBody>
@@ -1501,7 +1501,7 @@
           <a:lstStyle/>
           <a:p>
             <a:r>
-              <a:t>Evite apresentar o perfil Regular como um sistema completo de linhas recorrentes. A base operacional já existe; essas regras adicionais permanecem pendentes.</a:t>
+              <a:t>O cadastro inicial orienta a experiência da empresa. Turismo: viagens simples, transfers e pacotes com vários destinos. Regular: viagens simples, Rotas, frota, reservas e embarque. Os menus turísticos ficam ocultos no perfil Regular. Perfil operacional e plano comercial são escolhas independentes.</a:t>
             </a:r>
           </a:p>
         </p:txBody>
@@ -1571,7 +1571,7 @@
           <a:lstStyle/>
           <a:p>
             <a:r>
-              <a:t>O telefone é obrigatório para convites por WhatsApp. O e-mail permanece como identificador de login. Nos dois canais é enviado o mesmo link, não uma senha temporária.</a:t>
+              <a:t>Administrador, atendente, motorista e guia. Cadastro, ativação e suspensão de colaboradores. Convite por e-mail, WhatsApp ou pelos dois canais. Link de 24 horas para definir a própria senha. Recuperação de acesso e registro de atividades.</a:t>
             </a:r>
           </a:p>
         </p:txBody>
@@ -1641,7 +1641,7 @@
           <a:lstStyle/>
           <a:p>
             <a:r>
-              <a:t>A capacidade é copiada para a saída, preservando o histórico. O mesmo veículo pode operar novamente em outros horários compatíveis.</a:t>
+              <a:t>Capacidade e equipe conectadas ao planejamento. Cadastro de veículo, placa e quantidade de lugares. Vários veículos na mesma viagem ou deslocamento. Motorista e guias definidos em cada alocação. Conflitos de horários e capacidade verificados ao salvar.</a:t>
             </a:r>
           </a:p>
         </p:txBody>
@@ -1711,7 +1711,7 @@
           <a:lstStyle/>
           <a:p>
             <a:r>
-              <a:t>Mostre o catálogo. O botão Atualizar com a versão atual da Rota existe nos detalhes de saídas elegíveis e exige validação e atualização dos manifestos.</a:t>
+              <a:t>Cidades, endereços, paradas e duração estimada. UF e cidade para origem e destino. Paradas ordenadas de embarque, desembarque ou ambos. Somente ida ou ida e volta, com sugestão de retorno invertido. Navegação abre o Google Maps externo.</a:t>
             </a:r>
           </a:p>
         </p:txBody>
@@ -1781,7 +1781,7 @@
           <a:lstStyle/>
           <a:p>
             <a:r>
-              <a:t>Passeios nos dias 1 e 3 geram ida/volta em cada data. Circuito pode sair no dia 1, seguir no dia 3 e retornar no dia 6. Destinos separados exigem outro pacote.</a:t>
+              <a:t>Dois formatos para simplificar o roteiro. Passeios: cada dia retorna à mesma cidade-base. Sequência: várias cidades, com permanência e dias livres. Modelo com dias relativos; datas reais são definidas na saída. Venda do pacote completo, com retorno incluído.</a:t>
             </a:r>
           </a:p>
         </p:txBody>
@@ -1851,7 +1851,7 @@
           <a:lstStyle/>
           <a:p>
             <a:r>
-              <a:t>Editar um catálogo não reescreve a viagem. A atualização explícita de Rota é permitida apenas dentro das regras de reservas e embarques.</a:t>
+              <a:t>Rota ou pacote + data + horários + veículos + equipe. Viagem simples com trecho único ou ida e volta. Saída de pacote com todas as etapas e chegadas previstas. Troca de veículo e equipe entre deslocamentos do roteiro. Filtros de situação, edição protegida, duplicação e cancelamento.</a:t>
             </a:r>
           </a:p>
         </p:txBody>
@@ -6268,7 +6268,7 @@
               </a:defRPr>
             </a:pPr>
             <a:r>
-              <a:t>OpenWA para WhatsApp. Resend para e-mails de acesso.</a:t>
+              <a:t>WhatsApp e e-mail aproximam sua equipe dos clientes.</a:t>
             </a:r>
           </a:p>
         </p:txBody>
@@ -6307,7 +6307,7 @@
               </a:defRPr>
             </a:pPr>
             <a:r>
-              <a:t>• Confirmação, cancelamento e PAGO geram mensagens de reserva.</a:t>
+              <a:t>• Confirmação, cancelamento e registro de pagamento por WhatsApp.</a:t>
             </a:r>
           </a:p>
           <a:p>
@@ -6323,7 +6323,7 @@
               </a:defRPr>
             </a:pPr>
             <a:r>
-              <a:t>• Resumo e link do bilhete podem ser enviados manualmente.</a:t>
+              <a:t>• Resumo da reserva e link do bilhete enviados pelo atendimento.</a:t>
             </a:r>
           </a:p>
           <a:p>
@@ -6339,7 +6339,7 @@
               </a:defRPr>
             </a:pPr>
             <a:r>
-              <a:t>• Convites de colaboradores por um ou dois canais.</a:t>
+              <a:t>• Convites da equipe por WhatsApp, e-mail ou ambos.</a:t>
             </a:r>
           </a:p>
           <a:p>
@@ -6355,7 +6355,7 @@
               </a:defRPr>
             </a:pPr>
             <a:r>
-              <a:t>• Fila persistente e histórico de processamento.</a:t>
+              <a:t>• Histórico de mensagens para acompanhar o atendimento.</a:t>
             </a:r>
           </a:p>
         </p:txBody>
@@ -6394,7 +6394,7 @@
               </a:defRPr>
             </a:pPr>
             <a:r>
-              <a:t>Cada empresa usa sua sessão/número. Aceitação pelo provedor não comprova entrega/leitura.</a:t>
+              <a:t>Cada empresa se comunica com seus clientes pelo próprio número.</a:t>
             </a:r>
           </a:p>
         </p:txBody>
@@ -7048,7 +7048,7 @@
               </a:defRPr>
             </a:pPr>
             <a:r>
-              <a:t>Manifesto local e fila de ações por operador.</a:t>
+              <a:t>Lista de passageiros disponível durante o percurso.</a:t>
             </a:r>
           </a:p>
         </p:txBody>
@@ -7087,7 +7087,7 @@
               </a:defRPr>
             </a:pPr>
             <a:r>
-              <a:t>• Preparação separada por veículo e deslocamento.</a:t>
+              <a:t>• Prepare a lista do veículo antes de sair.</a:t>
             </a:r>
           </a:p>
           <a:p>
@@ -7103,7 +7103,7 @@
               </a:defRPr>
             </a:pPr>
             <a:r>
-              <a:t>• Embarques e desembarques offline com manifesto válido.</a:t>
+              <a:t>• Registre embarques e desembarques mesmo sem conexão.</a:t>
             </a:r>
           </a:p>
           <a:p>
@@ -7119,7 +7119,7 @@
               </a:defRPr>
             </a:pPr>
             <a:r>
-              <a:t>• Revalidação no servidor ao reconectar e revisão de conflitos.</a:t>
+              <a:t>• Sincronize os registros ao recuperar a internet.</a:t>
             </a:r>
           </a:p>
           <a:p>
@@ -7135,7 +7135,7 @@
               </a:defRPr>
             </a:pPr>
             <a:r>
-              <a:t>• Saída e chegada exigem conexão.</a:t>
+              <a:t>• Inicie e finalize o deslocamento com conexão disponível.</a:t>
             </a:r>
           </a:p>
         </p:txBody>
@@ -7564,7 +7564,7 @@
               </a:defRPr>
             </a:pPr>
             <a:r>
-              <a:t>Sem posição válida, registra o motivo. Este recurso não faz rastreamento contínuo.</a:t>
+              <a:t>O registro da chegada fica disponível nos detalhes da viagem.</a:t>
             </a:r>
           </a:p>
         </p:txBody>
@@ -8242,7 +8242,7 @@
               </a:defRPr>
             </a:pPr>
             <a:r>
-              <a:t>Empresas, planos, assinaturas e integrações.</a:t>
+              <a:t>Empresas, planos e assinaturas em um só painel.</a:t>
             </a:r>
           </a:p>
         </p:txBody>
@@ -8944,7 +8944,7 @@
               </a:defRPr>
             </a:pPr>
             <a:r>
-              <a:t>DISPONIBILIDADE ATUAL</a:t>
+              <a:t>VALOR PARA SUA EMPRESA</a:t>
             </a:r>
           </a:p>
         </p:txBody>
@@ -8983,7 +8983,7 @@
               </a:defRPr>
             </a:pPr>
             <a:r>
-              <a:t>Escopo claro para a próxima evolução</a:t>
+              <a:t>Mais organização em cada etapa</a:t>
             </a:r>
           </a:p>
         </p:txBody>
@@ -9022,7 +9022,7 @@
               </a:defRPr>
             </a:pPr>
             <a:r>
-              <a:t>O que existe hoje e o que permanece no planejamento.</a:t>
+              <a:t>Da preparação do roteiro à análise dos resultados.</a:t>
             </a:r>
           </a:p>
         </p:txBody>
@@ -9061,7 +9061,7 @@
               </a:defRPr>
             </a:pPr>
             <a:r>
-              <a:t>• Hoje: gestão web, Android operacional, QR, mensagens e relatórios.</a:t>
+              <a:t>• Reutilize rotas e pacotes para organizar novas saídas.</a:t>
             </a:r>
           </a:p>
           <a:p>
@@ -9077,7 +9077,7 @@
               </a:defRPr>
             </a:pPr>
             <a:r>
-              <a:t>• Menu oculto: página pública e integrações externas de reservas.</a:t>
+              <a:t>• Centralize passageiros, reservas e disponibilidade de lugares.</a:t>
             </a:r>
           </a:p>
           <a:p>
@@ -9093,7 +9093,7 @@
               </a:defRPr>
             </a:pPr>
             <a:r>
-              <a:t>• Futuro: app do passageiro, iOS, lembretes e rastreamento contínuo.</a:t>
+              <a:t>• Conecte atendimento, motorista e guia na mesma operação.</a:t>
             </a:r>
           </a:p>
           <a:p>
@@ -9109,7 +9109,7 @@
               </a:defRPr>
             </a:pPr>
             <a:r>
-              <a:t>• Futuro: pagamentos integrados, Google API e linhas recorrentes.</a:t>
+              <a:t>• Acompanhe ocupação, vendas e execução das viagens.</a:t>
             </a:r>
           </a:p>
         </p:txBody>
@@ -9148,7 +9148,7 @@
               </a:defRPr>
             </a:pPr>
             <a:r>
-              <a:t>Nenhum prazo futuro é prometido nesta apresentação.</a:t>
+              <a:t>Uma visão compartilhada para tomar decisões com mais clareza.</a:t>
             </a:r>
           </a:p>
         </p:txBody>
@@ -10279,7 +10279,7 @@
               </a:defRPr>
             </a:pPr>
             <a:r>
-              <a:t>• Nexus administra empresas, planos e integrações globais.</a:t>
+              <a:t>• Nexus administra empresas, planos e configurações da plataforma.</a:t>
             </a:r>
           </a:p>
         </p:txBody>
@@ -10708,7 +10708,7 @@
               </a:defRPr>
             </a:pPr>
             <a:r>
-              <a:t>Recorrência automática e venda independente de segmentos ainda são etapas futuras.</a:t>
+              <a:t>Uma experiência organizada para cada tipo de operação.</a:t>
             </a:r>
           </a:p>
         </p:txBody>

</xml_diff>

<commit_message>
fix: deploy production on rotafy.nexusdataanalytics.tech
</commit_message>
<xml_diff>
--- a/frontend/public/documentacao/apresentacao.pptx
+++ b/frontend/public/documentacao/apresentacao.pptx
@@ -1361,7 +1361,7 @@
           <a:lstStyle/>
           <a:p>
             <a:r>
-              <a:t>Planejamento, atendimento e equipe conectados. Conheça o sistema: frotafy.nexusdataanalytics.tech Manual e downloads: /ajuda Central com HTML, PDF e apresentação editável</a:t>
+              <a:t>Planejamento, atendimento e equipe conectados. Conheça o sistema: rotafy.nexusdataanalytics.tech Manual e downloads: /ajuda Central com HTML, PDF e apresentação editável</a:t>
             </a:r>
           </a:p>
         </p:txBody>
@@ -9857,7 +9857,7 @@
               </a:defRPr>
             </a:pPr>
             <a:r>
-              <a:t>• Conheça o sistema: frotafy.nexusdataanalytics.tech</a:t>
+              <a:t>• Conheça o sistema: rotafy.nexusdataanalytics.tech</a:t>
             </a:r>
           </a:p>
           <a:p>

</xml_diff>

<commit_message>
docs: refresh help manuals and commercial presentation
</commit_message>
<xml_diff>
--- a/frontend/public/documentacao/apresentacao.pptx
+++ b/frontend/public/documentacao/apresentacao.pptx
@@ -25,6 +25,11 @@
     <p:sldId id="273" r:id="rId25"/>
     <p:sldId id="274" r:id="rId26"/>
     <p:sldId id="275" r:id="rId27"/>
+    <p:sldId id="276" r:id="rId28"/>
+    <p:sldId id="277" r:id="rId29"/>
+    <p:sldId id="278" r:id="rId30"/>
+    <p:sldId id="279" r:id="rId31"/>
+    <p:sldId id="280" r:id="rId32"/>
   </p:sldIdLst>
   <p:sldSz cx="12191695" cy="6858000" type="screen4x3"/>
   <p:notesSz cx="6858000" cy="9144000"/>
@@ -521,7 +526,7 @@
           <a:lstStyle/>
           <a:p>
             <a:r>
-              <a:t>Nexus Rotafy Painel web para gestão e atendimento Android para motorista e guia Bilhete individual para o passageiro</a:t>
+              <a:t>Nexus Rotafy Painel web para gestão e atendimento Android para motorista e guia Bilhete individual para o passageiro Apresentação do sistema · Edição 2026.10 · 22/10/2026</a:t>
             </a:r>
           </a:p>
         </p:txBody>
@@ -591,7 +596,7 @@
           <a:lstStyle/>
           <a:p>
             <a:r>
-              <a:t>Um responsável, um telefone e vários passageiros. Menu Vender bilhete, sem abrir o cadastro da viagem. Disponibilidade por segmento e sugestão de veículo para o grupo. Bloqueios de 15 minutos, confirmação, cancelamento e realocação. Importação CSV/XLSX com prévia e validação do lote.</a:t>
+              <a:t>Um responsável, um telefone e vários passageiros. Menu Vender bilhete, sem abrir o cadastro da viagem. Disponibilidade por segmento e sugestão de veículo para o grupo. Bloqueios de 15 minutos, confirmação, cancelamento e realocação. Hotel ou endereço de embarque disponível para motorista e guia. CPF conforme roteiro e exceções; recebimento registrado manualmente como PAGO.</a:t>
             </a:r>
           </a:p>
         </p:txBody>
@@ -661,7 +666,7 @@
           <a:lstStyle/>
           <a:p>
             <a:r>
-              <a:t>O mesmo bilhete em todos os trechos contratados. Página privada com etapas, pontos, horários e veículos. Impressão/PDF, download do QR e compartilhamento do link. Envio do link pelo WhatsApp ao telefone da reserva. Reemissão e revogação para todos os trechos do passageiro.</a:t>
+              <a:t>O mesmo bilhete em todos os trechos contratados. Página privada com etapas, pontos, horários e veículos. Impressão/PDF, download do QR e compartilhamento do link. Envio do link pelo WhatsApp ao telefone da reserva. Reemissão e revogação para todos os trechos do passageiro. A leitura identifica o passageiro; o operador confirma o embarque.</a:t>
             </a:r>
           </a:p>
         </p:txBody>
@@ -731,7 +736,7 @@
           <a:lstStyle/>
           <a:p>
             <a:r>
-              <a:t>WhatsApp e e-mail aproximam sua equipe dos clientes. Confirmação, cancelamento e registro de pagamento por WhatsApp. Resumo da reserva e link do bilhete enviados pelo atendimento. Convites da equipe por WhatsApp, e-mail ou ambos. Histórico de mensagens para acompanhar o atendimento.</a:t>
+              <a:t>WhatsApp e e-mail aproximam sua equipe dos clientes. Confirmação, cancelamento e registro de pagamento por WhatsApp. Conversas, respostas e anexos diretamente no painel da empresa. Menu numerado personalizado com reserva, veículo e embarque. Atendimento humano com pausa das respostas automáticas. O administrador conecta o número da empresa por QR Code no próprio painel; cada empresa mantém sua sessão exclusiva.</a:t>
             </a:r>
           </a:p>
         </p:txBody>
@@ -801,7 +806,7 @@
           <a:lstStyle/>
           <a:p>
             <a:r>
-              <a:t>A viagem na mão de quem executa a operação. Viagens atribuídas e agenda dos próximos sete dias. QR pela câmera, lista e filtros de passageiros. Iniciar viagem, desembarcar todos e registrar chegada. Login biométrico opcional em aparelhos compatíveis.</a:t>
+              <a:t>A viagem na mão de quem executa a operação. Viagens atribuídas e agenda dos próximos sete dias. QR pela câmera, lista e filtros de passageiros. Iniciar viagem, desembarcar todos e registrar chegada. Login biométrico opcional em aparelhos compatíveis. APK por empresa; no perfil operacional, guia não é obrigatório.</a:t>
             </a:r>
           </a:p>
         </p:txBody>
@@ -871,7 +876,7 @@
           <a:lstStyle/>
           <a:p>
             <a:r>
-              <a:t>Lista de passageiros disponível durante o percurso. Prepare a lista do veículo antes de sair. Registre embarques e desembarques mesmo sem conexão. Sincronize os registros ao recuperar a internet. Inicie e finalize o deslocamento com conexão disponível.</a:t>
+              <a:t>Lista de passageiros disponível durante o percurso. Prepare a lista do veículo antes de sair. Registre embarques e desembarques mesmo sem conexão. Sincronize os registros ao recuperar a internet. Inicie e finalize o deslocamento com conexão disponível. Dados locais pendentes não equivalem a confirmação no sistema.</a:t>
             </a:r>
           </a:p>
         </p:txBody>
@@ -941,7 +946,7 @@
           <a:lstStyle/>
           <a:p>
             <a:r>
-              <a:t>Finalização consultável por veículo e trecho. Saída, chegada, responsável e horários registrados. GPS pontual: coordenadas, precisão e horário da captura. Link para consultar o ponto da chegada no Maps. Conclusão geral após todos os veículos e etapas previstos.</a:t>
+              <a:t>Finalização consultável por veículo e trecho. Saída, chegada, responsável e horários registrados. GPS pontual: coordenadas, precisão e horário da captura. Link para consultar o ponto da chegada no Maps. Conclusão geral após todos os veículos e etapas previstos. O registro da chegada fica disponível nos detalhes da viagem.</a:t>
             </a:r>
           </a:p>
         </p:txBody>
@@ -1011,7 +1016,7 @@
           <a:lstStyle/>
           <a:p>
             <a:r>
-              <a:t>Período, situação, veículo e viagem em uma visão integrada. Deslocamentos diários e viagens comerciais iniciadas. Ocupação máxima confirmada por veículo/deslocamento. Valores confirmados, PAGO, ticket médio e produtos vendidos. Baixa ocupação, presença, franquia e exportação CSV.</a:t>
+              <a:t>Período, situação, veículo e viagem em uma visão integrada. Deslocamentos diários e viagens comerciais iniciadas. Ocupação máxima confirmada por veículo/deslocamento. Valores confirmados, PAGO, ticket médio e produtos vendidos. Baixa ocupação, presença, franquia e exportação CSV. Valores nominais e marcação manual; não representam conciliação bancária, fluxo de caixa ou lucro.</a:t>
             </a:r>
           </a:p>
         </p:txBody>
@@ -1081,7 +1086,7 @@
           <a:lstStyle/>
           <a:p>
             <a:r>
-              <a:t>Empresas, planos e assinaturas em um só painel. Basic, Professional, Enterprise e planos adicionais configuráveis. Franquia mensal, mensalidade e valor da unidade extra. Uma viagem simples = uma unidade; pacote = destinos comerciais. Cancelamento estorna o consumo no ciclo original.</a:t>
+              <a:t>Empresas, planos e assinaturas em um só painel. Basic, Professional, Enterprise e planos adicionais configuráveis. Teste inicial, setup separado e mensalidade após cada ciclo de 30 dias, com confirmação automática por link. Uma viagem simples = uma unidade; pacote = destinos comerciais. Cancelamento estorna o consumo no ciclo original. Quatro destinos = quatro unidades, sem acréscimo por retorno, paradas ou quantidade de veículos.</a:t>
             </a:r>
           </a:p>
         </p:txBody>
@@ -1151,7 +1156,7 @@
           <a:lstStyle/>
           <a:p>
             <a:r>
-              <a:t>Um roteiro simples para colocar a equipe em funcionamento. 1 · Empresa, plano, equipe e veículo cadastrados. 2 · Rota criada e viagem agendada com equipe atribuída. 3 · Reserva confirmada, PAGO conferido e bilhete enviado. 4 · Manifesto preparado, embarque realizado e chegada registrada.</a:t>
+              <a:t>Um roteiro simples para colocar a equipe em funcionamento. 1 · Empresa, plano, equipe e veículo cadastrados. 2 · Rota criada e viagem agendada com equipe atribuída. 3 · Reserva confirmada, PAGO conferido e bilhete enviado. 4 · Manifesto preparado, embarque realizado e chegada registrada. O manual traz instruções por perfil, exemplos, checklists e solução de problemas.</a:t>
             </a:r>
           </a:p>
         </p:txBody>
@@ -1221,7 +1226,7 @@
           <a:lstStyle/>
           <a:p>
             <a:r>
-              <a:t>Da preparação do roteiro à análise dos resultados. Reutilize rotas e pacotes para organizar novas saídas. Centralize passageiros, reservas e disponibilidade de lugares. Conecte atendimento, motorista e guia na mesma operação. Acompanhe ocupação, vendas e execução das viagens.</a:t>
+              <a:t>Da preparação do roteiro à análise dos resultados. Reutilize rotas e pacotes para organizar novas saídas. Centralize passageiros, reservas e disponibilidade de lugares. Conecte atendimento, motorista e guia na mesma operação. Acompanhe ocupação, vendas e execução das viagens. Uma visão compartilhada para tomar decisões com mais clareza.</a:t>
             </a:r>
           </a:p>
         </p:txBody>
@@ -1291,7 +1296,7 @@
           <a:lstStyle/>
           <a:p>
             <a:r>
-              <a:t>Planejar → vender → embarcar → concluir → analisar Rotas e pacotes reutilizáveis reduzem o recadastro. Reservas conectam famílias, lugares e deslocamentos. QR e manifestos ligam o atendimento à equipe na estrada. Chegadas e relatórios dão visibilidade ao gestor.</a:t>
+              <a:t>Planejar → vender → embarcar → concluir → analisar Rotas e pacotes reutilizáveis reduzem o recadastro. Reservas conectam famílias, lugares e deslocamentos. QR e manifestos ligam o atendimento à equipe na estrada. Chegadas e relatórios dão visibilidade ao gestor. A operação é validada por empresa, usuário, veículo e trecho.</a:t>
             </a:r>
           </a:p>
         </p:txBody>
@@ -1361,7 +1366,357 @@
           <a:lstStyle/>
           <a:p>
             <a:r>
-              <a:t>Planejamento, atendimento e equipe conectados. Conheça o sistema: rotafy.nexusdataanalytics.tech Manual e downloads: /ajuda Central com HTML, PDF e apresentação editável</a:t>
+              <a:t>Informações úteis no próprio WhatsApp. Qualquer texto abre um menu com saudação personalizada. O passageiro consulta seus bilhetes, reserva, veículo e embarque. A equipe assume a conversa quando necessário. O atendimento automático encerra após um minuto de inatividade. A consulta utiliza o telefone vinculado à reserva.</a:t>
+            </a:r>
+          </a:p>
+        </p:txBody>
+      </p:sp>
+      <p:sp>
+        <p:nvSpPr>
+          <p:cNvPr id="4" name="Slide Number Placeholder 3"/>
+          <p:cNvSpPr>
+            <a:spLocks noGrp="1"/>
+          </p:cNvSpPr>
+          <p:nvPr>
+            <p:ph type="sldNum" idx="5" sz="quarter"/>
+          </p:nvPr>
+        </p:nvSpPr>
+        <p:spPr/>
+      </p:sp>
+    </p:spTree>
+  </p:cSld>
+  <p:clrMapOvr>
+    <a:masterClrMapping/>
+  </p:clrMapOvr>
+</p:notes>
+</file>
+
+<file path=ppt/notesSlides/notesSlide21.xml><?xml version="1.0" encoding="utf-8"?>
+<p:notes xmlns:a="http://schemas.openxmlformats.org/drawingml/2006/main" xmlns:p="http://schemas.openxmlformats.org/presentationml/2006/main" xmlns:r="http://schemas.openxmlformats.org/officeDocument/2006/relationships">
+  <p:cSld>
+    <p:spTree>
+      <p:nvGrpSpPr>
+        <p:cNvPr id="1" name=""/>
+        <p:cNvGrpSpPr/>
+        <p:nvPr/>
+      </p:nvGrpSpPr>
+      <p:grpSpPr>
+        <a:xfrm>
+          <a:off x="0" y="0"/>
+          <a:ext cx="0" cy="0"/>
+          <a:chOff x="0" y="0"/>
+          <a:chExt cx="0" cy="0"/>
+        </a:xfrm>
+      </p:grpSpPr>
+      <p:sp>
+        <p:nvSpPr>
+          <p:cNvPr id="2" name="Slide Image Placeholder 1"/>
+          <p:cNvSpPr>
+            <a:spLocks noGrp="1"/>
+          </p:cNvSpPr>
+          <p:nvPr>
+            <p:ph type="sldImg" idx="2"/>
+          </p:nvPr>
+        </p:nvSpPr>
+        <p:spPr/>
+      </p:sp>
+      <p:sp>
+        <p:nvSpPr>
+          <p:cNvPr id="3" name="Notes Placeholder 2"/>
+          <p:cNvSpPr>
+            <a:spLocks noGrp="1"/>
+          </p:cNvSpPr>
+          <p:nvPr>
+            <p:ph type="body" idx="3" sz="quarter"/>
+          </p:nvPr>
+        </p:nvSpPr>
+        <p:spPr/>
+        <p:txBody>
+          <a:bodyPr/>
+          <a:lstStyle/>
+          <a:p>
+            <a:r>
+              <a:t>Ative o envio automático antes do primeiro embarque. Reservas confirmadas entram na fila até 24 horas antes. Um bilhete por passageiro, válido para todos os trechos contratados. Intervalo mínimo de três minutos entre os envios automáticos. O envio manual permanece disponível para o atendimento. A entrada na fila não garante o horário exato de entrega; acompanhe os envios.</a:t>
+            </a:r>
+          </a:p>
+        </p:txBody>
+      </p:sp>
+      <p:sp>
+        <p:nvSpPr>
+          <p:cNvPr id="4" name="Slide Number Placeholder 3"/>
+          <p:cNvSpPr>
+            <a:spLocks noGrp="1"/>
+          </p:cNvSpPr>
+          <p:nvPr>
+            <p:ph type="sldNum" idx="5" sz="quarter"/>
+          </p:nvPr>
+        </p:nvSpPr>
+        <p:spPr/>
+      </p:sp>
+    </p:spTree>
+  </p:cSld>
+  <p:clrMapOvr>
+    <a:masterClrMapping/>
+  </p:clrMapOvr>
+</p:notes>
+</file>
+
+<file path=ppt/notesSlides/notesSlide22.xml><?xml version="1.0" encoding="utf-8"?>
+<p:notes xmlns:a="http://schemas.openxmlformats.org/drawingml/2006/main" xmlns:p="http://schemas.openxmlformats.org/presentationml/2006/main" xmlns:r="http://schemas.openxmlformats.org/officeDocument/2006/relationships">
+  <p:cSld>
+    <p:spTree>
+      <p:nvGrpSpPr>
+        <p:cNvPr id="1" name=""/>
+        <p:cNvGrpSpPr/>
+        <p:nvPr/>
+      </p:nvGrpSpPr>
+      <p:grpSpPr>
+        <a:xfrm>
+          <a:off x="0" y="0"/>
+          <a:ext cx="0" cy="0"/>
+          <a:chOff x="0" y="0"/>
+          <a:chExt cx="0" cy="0"/>
+        </a:xfrm>
+      </p:grpSpPr>
+      <p:sp>
+        <p:nvSpPr>
+          <p:cNvPr id="2" name="Slide Image Placeholder 1"/>
+          <p:cNvSpPr>
+            <a:spLocks noGrp="1"/>
+          </p:cNvSpPr>
+          <p:nvPr>
+            <p:ph type="sldImg" idx="2"/>
+          </p:nvPr>
+        </p:nvSpPr>
+        <p:spPr/>
+      </p:sp>
+      <p:sp>
+        <p:nvSpPr>
+          <p:cNvPr id="3" name="Notes Placeholder 2"/>
+          <p:cNvSpPr>
+            <a:spLocks noGrp="1"/>
+          </p:cNvSpPr>
+          <p:nvPr>
+            <p:ph type="body" idx="3" sz="quarter"/>
+          </p:nvPr>
+        </p:nvSpPr>
+        <p:spPr/>
+        <p:txBody>
+          <a:bodyPr/>
+          <a:lstStyle/>
+          <a:p>
+            <a:r>
+              <a:t>Rastreamento e avisos configuráveis pela empresa. Posições do celular responsável coletadas a cada cinco minutos. Mapa com última posição e trilha das amostras durante o trecho. Aviso de proximidade para embarques confirmados no mapa. Lembrete de saída na ida e na volta pelo WhatsApp. Localização aproximada; depende de conexão, GPS e permissões.</a:t>
+            </a:r>
+          </a:p>
+        </p:txBody>
+      </p:sp>
+      <p:sp>
+        <p:nvSpPr>
+          <p:cNvPr id="4" name="Slide Number Placeholder 3"/>
+          <p:cNvSpPr>
+            <a:spLocks noGrp="1"/>
+          </p:cNvSpPr>
+          <p:nvPr>
+            <p:ph type="sldNum" idx="5" sz="quarter"/>
+          </p:nvPr>
+        </p:nvSpPr>
+        <p:spPr/>
+      </p:sp>
+    </p:spTree>
+  </p:cSld>
+  <p:clrMapOvr>
+    <a:masterClrMapping/>
+  </p:clrMapOvr>
+</p:notes>
+</file>
+
+<file path=ppt/notesSlides/notesSlide23.xml><?xml version="1.0" encoding="utf-8"?>
+<p:notes xmlns:a="http://schemas.openxmlformats.org/drawingml/2006/main" xmlns:p="http://schemas.openxmlformats.org/presentationml/2006/main" xmlns:r="http://schemas.openxmlformats.org/officeDocument/2006/relationships">
+  <p:cSld>
+    <p:spTree>
+      <p:nvGrpSpPr>
+        <p:cNvPr id="1" name=""/>
+        <p:cNvGrpSpPr/>
+        <p:nvPr/>
+      </p:nvGrpSpPr>
+      <p:grpSpPr>
+        <a:xfrm>
+          <a:off x="0" y="0"/>
+          <a:ext cx="0" cy="0"/>
+          <a:chOff x="0" y="0"/>
+          <a:chExt cx="0" cy="0"/>
+        </a:xfrm>
+      </p:grpSpPr>
+      <p:sp>
+        <p:nvSpPr>
+          <p:cNvPr id="2" name="Slide Image Placeholder 1"/>
+          <p:cNvSpPr>
+            <a:spLocks noGrp="1"/>
+          </p:cNvSpPr>
+          <p:nvPr>
+            <p:ph type="sldImg" idx="2"/>
+          </p:nvPr>
+        </p:nvSpPr>
+        <p:spPr/>
+      </p:sp>
+      <p:sp>
+        <p:nvSpPr>
+          <p:cNvPr id="3" name="Notes Placeholder 2"/>
+          <p:cNvSpPr>
+            <a:spLocks noGrp="1"/>
+          </p:cNvSpPr>
+          <p:nvPr>
+            <p:ph type="body" idx="3" sz="quarter"/>
+          </p:nvPr>
+        </p:nvSpPr>
+        <p:spPr/>
+        <p:txBody>
+          <a:bodyPr/>
+          <a:lstStyle/>
+          <a:p>
+            <a:r>
+              <a:t>Contrato, valores e vencimentos no mesmo ambiente. Leitura e download do contrato antes do aceite por confirmação de e-mail. Plano e valores preservados no documento; mudanças exigem novo aceite. Financeiro com valor previsto, próximo vencimento e situação. Link de pagamento e confirmação automática após aprovação. O setup é separado; a mensalidade é cobrada ao final do ciclo de 30 dias.</a:t>
+            </a:r>
+          </a:p>
+        </p:txBody>
+      </p:sp>
+      <p:sp>
+        <p:nvSpPr>
+          <p:cNvPr id="4" name="Slide Number Placeholder 3"/>
+          <p:cNvSpPr>
+            <a:spLocks noGrp="1"/>
+          </p:cNvSpPr>
+          <p:nvPr>
+            <p:ph type="sldNum" idx="5" sz="quarter"/>
+          </p:nvPr>
+        </p:nvSpPr>
+        <p:spPr/>
+      </p:sp>
+    </p:spTree>
+  </p:cSld>
+  <p:clrMapOvr>
+    <a:masterClrMapping/>
+  </p:clrMapOvr>
+</p:notes>
+</file>
+
+<file path=ppt/notesSlides/notesSlide24.xml><?xml version="1.0" encoding="utf-8"?>
+<p:notes xmlns:a="http://schemas.openxmlformats.org/drawingml/2006/main" xmlns:p="http://schemas.openxmlformats.org/presentationml/2006/main" xmlns:r="http://schemas.openxmlformats.org/officeDocument/2006/relationships">
+  <p:cSld>
+    <p:spTree>
+      <p:nvGrpSpPr>
+        <p:cNvPr id="1" name=""/>
+        <p:cNvGrpSpPr/>
+        <p:nvPr/>
+      </p:nvGrpSpPr>
+      <p:grpSpPr>
+        <a:xfrm>
+          <a:off x="0" y="0"/>
+          <a:ext cx="0" cy="0"/>
+          <a:chOff x="0" y="0"/>
+          <a:chExt cx="0" cy="0"/>
+        </a:xfrm>
+      </p:grpSpPr>
+      <p:sp>
+        <p:nvSpPr>
+          <p:cNvPr id="2" name="Slide Image Placeholder 1"/>
+          <p:cNvSpPr>
+            <a:spLocks noGrp="1"/>
+          </p:cNvSpPr>
+          <p:nvPr>
+            <p:ph type="sldImg" idx="2"/>
+          </p:nvPr>
+        </p:nvSpPr>
+        <p:spPr/>
+      </p:sp>
+      <p:sp>
+        <p:nvSpPr>
+          <p:cNvPr id="3" name="Notes Placeholder 2"/>
+          <p:cNvSpPr>
+            <a:spLocks noGrp="1"/>
+          </p:cNvSpPr>
+          <p:nvPr>
+            <p:ph type="body" idx="3" sz="quarter"/>
+          </p:nvPr>
+        </p:nvSpPr>
+        <p:spPr/>
+        <p:txBody>
+          <a:bodyPr/>
+          <a:lstStyle/>
+          <a:p>
+            <a:r>
+              <a:t>Módulos adequados ao que a empresa precisa. WhatsApp e bilhetes podem complementar um sistema de vendas parceiro. Dados sincronizados apoiam a comunicação e a operação da viagem. Motorista e guia registram embarque e desembarque no Android. Permissões por empresa e credenciais de integração controladas. O conjunto de módulos depende da configuração da empresa.</a:t>
+            </a:r>
+          </a:p>
+        </p:txBody>
+      </p:sp>
+      <p:sp>
+        <p:nvSpPr>
+          <p:cNvPr id="4" name="Slide Number Placeholder 3"/>
+          <p:cNvSpPr>
+            <a:spLocks noGrp="1"/>
+          </p:cNvSpPr>
+          <p:nvPr>
+            <p:ph type="sldNum" idx="5" sz="quarter"/>
+          </p:nvPr>
+        </p:nvSpPr>
+        <p:spPr/>
+      </p:sp>
+    </p:spTree>
+  </p:cSld>
+  <p:clrMapOvr>
+    <a:masterClrMapping/>
+  </p:clrMapOvr>
+</p:notes>
+</file>
+
+<file path=ppt/notesSlides/notesSlide25.xml><?xml version="1.0" encoding="utf-8"?>
+<p:notes xmlns:a="http://schemas.openxmlformats.org/drawingml/2006/main" xmlns:p="http://schemas.openxmlformats.org/presentationml/2006/main" xmlns:r="http://schemas.openxmlformats.org/officeDocument/2006/relationships">
+  <p:cSld>
+    <p:spTree>
+      <p:nvGrpSpPr>
+        <p:cNvPr id="1" name=""/>
+        <p:cNvGrpSpPr/>
+        <p:nvPr/>
+      </p:nvGrpSpPr>
+      <p:grpSpPr>
+        <a:xfrm>
+          <a:off x="0" y="0"/>
+          <a:ext cx="0" cy="0"/>
+          <a:chOff x="0" y="0"/>
+          <a:chExt cx="0" cy="0"/>
+        </a:xfrm>
+      </p:grpSpPr>
+      <p:sp>
+        <p:nvSpPr>
+          <p:cNvPr id="2" name="Slide Image Placeholder 1"/>
+          <p:cNvSpPr>
+            <a:spLocks noGrp="1"/>
+          </p:cNvSpPr>
+          <p:nvPr>
+            <p:ph type="sldImg" idx="2"/>
+          </p:nvPr>
+        </p:nvSpPr>
+        <p:spPr/>
+      </p:sp>
+      <p:sp>
+        <p:nvSpPr>
+          <p:cNvPr id="3" name="Notes Placeholder 2"/>
+          <p:cNvSpPr>
+            <a:spLocks noGrp="1"/>
+          </p:cNvSpPr>
+          <p:nvPr>
+            <p:ph type="body" idx="3" sz="quarter"/>
+          </p:nvPr>
+        </p:nvSpPr>
+        <p:spPr/>
+        <p:txBody>
+          <a:bodyPr/>
+          <a:lstStyle/>
+          <a:p>
+            <a:r>
+              <a:t>Planejamento, atendimento e equipe conectados. Conheça o sistema: rotafy.nexusdataanalytics.tech Manual e downloads: /ajuda Central com HTML, PDF e apresentação editável Nexus Data Analytics · Edição 2026.10</a:t>
             </a:r>
           </a:p>
         </p:txBody>
@@ -1431,7 +1786,7 @@
           <a:lstStyle/>
           <a:p>
             <a:r>
-              <a:t>Uma plataforma compartilhada, com operação segregada. Cadastros, viagens, reservas e históricos pertencem à empresa. Acesso definido pelo identificador da empresa e pelo perfil do usuário. Um profissional de várias empresas possui um cadastro em cada uma. Nexus administra empresas, planos e configurações da plataforma.</a:t>
+              <a:t>Uma plataforma compartilhada, com operação segregada. Cadastros, viagens, reservas e históricos pertencem à empresa. Acesso definido pelo identificador da empresa e pelo perfil do usuário. Um profissional de várias empresas possui um cadastro em cada uma. Nexus administra empresas, planos e configurações da plataforma. Guias e motoristas acessam somente os deslocamentos atribuídos.</a:t>
             </a:r>
           </a:p>
         </p:txBody>
@@ -1501,7 +1856,7 @@
           <a:lstStyle/>
           <a:p>
             <a:r>
-              <a:t>O cadastro inicial orienta a experiência da empresa. Turismo: viagens simples, transfers e pacotes com vários destinos. Regular: viagens simples, Rotas, frota, reservas e embarque. Os menus turísticos ficam ocultos no perfil Regular. Perfil operacional e plano comercial são escolhas independentes.</a:t>
+              <a:t>O cadastro inicial orienta a experiência da empresa. Turismo: viagens simples, transfers e pacotes com vários destinos. Regular: viagens simples, Rotas, frota, reservas e embarque. Os menus turísticos ficam ocultos no perfil Regular. Perfil operacional e plano comercial são escolhas independentes. Uma experiência organizada para cada tipo de operação.</a:t>
             </a:r>
           </a:p>
         </p:txBody>
@@ -1571,7 +1926,7 @@
           <a:lstStyle/>
           <a:p>
             <a:r>
-              <a:t>Administrador, atendente, motorista e guia. Cadastro, ativação e suspensão de colaboradores. Convite por e-mail, WhatsApp ou pelos dois canais. Link de 24 horas para definir a própria senha. Recuperação de acesso e registro de atividades.</a:t>
+              <a:t>Administrador, atendente, motorista e guia. Cadastro, ativação e suspensão de colaboradores. Convite por e-mail, WhatsApp ou pelos dois canais. Link de 24 horas para definir a própria senha. Recuperação de acesso e registro de atividades. Motorista e guia compartilham os recursos operacionais; o guia é opcional.</a:t>
             </a:r>
           </a:p>
         </p:txBody>
@@ -1641,7 +1996,7 @@
           <a:lstStyle/>
           <a:p>
             <a:r>
-              <a:t>Capacidade e equipe conectadas ao planejamento. Cadastro de veículo, placa e quantidade de lugares. Vários veículos na mesma viagem ou deslocamento. Motorista e guias definidos em cada alocação. Conflitos de horários e capacidade verificados ao salvar.</a:t>
+              <a:t>Capacidade e equipe conectadas ao planejamento. Cadastro de veículo, placa e quantidade de lugares. Vários veículos na mesma viagem ou deslocamento. Mais de um motorista e guia podem acompanhar o mesmo veículo. Conflitos de horários e capacidade verificados ao salvar. A distribuição considera quantidade de lugares; não há escolha de poltrona numerada.</a:t>
             </a:r>
           </a:p>
         </p:txBody>
@@ -1711,7 +2066,7 @@
           <a:lstStyle/>
           <a:p>
             <a:r>
-              <a:t>Cidades, endereços, paradas e duração estimada. UF e cidade para origem e destino. Paradas ordenadas de embarque, desembarque ou ambos. Somente ida ou ida e volta, com sugestão de retorno invertido. Navegação abre o Google Maps externo.</a:t>
+              <a:t>Cidades, endereços, paradas e duração estimada. UF e cidade para origem e destino. Paradas ordenadas de embarque, desembarque ou ambos. Somente ida ou ida e volta, com sugestão de retorno invertido. Navegação abre o Google Maps externo. Duração manual. Atualizar uma Rota não altera automaticamente viagens já criadas.</a:t>
             </a:r>
           </a:p>
         </p:txBody>
@@ -1781,7 +2136,7 @@
           <a:lstStyle/>
           <a:p>
             <a:r>
-              <a:t>Dois formatos para simplificar o roteiro. Passeios: cada dia retorna à mesma cidade-base. Sequência: várias cidades, com permanência e dias livres. Modelo com dias relativos; datas reais são definidas na saída. Venda do pacote completo, com retorno incluído.</a:t>
+              <a:t>Dois formatos para simplificar o roteiro. Passeios: cada dia retorna à mesma cidade-base. Sequência: várias cidades, com permanência e dias livres. Modelo com dias relativos; datas reais são definidas na saída. Venda do pacote completo, com retorno incluído. Exemplos: Maceió ↔ Maragogi / Gunga; ou Maceió → Fortaleza → Natal → Maceió.</a:t>
             </a:r>
           </a:p>
         </p:txBody>
@@ -1851,7 +2206,7 @@
           <a:lstStyle/>
           <a:p>
             <a:r>
-              <a:t>Rota ou pacote + data + horários + veículos + equipe. Viagem simples com trecho único ou ida e volta. Saída de pacote com todas as etapas e chegadas previstas. Troca de veículo e equipe entre deslocamentos do roteiro. Filtros de situação, edição protegida, duplicação e cancelamento.</a:t>
+              <a:t>Rota ou pacote + data + horários + veículos + equipe. Viagem simples com trecho único ou ida e volta. Saída de pacote com todas as etapas e chegadas previstas. Troca de veículo e equipe entre deslocamentos do roteiro. Filtros de situação, edição protegida, duplicação e cancelamento. A saída preserva sua versão de percurso, preço e capacidade.</a:t>
             </a:r>
           </a:p>
         </p:txBody>
@@ -4981,7 +5336,7 @@
               </a:defRPr>
             </a:pPr>
             <a:r>
-              <a:t>01 / 20</a:t>
+              <a:t>01 / 25</a:t>
             </a:r>
           </a:p>
         </p:txBody>
@@ -5224,7 +5579,7 @@
               </a:defRPr>
             </a:pPr>
             <a:r>
-              <a:t>Apresentação do sistema · Edição 2026.10 · 09/10/2026</a:t>
+              <a:t>Apresentação do sistema · Edição 2026.10 · 22/10/2026</a:t>
             </a:r>
           </a:p>
         </p:txBody>
@@ -5371,7 +5726,7 @@
               </a:defRPr>
             </a:pPr>
             <a:r>
-              <a:t>10 / 20</a:t>
+              <a:t>10 / 25</a:t>
             </a:r>
           </a:p>
         </p:txBody>
@@ -5575,7 +5930,7 @@
               </a:defRPr>
             </a:pPr>
             <a:r>
-              <a:t>• Importação CSV/XLSX com prévia e validação do lote.</a:t>
+              <a:t>• Hotel ou endereço de embarque disponível para motorista e guia.</a:t>
             </a:r>
           </a:p>
         </p:txBody>
@@ -5761,7 +6116,7 @@
               </a:defRPr>
             </a:pPr>
             <a:r>
-              <a:t>11 / 20</a:t>
+              <a:t>11 / 25</a:t>
             </a:r>
           </a:p>
         </p:txBody>
@@ -6151,7 +6506,7 @@
               </a:defRPr>
             </a:pPr>
             <a:r>
-              <a:t>12 / 20</a:t>
+              <a:t>12 / 25</a:t>
             </a:r>
           </a:p>
         </p:txBody>
@@ -6323,7 +6678,7 @@
               </a:defRPr>
             </a:pPr>
             <a:r>
-              <a:t>• Resumo da reserva e link do bilhete enviados pelo atendimento.</a:t>
+              <a:t>• Conversas, respostas e anexos diretamente no painel da empresa.</a:t>
             </a:r>
           </a:p>
           <a:p>
@@ -6339,7 +6694,7 @@
               </a:defRPr>
             </a:pPr>
             <a:r>
-              <a:t>• Convites da equipe por WhatsApp, e-mail ou ambos.</a:t>
+              <a:t>• Menu numerado personalizado com reserva, veículo e embarque.</a:t>
             </a:r>
           </a:p>
           <a:p>
@@ -6355,7 +6710,7 @@
               </a:defRPr>
             </a:pPr>
             <a:r>
-              <a:t>• Histórico de mensagens para acompanhar o atendimento.</a:t>
+              <a:t>• Atendimento humano com pausa das respostas automáticas.</a:t>
             </a:r>
           </a:p>
         </p:txBody>
@@ -6541,7 +6896,7 @@
               </a:defRPr>
             </a:pPr>
             <a:r>
-              <a:t>13 / 20</a:t>
+              <a:t>13 / 25</a:t>
             </a:r>
           </a:p>
         </p:txBody>
@@ -6931,7 +7286,7 @@
               </a:defRPr>
             </a:pPr>
             <a:r>
-              <a:t>14 / 20</a:t>
+              <a:t>14 / 25</a:t>
             </a:r>
           </a:p>
         </p:txBody>
@@ -7321,7 +7676,7 @@
               </a:defRPr>
             </a:pPr>
             <a:r>
-              <a:t>15 / 20</a:t>
+              <a:t>15 / 25</a:t>
             </a:r>
           </a:p>
         </p:txBody>
@@ -7711,7 +8066,7 @@
               </a:defRPr>
             </a:pPr>
             <a:r>
-              <a:t>16 / 20</a:t>
+              <a:t>16 / 25</a:t>
             </a:r>
           </a:p>
         </p:txBody>
@@ -8125,7 +8480,7 @@
               </a:defRPr>
             </a:pPr>
             <a:r>
-              <a:t>17 / 20</a:t>
+              <a:t>17 / 25</a:t>
             </a:r>
           </a:p>
         </p:txBody>
@@ -8515,7 +8870,7 @@
               </a:defRPr>
             </a:pPr>
             <a:r>
-              <a:t>18 / 20</a:t>
+              <a:t>18 / 25</a:t>
             </a:r>
           </a:p>
         </p:txBody>
@@ -8905,7 +9260,7 @@
               </a:defRPr>
             </a:pPr>
             <a:r>
-              <a:t>19 / 20</a:t>
+              <a:t>19 / 25</a:t>
             </a:r>
           </a:p>
         </p:txBody>
@@ -9295,7 +9650,7 @@
               </a:defRPr>
             </a:pPr>
             <a:r>
-              <a:t>02 / 20</a:t>
+              <a:t>02 / 25</a:t>
             </a:r>
           </a:p>
         </p:txBody>
@@ -9552,6 +9907,2036 @@
 </file>
 
 <file path=ppt/slides/slide20.xml><?xml version="1.0" encoding="utf-8"?>
+<p:sld xmlns:a="http://schemas.openxmlformats.org/drawingml/2006/main" xmlns:p="http://schemas.openxmlformats.org/presentationml/2006/main" xmlns:r="http://schemas.openxmlformats.org/officeDocument/2006/relationships">
+  <p:cSld>
+    <p:bg>
+      <p:bgPr>
+        <a:solidFill>
+          <a:srgbClr val="F4F7FA"/>
+        </a:solidFill>
+        <a:effectLst/>
+      </p:bgPr>
+    </p:bg>
+    <p:spTree>
+      <p:nvGrpSpPr>
+        <p:cNvPr id="1" name=""/>
+        <p:cNvGrpSpPr/>
+        <p:nvPr/>
+      </p:nvGrpSpPr>
+      <p:grpSpPr/>
+      <p:sp>
+        <p:nvSpPr>
+          <p:cNvPr id="2" name="Rectangle 1"/>
+          <p:cNvSpPr/>
+          <p:nvPr/>
+        </p:nvSpPr>
+        <p:spPr>
+          <a:xfrm>
+            <a:off x="0" y="0"/>
+            <a:ext cx="109728" cy="6858000"/>
+          </a:xfrm>
+          <a:prstGeom prst="rect">
+            <a:avLst/>
+          </a:prstGeom>
+          <a:solidFill>
+            <a:srgbClr val="0C7A76"/>
+          </a:solidFill>
+          <a:ln>
+            <a:noFill/>
+          </a:ln>
+        </p:spPr>
+        <p:style>
+          <a:lnRef idx="1">
+            <a:schemeClr val="accent1"/>
+          </a:lnRef>
+          <a:fillRef idx="3">
+            <a:schemeClr val="accent1"/>
+          </a:fillRef>
+          <a:effectRef idx="2">
+            <a:schemeClr val="accent1"/>
+          </a:effectRef>
+          <a:fontRef idx="minor">
+            <a:schemeClr val="lt1"/>
+          </a:fontRef>
+        </p:style>
+        <p:txBody>
+          <a:bodyPr rtlCol="0" anchor="ctr"/>
+          <a:lstStyle/>
+          <a:p>
+            <a:pPr algn="ctr"/>
+          </a:p>
+        </p:txBody>
+      </p:sp>
+      <p:sp>
+        <p:nvSpPr>
+          <p:cNvPr id="3" name="TextBox 2"/>
+          <p:cNvSpPr txBox="1"/>
+          <p:nvPr/>
+        </p:nvSpPr>
+        <p:spPr>
+          <a:xfrm>
+            <a:off x="594360" y="320040"/>
+            <a:ext cx="2743200" cy="365760"/>
+          </a:xfrm>
+          <a:prstGeom prst="rect">
+            <a:avLst/>
+          </a:prstGeom>
+          <a:noFill/>
+        </p:spPr>
+        <p:txBody>
+          <a:bodyPr wrap="square" lIns="18288" rIns="18288" tIns="18288" bIns="18288">
+            <a:spAutoFit/>
+          </a:bodyPr>
+          <a:lstStyle/>
+          <a:p>
+            <a:pPr>
+              <a:spcAft>
+                <a:spcPts val="1100"/>
+              </a:spcAft>
+              <a:defRPr sz="1800" b="1">
+                <a:solidFill>
+                  <a:srgbClr val="0B253F"/>
+                </a:solidFill>
+                <a:latin typeface="Arial"/>
+              </a:defRPr>
+            </a:pPr>
+            <a:r>
+              <a:t>rotafy.  /  NEXUS</a:t>
+            </a:r>
+          </a:p>
+        </p:txBody>
+      </p:sp>
+      <p:sp>
+        <p:nvSpPr>
+          <p:cNvPr id="4" name="TextBox 3"/>
+          <p:cNvSpPr txBox="1"/>
+          <p:nvPr/>
+        </p:nvSpPr>
+        <p:spPr>
+          <a:xfrm>
+            <a:off x="10424160" y="365760"/>
+            <a:ext cx="1188720" cy="320040"/>
+          </a:xfrm>
+          <a:prstGeom prst="rect">
+            <a:avLst/>
+          </a:prstGeom>
+          <a:noFill/>
+        </p:spPr>
+        <p:txBody>
+          <a:bodyPr wrap="square" lIns="18288" rIns="18288" tIns="18288" bIns="18288">
+            <a:spAutoFit/>
+          </a:bodyPr>
+          <a:lstStyle/>
+          <a:p>
+            <a:pPr>
+              <a:spcAft>
+                <a:spcPts val="1100"/>
+              </a:spcAft>
+              <a:defRPr sz="1200" b="0">
+                <a:solidFill>
+                  <a:srgbClr val="0B253F"/>
+                </a:solidFill>
+                <a:latin typeface="Arial"/>
+              </a:defRPr>
+            </a:pPr>
+            <a:r>
+              <a:t>20 / 25</a:t>
+            </a:r>
+          </a:p>
+        </p:txBody>
+      </p:sp>
+      <p:sp>
+        <p:nvSpPr>
+          <p:cNvPr id="5" name="TextBox 4"/>
+          <p:cNvSpPr txBox="1"/>
+          <p:nvPr/>
+        </p:nvSpPr>
+        <p:spPr>
+          <a:xfrm>
+            <a:off x="594360" y="914400"/>
+            <a:ext cx="10789920" cy="365760"/>
+          </a:xfrm>
+          <a:prstGeom prst="rect">
+            <a:avLst/>
+          </a:prstGeom>
+          <a:noFill/>
+        </p:spPr>
+        <p:txBody>
+          <a:bodyPr wrap="square" lIns="18288" rIns="18288" tIns="18288" bIns="18288">
+            <a:spAutoFit/>
+          </a:bodyPr>
+          <a:lstStyle/>
+          <a:p>
+            <a:pPr>
+              <a:spcAft>
+                <a:spcPts val="1100"/>
+              </a:spcAft>
+              <a:defRPr sz="1100" b="1">
+                <a:solidFill>
+                  <a:srgbClr val="0C7A76"/>
+                </a:solidFill>
+                <a:latin typeface="Arial"/>
+              </a:defRPr>
+            </a:pPr>
+            <a:r>
+              <a:t>ATENDIMENTO MAIS ÁGIL</a:t>
+            </a:r>
+          </a:p>
+        </p:txBody>
+      </p:sp>
+      <p:sp>
+        <p:nvSpPr>
+          <p:cNvPr id="6" name="TextBox 5"/>
+          <p:cNvSpPr txBox="1"/>
+          <p:nvPr/>
+        </p:nvSpPr>
+        <p:spPr>
+          <a:xfrm>
+            <a:off x="594360" y="1389888"/>
+            <a:ext cx="10789920" cy="1170432"/>
+          </a:xfrm>
+          <a:prstGeom prst="rect">
+            <a:avLst/>
+          </a:prstGeom>
+          <a:noFill/>
+        </p:spPr>
+        <p:txBody>
+          <a:bodyPr wrap="square" lIns="18288" rIns="18288" tIns="18288" bIns="18288">
+            <a:spAutoFit/>
+          </a:bodyPr>
+          <a:lstStyle/>
+          <a:p>
+            <a:pPr>
+              <a:spcAft>
+                <a:spcPts val="1100"/>
+              </a:spcAft>
+              <a:defRPr sz="3600" b="1">
+                <a:solidFill>
+                  <a:srgbClr val="0B253F"/>
+                </a:solidFill>
+                <a:latin typeface="Arial"/>
+              </a:defRPr>
+            </a:pPr>
+            <a:r>
+              <a:t>O passageiro pergunta.</a:t>
+            </a:r>
+          </a:p>
+          <a:p>
+            <a:pPr>
+              <a:spcAft>
+                <a:spcPts val="1100"/>
+              </a:spcAft>
+              <a:defRPr sz="3600" b="1">
+                <a:solidFill>
+                  <a:srgbClr val="0B253F"/>
+                </a:solidFill>
+                <a:latin typeface="Arial"/>
+              </a:defRPr>
+            </a:pPr>
+            <a:r>
+              <a:t>A empresa acompanha.</a:t>
+            </a:r>
+          </a:p>
+        </p:txBody>
+      </p:sp>
+      <p:sp>
+        <p:nvSpPr>
+          <p:cNvPr id="7" name="TextBox 6"/>
+          <p:cNvSpPr txBox="1"/>
+          <p:nvPr/>
+        </p:nvSpPr>
+        <p:spPr>
+          <a:xfrm>
+            <a:off x="594360" y="2651760"/>
+            <a:ext cx="10789920" cy="658368"/>
+          </a:xfrm>
+          <a:prstGeom prst="rect">
+            <a:avLst/>
+          </a:prstGeom>
+          <a:noFill/>
+        </p:spPr>
+        <p:txBody>
+          <a:bodyPr wrap="square" lIns="18288" rIns="18288" tIns="18288" bIns="18288">
+            <a:spAutoFit/>
+          </a:bodyPr>
+          <a:lstStyle/>
+          <a:p>
+            <a:pPr>
+              <a:spcAft>
+                <a:spcPts val="1100"/>
+              </a:spcAft>
+              <a:defRPr sz="2000" b="0">
+                <a:solidFill>
+                  <a:srgbClr val="577084"/>
+                </a:solidFill>
+                <a:latin typeface="Arial"/>
+              </a:defRPr>
+            </a:pPr>
+            <a:r>
+              <a:t>Informações úteis no próprio WhatsApp.</a:t>
+            </a:r>
+          </a:p>
+        </p:txBody>
+      </p:sp>
+      <p:sp>
+        <p:nvSpPr>
+          <p:cNvPr id="8" name="TextBox 7"/>
+          <p:cNvSpPr txBox="1"/>
+          <p:nvPr/>
+        </p:nvSpPr>
+        <p:spPr>
+          <a:xfrm>
+            <a:off x="640080" y="3520440"/>
+            <a:ext cx="10789920" cy="2194560"/>
+          </a:xfrm>
+          <a:prstGeom prst="rect">
+            <a:avLst/>
+          </a:prstGeom>
+          <a:noFill/>
+        </p:spPr>
+        <p:txBody>
+          <a:bodyPr wrap="square" lIns="18288" rIns="18288" tIns="18288" bIns="18288">
+            <a:spAutoFit/>
+          </a:bodyPr>
+          <a:lstStyle/>
+          <a:p>
+            <a:pPr>
+              <a:spcAft>
+                <a:spcPts val="1100"/>
+              </a:spcAft>
+              <a:defRPr sz="1800" b="0">
+                <a:solidFill>
+                  <a:srgbClr val="0B253F"/>
+                </a:solidFill>
+                <a:latin typeface="Arial"/>
+              </a:defRPr>
+            </a:pPr>
+            <a:r>
+              <a:t>• Qualquer texto abre um menu com saudação personalizada.</a:t>
+            </a:r>
+          </a:p>
+          <a:p>
+            <a:pPr>
+              <a:spcAft>
+                <a:spcPts val="1100"/>
+              </a:spcAft>
+              <a:defRPr sz="1800" b="0">
+                <a:solidFill>
+                  <a:srgbClr val="0B253F"/>
+                </a:solidFill>
+                <a:latin typeface="Arial"/>
+              </a:defRPr>
+            </a:pPr>
+            <a:r>
+              <a:t>• O passageiro consulta seus bilhetes, reserva, veículo e embarque.</a:t>
+            </a:r>
+          </a:p>
+          <a:p>
+            <a:pPr>
+              <a:spcAft>
+                <a:spcPts val="1100"/>
+              </a:spcAft>
+              <a:defRPr sz="1800" b="0">
+                <a:solidFill>
+                  <a:srgbClr val="0B253F"/>
+                </a:solidFill>
+                <a:latin typeface="Arial"/>
+              </a:defRPr>
+            </a:pPr>
+            <a:r>
+              <a:t>• A equipe assume a conversa quando necessário.</a:t>
+            </a:r>
+          </a:p>
+          <a:p>
+            <a:pPr>
+              <a:spcAft>
+                <a:spcPts val="1100"/>
+              </a:spcAft>
+              <a:defRPr sz="1800" b="0">
+                <a:solidFill>
+                  <a:srgbClr val="0B253F"/>
+                </a:solidFill>
+                <a:latin typeface="Arial"/>
+              </a:defRPr>
+            </a:pPr>
+            <a:r>
+              <a:t>• O atendimento automático encerra após um minuto de inatividade.</a:t>
+            </a:r>
+          </a:p>
+        </p:txBody>
+      </p:sp>
+      <p:sp>
+        <p:nvSpPr>
+          <p:cNvPr id="9" name="TextBox 8"/>
+          <p:cNvSpPr txBox="1"/>
+          <p:nvPr/>
+        </p:nvSpPr>
+        <p:spPr>
+          <a:xfrm>
+            <a:off x="594360" y="6217920"/>
+            <a:ext cx="10972800" cy="411480"/>
+          </a:xfrm>
+          <a:prstGeom prst="rect">
+            <a:avLst/>
+          </a:prstGeom>
+          <a:noFill/>
+        </p:spPr>
+        <p:txBody>
+          <a:bodyPr wrap="square" lIns="18288" rIns="18288" tIns="18288" bIns="18288">
+            <a:spAutoFit/>
+          </a:bodyPr>
+          <a:lstStyle/>
+          <a:p>
+            <a:pPr>
+              <a:spcAft>
+                <a:spcPts val="1100"/>
+              </a:spcAft>
+              <a:defRPr sz="1100" b="0">
+                <a:solidFill>
+                  <a:srgbClr val="577084"/>
+                </a:solidFill>
+                <a:latin typeface="Arial"/>
+              </a:defRPr>
+            </a:pPr>
+            <a:r>
+              <a:t>A consulta utiliza o telefone vinculado à reserva.</a:t>
+            </a:r>
+          </a:p>
+        </p:txBody>
+      </p:sp>
+    </p:spTree>
+  </p:cSld>
+  <p:clrMapOvr>
+    <a:masterClrMapping/>
+  </p:clrMapOvr>
+</p:sld>
+</file>
+
+<file path=ppt/slides/slide21.xml><?xml version="1.0" encoding="utf-8"?>
+<p:sld xmlns:a="http://schemas.openxmlformats.org/drawingml/2006/main" xmlns:p="http://schemas.openxmlformats.org/presentationml/2006/main" xmlns:r="http://schemas.openxmlformats.org/officeDocument/2006/relationships">
+  <p:cSld>
+    <p:bg>
+      <p:bgPr>
+        <a:solidFill>
+          <a:srgbClr val="F4F7FA"/>
+        </a:solidFill>
+        <a:effectLst/>
+      </p:bgPr>
+    </p:bg>
+    <p:spTree>
+      <p:nvGrpSpPr>
+        <p:cNvPr id="1" name=""/>
+        <p:cNvGrpSpPr/>
+        <p:nvPr/>
+      </p:nvGrpSpPr>
+      <p:grpSpPr/>
+      <p:sp>
+        <p:nvSpPr>
+          <p:cNvPr id="2" name="Rectangle 1"/>
+          <p:cNvSpPr/>
+          <p:nvPr/>
+        </p:nvSpPr>
+        <p:spPr>
+          <a:xfrm>
+            <a:off x="0" y="0"/>
+            <a:ext cx="109728" cy="6858000"/>
+          </a:xfrm>
+          <a:prstGeom prst="rect">
+            <a:avLst/>
+          </a:prstGeom>
+          <a:solidFill>
+            <a:srgbClr val="0C7A76"/>
+          </a:solidFill>
+          <a:ln>
+            <a:noFill/>
+          </a:ln>
+        </p:spPr>
+        <p:style>
+          <a:lnRef idx="1">
+            <a:schemeClr val="accent1"/>
+          </a:lnRef>
+          <a:fillRef idx="3">
+            <a:schemeClr val="accent1"/>
+          </a:fillRef>
+          <a:effectRef idx="2">
+            <a:schemeClr val="accent1"/>
+          </a:effectRef>
+          <a:fontRef idx="minor">
+            <a:schemeClr val="lt1"/>
+          </a:fontRef>
+        </p:style>
+        <p:txBody>
+          <a:bodyPr rtlCol="0" anchor="ctr"/>
+          <a:lstStyle/>
+          <a:p>
+            <a:pPr algn="ctr"/>
+          </a:p>
+        </p:txBody>
+      </p:sp>
+      <p:sp>
+        <p:nvSpPr>
+          <p:cNvPr id="3" name="TextBox 2"/>
+          <p:cNvSpPr txBox="1"/>
+          <p:nvPr/>
+        </p:nvSpPr>
+        <p:spPr>
+          <a:xfrm>
+            <a:off x="594360" y="320040"/>
+            <a:ext cx="2743200" cy="365760"/>
+          </a:xfrm>
+          <a:prstGeom prst="rect">
+            <a:avLst/>
+          </a:prstGeom>
+          <a:noFill/>
+        </p:spPr>
+        <p:txBody>
+          <a:bodyPr wrap="square" lIns="18288" rIns="18288" tIns="18288" bIns="18288">
+            <a:spAutoFit/>
+          </a:bodyPr>
+          <a:lstStyle/>
+          <a:p>
+            <a:pPr>
+              <a:spcAft>
+                <a:spcPts val="1100"/>
+              </a:spcAft>
+              <a:defRPr sz="1800" b="1">
+                <a:solidFill>
+                  <a:srgbClr val="0B253F"/>
+                </a:solidFill>
+                <a:latin typeface="Arial"/>
+              </a:defRPr>
+            </a:pPr>
+            <a:r>
+              <a:t>rotafy.  /  NEXUS</a:t>
+            </a:r>
+          </a:p>
+        </p:txBody>
+      </p:sp>
+      <p:sp>
+        <p:nvSpPr>
+          <p:cNvPr id="4" name="TextBox 3"/>
+          <p:cNvSpPr txBox="1"/>
+          <p:nvPr/>
+        </p:nvSpPr>
+        <p:spPr>
+          <a:xfrm>
+            <a:off x="10424160" y="365760"/>
+            <a:ext cx="1188720" cy="320040"/>
+          </a:xfrm>
+          <a:prstGeom prst="rect">
+            <a:avLst/>
+          </a:prstGeom>
+          <a:noFill/>
+        </p:spPr>
+        <p:txBody>
+          <a:bodyPr wrap="square" lIns="18288" rIns="18288" tIns="18288" bIns="18288">
+            <a:spAutoFit/>
+          </a:bodyPr>
+          <a:lstStyle/>
+          <a:p>
+            <a:pPr>
+              <a:spcAft>
+                <a:spcPts val="1100"/>
+              </a:spcAft>
+              <a:defRPr sz="1200" b="0">
+                <a:solidFill>
+                  <a:srgbClr val="0B253F"/>
+                </a:solidFill>
+                <a:latin typeface="Arial"/>
+              </a:defRPr>
+            </a:pPr>
+            <a:r>
+              <a:t>21 / 25</a:t>
+            </a:r>
+          </a:p>
+        </p:txBody>
+      </p:sp>
+      <p:sp>
+        <p:nvSpPr>
+          <p:cNvPr id="5" name="TextBox 4"/>
+          <p:cNvSpPr txBox="1"/>
+          <p:nvPr/>
+        </p:nvSpPr>
+        <p:spPr>
+          <a:xfrm>
+            <a:off x="594360" y="914400"/>
+            <a:ext cx="10789920" cy="365760"/>
+          </a:xfrm>
+          <a:prstGeom prst="rect">
+            <a:avLst/>
+          </a:prstGeom>
+          <a:noFill/>
+        </p:spPr>
+        <p:txBody>
+          <a:bodyPr wrap="square" lIns="18288" rIns="18288" tIns="18288" bIns="18288">
+            <a:spAutoFit/>
+          </a:bodyPr>
+          <a:lstStyle/>
+          <a:p>
+            <a:pPr>
+              <a:spcAft>
+                <a:spcPts val="1100"/>
+              </a:spcAft>
+              <a:defRPr sz="1100" b="1">
+                <a:solidFill>
+                  <a:srgbClr val="0C7A76"/>
+                </a:solidFill>
+                <a:latin typeface="Arial"/>
+              </a:defRPr>
+            </a:pPr>
+            <a:r>
+              <a:t>BILHETE NA HORA DE VIAJAR</a:t>
+            </a:r>
+          </a:p>
+        </p:txBody>
+      </p:sp>
+      <p:sp>
+        <p:nvSpPr>
+          <p:cNvPr id="6" name="TextBox 5"/>
+          <p:cNvSpPr txBox="1"/>
+          <p:nvPr/>
+        </p:nvSpPr>
+        <p:spPr>
+          <a:xfrm>
+            <a:off x="594360" y="1389888"/>
+            <a:ext cx="10789920" cy="1170432"/>
+          </a:xfrm>
+          <a:prstGeom prst="rect">
+            <a:avLst/>
+          </a:prstGeom>
+          <a:noFill/>
+        </p:spPr>
+        <p:txBody>
+          <a:bodyPr wrap="square" lIns="18288" rIns="18288" tIns="18288" bIns="18288">
+            <a:spAutoFit/>
+          </a:bodyPr>
+          <a:lstStyle/>
+          <a:p>
+            <a:pPr>
+              <a:spcAft>
+                <a:spcPts val="1100"/>
+              </a:spcAft>
+              <a:defRPr sz="3600" b="1">
+                <a:solidFill>
+                  <a:srgbClr val="0B253F"/>
+                </a:solidFill>
+                <a:latin typeface="Arial"/>
+              </a:defRPr>
+            </a:pPr>
+            <a:r>
+              <a:t>Envio antecipado,</a:t>
+            </a:r>
+          </a:p>
+          <a:p>
+            <a:pPr>
+              <a:spcAft>
+                <a:spcPts val="1100"/>
+              </a:spcAft>
+              <a:defRPr sz="3600" b="1">
+                <a:solidFill>
+                  <a:srgbClr val="0B253F"/>
+                </a:solidFill>
+                <a:latin typeface="Arial"/>
+              </a:defRPr>
+            </a:pPr>
+            <a:r>
+              <a:t>com acompanhamento.</a:t>
+            </a:r>
+          </a:p>
+        </p:txBody>
+      </p:sp>
+      <p:sp>
+        <p:nvSpPr>
+          <p:cNvPr id="7" name="TextBox 6"/>
+          <p:cNvSpPr txBox="1"/>
+          <p:nvPr/>
+        </p:nvSpPr>
+        <p:spPr>
+          <a:xfrm>
+            <a:off x="594360" y="2651760"/>
+            <a:ext cx="10789920" cy="658368"/>
+          </a:xfrm>
+          <a:prstGeom prst="rect">
+            <a:avLst/>
+          </a:prstGeom>
+          <a:noFill/>
+        </p:spPr>
+        <p:txBody>
+          <a:bodyPr wrap="square" lIns="18288" rIns="18288" tIns="18288" bIns="18288">
+            <a:spAutoFit/>
+          </a:bodyPr>
+          <a:lstStyle/>
+          <a:p>
+            <a:pPr>
+              <a:spcAft>
+                <a:spcPts val="1100"/>
+              </a:spcAft>
+              <a:defRPr sz="2000" b="0">
+                <a:solidFill>
+                  <a:srgbClr val="577084"/>
+                </a:solidFill>
+                <a:latin typeface="Arial"/>
+              </a:defRPr>
+            </a:pPr>
+            <a:r>
+              <a:t>Ative o envio automático antes do primeiro embarque.</a:t>
+            </a:r>
+          </a:p>
+        </p:txBody>
+      </p:sp>
+      <p:sp>
+        <p:nvSpPr>
+          <p:cNvPr id="8" name="TextBox 7"/>
+          <p:cNvSpPr txBox="1"/>
+          <p:nvPr/>
+        </p:nvSpPr>
+        <p:spPr>
+          <a:xfrm>
+            <a:off x="640080" y="3520440"/>
+            <a:ext cx="10789920" cy="2194560"/>
+          </a:xfrm>
+          <a:prstGeom prst="rect">
+            <a:avLst/>
+          </a:prstGeom>
+          <a:noFill/>
+        </p:spPr>
+        <p:txBody>
+          <a:bodyPr wrap="square" lIns="18288" rIns="18288" tIns="18288" bIns="18288">
+            <a:spAutoFit/>
+          </a:bodyPr>
+          <a:lstStyle/>
+          <a:p>
+            <a:pPr>
+              <a:spcAft>
+                <a:spcPts val="1100"/>
+              </a:spcAft>
+              <a:defRPr sz="1800" b="0">
+                <a:solidFill>
+                  <a:srgbClr val="0B253F"/>
+                </a:solidFill>
+                <a:latin typeface="Arial"/>
+              </a:defRPr>
+            </a:pPr>
+            <a:r>
+              <a:t>• Reservas confirmadas entram na fila até 24 horas antes.</a:t>
+            </a:r>
+          </a:p>
+          <a:p>
+            <a:pPr>
+              <a:spcAft>
+                <a:spcPts val="1100"/>
+              </a:spcAft>
+              <a:defRPr sz="1800" b="0">
+                <a:solidFill>
+                  <a:srgbClr val="0B253F"/>
+                </a:solidFill>
+                <a:latin typeface="Arial"/>
+              </a:defRPr>
+            </a:pPr>
+            <a:r>
+              <a:t>• Um bilhete por passageiro, válido para todos os trechos contratados.</a:t>
+            </a:r>
+          </a:p>
+          <a:p>
+            <a:pPr>
+              <a:spcAft>
+                <a:spcPts val="1100"/>
+              </a:spcAft>
+              <a:defRPr sz="1800" b="0">
+                <a:solidFill>
+                  <a:srgbClr val="0B253F"/>
+                </a:solidFill>
+                <a:latin typeface="Arial"/>
+              </a:defRPr>
+            </a:pPr>
+            <a:r>
+              <a:t>• Intervalo mínimo de três minutos entre os envios automáticos.</a:t>
+            </a:r>
+          </a:p>
+          <a:p>
+            <a:pPr>
+              <a:spcAft>
+                <a:spcPts val="1100"/>
+              </a:spcAft>
+              <a:defRPr sz="1800" b="0">
+                <a:solidFill>
+                  <a:srgbClr val="0B253F"/>
+                </a:solidFill>
+                <a:latin typeface="Arial"/>
+              </a:defRPr>
+            </a:pPr>
+            <a:r>
+              <a:t>• O envio manual permanece disponível para o atendimento.</a:t>
+            </a:r>
+          </a:p>
+        </p:txBody>
+      </p:sp>
+      <p:sp>
+        <p:nvSpPr>
+          <p:cNvPr id="9" name="TextBox 8"/>
+          <p:cNvSpPr txBox="1"/>
+          <p:nvPr/>
+        </p:nvSpPr>
+        <p:spPr>
+          <a:xfrm>
+            <a:off x="594360" y="6217920"/>
+            <a:ext cx="10972800" cy="411480"/>
+          </a:xfrm>
+          <a:prstGeom prst="rect">
+            <a:avLst/>
+          </a:prstGeom>
+          <a:noFill/>
+        </p:spPr>
+        <p:txBody>
+          <a:bodyPr wrap="square" lIns="18288" rIns="18288" tIns="18288" bIns="18288">
+            <a:spAutoFit/>
+          </a:bodyPr>
+          <a:lstStyle/>
+          <a:p>
+            <a:pPr>
+              <a:spcAft>
+                <a:spcPts val="1100"/>
+              </a:spcAft>
+              <a:defRPr sz="1100" b="0">
+                <a:solidFill>
+                  <a:srgbClr val="577084"/>
+                </a:solidFill>
+                <a:latin typeface="Arial"/>
+              </a:defRPr>
+            </a:pPr>
+            <a:r>
+              <a:t>A entrada na fila não garante o horário exato de entrega; acompanhe os envios.</a:t>
+            </a:r>
+          </a:p>
+        </p:txBody>
+      </p:sp>
+    </p:spTree>
+  </p:cSld>
+  <p:clrMapOvr>
+    <a:masterClrMapping/>
+  </p:clrMapOvr>
+</p:sld>
+</file>
+
+<file path=ppt/slides/slide22.xml><?xml version="1.0" encoding="utf-8"?>
+<p:sld xmlns:a="http://schemas.openxmlformats.org/drawingml/2006/main" xmlns:p="http://schemas.openxmlformats.org/presentationml/2006/main" xmlns:r="http://schemas.openxmlformats.org/officeDocument/2006/relationships">
+  <p:cSld>
+    <p:bg>
+      <p:bgPr>
+        <a:solidFill>
+          <a:srgbClr val="F4F7FA"/>
+        </a:solidFill>
+        <a:effectLst/>
+      </p:bgPr>
+    </p:bg>
+    <p:spTree>
+      <p:nvGrpSpPr>
+        <p:cNvPr id="1" name=""/>
+        <p:cNvGrpSpPr/>
+        <p:nvPr/>
+      </p:nvGrpSpPr>
+      <p:grpSpPr/>
+      <p:sp>
+        <p:nvSpPr>
+          <p:cNvPr id="2" name="Rectangle 1"/>
+          <p:cNvSpPr/>
+          <p:nvPr/>
+        </p:nvSpPr>
+        <p:spPr>
+          <a:xfrm>
+            <a:off x="0" y="0"/>
+            <a:ext cx="109728" cy="6858000"/>
+          </a:xfrm>
+          <a:prstGeom prst="rect">
+            <a:avLst/>
+          </a:prstGeom>
+          <a:solidFill>
+            <a:srgbClr val="0C7A76"/>
+          </a:solidFill>
+          <a:ln>
+            <a:noFill/>
+          </a:ln>
+        </p:spPr>
+        <p:style>
+          <a:lnRef idx="1">
+            <a:schemeClr val="accent1"/>
+          </a:lnRef>
+          <a:fillRef idx="3">
+            <a:schemeClr val="accent1"/>
+          </a:fillRef>
+          <a:effectRef idx="2">
+            <a:schemeClr val="accent1"/>
+          </a:effectRef>
+          <a:fontRef idx="minor">
+            <a:schemeClr val="lt1"/>
+          </a:fontRef>
+        </p:style>
+        <p:txBody>
+          <a:bodyPr rtlCol="0" anchor="ctr"/>
+          <a:lstStyle/>
+          <a:p>
+            <a:pPr algn="ctr"/>
+          </a:p>
+        </p:txBody>
+      </p:sp>
+      <p:sp>
+        <p:nvSpPr>
+          <p:cNvPr id="3" name="TextBox 2"/>
+          <p:cNvSpPr txBox="1"/>
+          <p:nvPr/>
+        </p:nvSpPr>
+        <p:spPr>
+          <a:xfrm>
+            <a:off x="594360" y="320040"/>
+            <a:ext cx="2743200" cy="365760"/>
+          </a:xfrm>
+          <a:prstGeom prst="rect">
+            <a:avLst/>
+          </a:prstGeom>
+          <a:noFill/>
+        </p:spPr>
+        <p:txBody>
+          <a:bodyPr wrap="square" lIns="18288" rIns="18288" tIns="18288" bIns="18288">
+            <a:spAutoFit/>
+          </a:bodyPr>
+          <a:lstStyle/>
+          <a:p>
+            <a:pPr>
+              <a:spcAft>
+                <a:spcPts val="1100"/>
+              </a:spcAft>
+              <a:defRPr sz="1800" b="1">
+                <a:solidFill>
+                  <a:srgbClr val="0B253F"/>
+                </a:solidFill>
+                <a:latin typeface="Arial"/>
+              </a:defRPr>
+            </a:pPr>
+            <a:r>
+              <a:t>rotafy.  /  NEXUS</a:t>
+            </a:r>
+          </a:p>
+        </p:txBody>
+      </p:sp>
+      <p:sp>
+        <p:nvSpPr>
+          <p:cNvPr id="4" name="TextBox 3"/>
+          <p:cNvSpPr txBox="1"/>
+          <p:nvPr/>
+        </p:nvSpPr>
+        <p:spPr>
+          <a:xfrm>
+            <a:off x="10424160" y="365760"/>
+            <a:ext cx="1188720" cy="320040"/>
+          </a:xfrm>
+          <a:prstGeom prst="rect">
+            <a:avLst/>
+          </a:prstGeom>
+          <a:noFill/>
+        </p:spPr>
+        <p:txBody>
+          <a:bodyPr wrap="square" lIns="18288" rIns="18288" tIns="18288" bIns="18288">
+            <a:spAutoFit/>
+          </a:bodyPr>
+          <a:lstStyle/>
+          <a:p>
+            <a:pPr>
+              <a:spcAft>
+                <a:spcPts val="1100"/>
+              </a:spcAft>
+              <a:defRPr sz="1200" b="0">
+                <a:solidFill>
+                  <a:srgbClr val="0B253F"/>
+                </a:solidFill>
+                <a:latin typeface="Arial"/>
+              </a:defRPr>
+            </a:pPr>
+            <a:r>
+              <a:t>22 / 25</a:t>
+            </a:r>
+          </a:p>
+        </p:txBody>
+      </p:sp>
+      <p:sp>
+        <p:nvSpPr>
+          <p:cNvPr id="5" name="TextBox 4"/>
+          <p:cNvSpPr txBox="1"/>
+          <p:nvPr/>
+        </p:nvSpPr>
+        <p:spPr>
+          <a:xfrm>
+            <a:off x="594360" y="914400"/>
+            <a:ext cx="10789920" cy="365760"/>
+          </a:xfrm>
+          <a:prstGeom prst="rect">
+            <a:avLst/>
+          </a:prstGeom>
+          <a:noFill/>
+        </p:spPr>
+        <p:txBody>
+          <a:bodyPr wrap="square" lIns="18288" rIns="18288" tIns="18288" bIns="18288">
+            <a:spAutoFit/>
+          </a:bodyPr>
+          <a:lstStyle/>
+          <a:p>
+            <a:pPr>
+              <a:spcAft>
+                <a:spcPts val="1100"/>
+              </a:spcAft>
+              <a:defRPr sz="1100" b="1">
+                <a:solidFill>
+                  <a:srgbClr val="0C7A76"/>
+                </a:solidFill>
+                <a:latin typeface="Arial"/>
+              </a:defRPr>
+            </a:pPr>
+            <a:r>
+              <a:t>VISIBILIDADE DA OPERAÇÃO</a:t>
+            </a:r>
+          </a:p>
+        </p:txBody>
+      </p:sp>
+      <p:sp>
+        <p:nvSpPr>
+          <p:cNvPr id="6" name="TextBox 5"/>
+          <p:cNvSpPr txBox="1"/>
+          <p:nvPr/>
+        </p:nvSpPr>
+        <p:spPr>
+          <a:xfrm>
+            <a:off x="594360" y="1389888"/>
+            <a:ext cx="10789920" cy="1170432"/>
+          </a:xfrm>
+          <a:prstGeom prst="rect">
+            <a:avLst/>
+          </a:prstGeom>
+          <a:noFill/>
+        </p:spPr>
+        <p:txBody>
+          <a:bodyPr wrap="square" lIns="18288" rIns="18288" tIns="18288" bIns="18288">
+            <a:spAutoFit/>
+          </a:bodyPr>
+          <a:lstStyle/>
+          <a:p>
+            <a:pPr>
+              <a:spcAft>
+                <a:spcPts val="1100"/>
+              </a:spcAft>
+              <a:defRPr sz="3600" b="1">
+                <a:solidFill>
+                  <a:srgbClr val="0B253F"/>
+                </a:solidFill>
+                <a:latin typeface="Arial"/>
+              </a:defRPr>
+            </a:pPr>
+            <a:r>
+              <a:t>Acompanhe o veículo.</a:t>
+            </a:r>
+          </a:p>
+          <a:p>
+            <a:pPr>
+              <a:spcAft>
+                <a:spcPts val="1100"/>
+              </a:spcAft>
+              <a:defRPr sz="3600" b="1">
+                <a:solidFill>
+                  <a:srgbClr val="0B253F"/>
+                </a:solidFill>
+                <a:latin typeface="Arial"/>
+              </a:defRPr>
+            </a:pPr>
+            <a:r>
+              <a:t>Oriente o passageiro.</a:t>
+            </a:r>
+          </a:p>
+        </p:txBody>
+      </p:sp>
+      <p:sp>
+        <p:nvSpPr>
+          <p:cNvPr id="7" name="TextBox 6"/>
+          <p:cNvSpPr txBox="1"/>
+          <p:nvPr/>
+        </p:nvSpPr>
+        <p:spPr>
+          <a:xfrm>
+            <a:off x="594360" y="2651760"/>
+            <a:ext cx="10789920" cy="658368"/>
+          </a:xfrm>
+          <a:prstGeom prst="rect">
+            <a:avLst/>
+          </a:prstGeom>
+          <a:noFill/>
+        </p:spPr>
+        <p:txBody>
+          <a:bodyPr wrap="square" lIns="18288" rIns="18288" tIns="18288" bIns="18288">
+            <a:spAutoFit/>
+          </a:bodyPr>
+          <a:lstStyle/>
+          <a:p>
+            <a:pPr>
+              <a:spcAft>
+                <a:spcPts val="1100"/>
+              </a:spcAft>
+              <a:defRPr sz="2000" b="0">
+                <a:solidFill>
+                  <a:srgbClr val="577084"/>
+                </a:solidFill>
+                <a:latin typeface="Arial"/>
+              </a:defRPr>
+            </a:pPr>
+            <a:r>
+              <a:t>Rastreamento e avisos configuráveis pela empresa.</a:t>
+            </a:r>
+          </a:p>
+        </p:txBody>
+      </p:sp>
+      <p:sp>
+        <p:nvSpPr>
+          <p:cNvPr id="8" name="TextBox 7"/>
+          <p:cNvSpPr txBox="1"/>
+          <p:nvPr/>
+        </p:nvSpPr>
+        <p:spPr>
+          <a:xfrm>
+            <a:off x="640080" y="3520440"/>
+            <a:ext cx="10789920" cy="2194560"/>
+          </a:xfrm>
+          <a:prstGeom prst="rect">
+            <a:avLst/>
+          </a:prstGeom>
+          <a:noFill/>
+        </p:spPr>
+        <p:txBody>
+          <a:bodyPr wrap="square" lIns="18288" rIns="18288" tIns="18288" bIns="18288">
+            <a:spAutoFit/>
+          </a:bodyPr>
+          <a:lstStyle/>
+          <a:p>
+            <a:pPr>
+              <a:spcAft>
+                <a:spcPts val="1100"/>
+              </a:spcAft>
+              <a:defRPr sz="1800" b="0">
+                <a:solidFill>
+                  <a:srgbClr val="0B253F"/>
+                </a:solidFill>
+                <a:latin typeface="Arial"/>
+              </a:defRPr>
+            </a:pPr>
+            <a:r>
+              <a:t>• Posições do celular responsável coletadas a cada cinco minutos.</a:t>
+            </a:r>
+          </a:p>
+          <a:p>
+            <a:pPr>
+              <a:spcAft>
+                <a:spcPts val="1100"/>
+              </a:spcAft>
+              <a:defRPr sz="1800" b="0">
+                <a:solidFill>
+                  <a:srgbClr val="0B253F"/>
+                </a:solidFill>
+                <a:latin typeface="Arial"/>
+              </a:defRPr>
+            </a:pPr>
+            <a:r>
+              <a:t>• Mapa com última posição e trilha das amostras durante o trecho.</a:t>
+            </a:r>
+          </a:p>
+          <a:p>
+            <a:pPr>
+              <a:spcAft>
+                <a:spcPts val="1100"/>
+              </a:spcAft>
+              <a:defRPr sz="1800" b="0">
+                <a:solidFill>
+                  <a:srgbClr val="0B253F"/>
+                </a:solidFill>
+                <a:latin typeface="Arial"/>
+              </a:defRPr>
+            </a:pPr>
+            <a:r>
+              <a:t>• Aviso de proximidade para embarques confirmados no mapa.</a:t>
+            </a:r>
+          </a:p>
+          <a:p>
+            <a:pPr>
+              <a:spcAft>
+                <a:spcPts val="1100"/>
+              </a:spcAft>
+              <a:defRPr sz="1800" b="0">
+                <a:solidFill>
+                  <a:srgbClr val="0B253F"/>
+                </a:solidFill>
+                <a:latin typeface="Arial"/>
+              </a:defRPr>
+            </a:pPr>
+            <a:r>
+              <a:t>• Lembrete de saída na ida e na volta pelo WhatsApp.</a:t>
+            </a:r>
+          </a:p>
+        </p:txBody>
+      </p:sp>
+      <p:sp>
+        <p:nvSpPr>
+          <p:cNvPr id="9" name="TextBox 8"/>
+          <p:cNvSpPr txBox="1"/>
+          <p:nvPr/>
+        </p:nvSpPr>
+        <p:spPr>
+          <a:xfrm>
+            <a:off x="594360" y="6217920"/>
+            <a:ext cx="10972800" cy="411480"/>
+          </a:xfrm>
+          <a:prstGeom prst="rect">
+            <a:avLst/>
+          </a:prstGeom>
+          <a:noFill/>
+        </p:spPr>
+        <p:txBody>
+          <a:bodyPr wrap="square" lIns="18288" rIns="18288" tIns="18288" bIns="18288">
+            <a:spAutoFit/>
+          </a:bodyPr>
+          <a:lstStyle/>
+          <a:p>
+            <a:pPr>
+              <a:spcAft>
+                <a:spcPts val="1100"/>
+              </a:spcAft>
+              <a:defRPr sz="1100" b="0">
+                <a:solidFill>
+                  <a:srgbClr val="577084"/>
+                </a:solidFill>
+                <a:latin typeface="Arial"/>
+              </a:defRPr>
+            </a:pPr>
+            <a:r>
+              <a:t>Localização aproximada; depende de conexão, GPS e permissões.</a:t>
+            </a:r>
+          </a:p>
+        </p:txBody>
+      </p:sp>
+    </p:spTree>
+  </p:cSld>
+  <p:clrMapOvr>
+    <a:masterClrMapping/>
+  </p:clrMapOvr>
+</p:sld>
+</file>
+
+<file path=ppt/slides/slide23.xml><?xml version="1.0" encoding="utf-8"?>
+<p:sld xmlns:a="http://schemas.openxmlformats.org/drawingml/2006/main" xmlns:p="http://schemas.openxmlformats.org/presentationml/2006/main" xmlns:r="http://schemas.openxmlformats.org/officeDocument/2006/relationships">
+  <p:cSld>
+    <p:bg>
+      <p:bgPr>
+        <a:solidFill>
+          <a:srgbClr val="F4F7FA"/>
+        </a:solidFill>
+        <a:effectLst/>
+      </p:bgPr>
+    </p:bg>
+    <p:spTree>
+      <p:nvGrpSpPr>
+        <p:cNvPr id="1" name=""/>
+        <p:cNvGrpSpPr/>
+        <p:nvPr/>
+      </p:nvGrpSpPr>
+      <p:grpSpPr/>
+      <p:sp>
+        <p:nvSpPr>
+          <p:cNvPr id="2" name="Rectangle 1"/>
+          <p:cNvSpPr/>
+          <p:nvPr/>
+        </p:nvSpPr>
+        <p:spPr>
+          <a:xfrm>
+            <a:off x="0" y="0"/>
+            <a:ext cx="109728" cy="6858000"/>
+          </a:xfrm>
+          <a:prstGeom prst="rect">
+            <a:avLst/>
+          </a:prstGeom>
+          <a:solidFill>
+            <a:srgbClr val="0C7A76"/>
+          </a:solidFill>
+          <a:ln>
+            <a:noFill/>
+          </a:ln>
+        </p:spPr>
+        <p:style>
+          <a:lnRef idx="1">
+            <a:schemeClr val="accent1"/>
+          </a:lnRef>
+          <a:fillRef idx="3">
+            <a:schemeClr val="accent1"/>
+          </a:fillRef>
+          <a:effectRef idx="2">
+            <a:schemeClr val="accent1"/>
+          </a:effectRef>
+          <a:fontRef idx="minor">
+            <a:schemeClr val="lt1"/>
+          </a:fontRef>
+        </p:style>
+        <p:txBody>
+          <a:bodyPr rtlCol="0" anchor="ctr"/>
+          <a:lstStyle/>
+          <a:p>
+            <a:pPr algn="ctr"/>
+          </a:p>
+        </p:txBody>
+      </p:sp>
+      <p:sp>
+        <p:nvSpPr>
+          <p:cNvPr id="3" name="TextBox 2"/>
+          <p:cNvSpPr txBox="1"/>
+          <p:nvPr/>
+        </p:nvSpPr>
+        <p:spPr>
+          <a:xfrm>
+            <a:off x="594360" y="320040"/>
+            <a:ext cx="2743200" cy="365760"/>
+          </a:xfrm>
+          <a:prstGeom prst="rect">
+            <a:avLst/>
+          </a:prstGeom>
+          <a:noFill/>
+        </p:spPr>
+        <p:txBody>
+          <a:bodyPr wrap="square" lIns="18288" rIns="18288" tIns="18288" bIns="18288">
+            <a:spAutoFit/>
+          </a:bodyPr>
+          <a:lstStyle/>
+          <a:p>
+            <a:pPr>
+              <a:spcAft>
+                <a:spcPts val="1100"/>
+              </a:spcAft>
+              <a:defRPr sz="1800" b="1">
+                <a:solidFill>
+                  <a:srgbClr val="0B253F"/>
+                </a:solidFill>
+                <a:latin typeface="Arial"/>
+              </a:defRPr>
+            </a:pPr>
+            <a:r>
+              <a:t>rotafy.  /  NEXUS</a:t>
+            </a:r>
+          </a:p>
+        </p:txBody>
+      </p:sp>
+      <p:sp>
+        <p:nvSpPr>
+          <p:cNvPr id="4" name="TextBox 3"/>
+          <p:cNvSpPr txBox="1"/>
+          <p:nvPr/>
+        </p:nvSpPr>
+        <p:spPr>
+          <a:xfrm>
+            <a:off x="10424160" y="365760"/>
+            <a:ext cx="1188720" cy="320040"/>
+          </a:xfrm>
+          <a:prstGeom prst="rect">
+            <a:avLst/>
+          </a:prstGeom>
+          <a:noFill/>
+        </p:spPr>
+        <p:txBody>
+          <a:bodyPr wrap="square" lIns="18288" rIns="18288" tIns="18288" bIns="18288">
+            <a:spAutoFit/>
+          </a:bodyPr>
+          <a:lstStyle/>
+          <a:p>
+            <a:pPr>
+              <a:spcAft>
+                <a:spcPts val="1100"/>
+              </a:spcAft>
+              <a:defRPr sz="1200" b="0">
+                <a:solidFill>
+                  <a:srgbClr val="0B253F"/>
+                </a:solidFill>
+                <a:latin typeface="Arial"/>
+              </a:defRPr>
+            </a:pPr>
+            <a:r>
+              <a:t>23 / 25</a:t>
+            </a:r>
+          </a:p>
+        </p:txBody>
+      </p:sp>
+      <p:sp>
+        <p:nvSpPr>
+          <p:cNvPr id="5" name="TextBox 4"/>
+          <p:cNvSpPr txBox="1"/>
+          <p:nvPr/>
+        </p:nvSpPr>
+        <p:spPr>
+          <a:xfrm>
+            <a:off x="594360" y="914400"/>
+            <a:ext cx="10789920" cy="365760"/>
+          </a:xfrm>
+          <a:prstGeom prst="rect">
+            <a:avLst/>
+          </a:prstGeom>
+          <a:noFill/>
+        </p:spPr>
+        <p:txBody>
+          <a:bodyPr wrap="square" lIns="18288" rIns="18288" tIns="18288" bIns="18288">
+            <a:spAutoFit/>
+          </a:bodyPr>
+          <a:lstStyle/>
+          <a:p>
+            <a:pPr>
+              <a:spcAft>
+                <a:spcPts val="1100"/>
+              </a:spcAft>
+              <a:defRPr sz="1100" b="1">
+                <a:solidFill>
+                  <a:srgbClr val="0C7A76"/>
+                </a:solidFill>
+                <a:latin typeface="Arial"/>
+              </a:defRPr>
+            </a:pPr>
+            <a:r>
+              <a:t>GESTÃO DA ASSINATURA</a:t>
+            </a:r>
+          </a:p>
+        </p:txBody>
+      </p:sp>
+      <p:sp>
+        <p:nvSpPr>
+          <p:cNvPr id="6" name="TextBox 5"/>
+          <p:cNvSpPr txBox="1"/>
+          <p:nvPr/>
+        </p:nvSpPr>
+        <p:spPr>
+          <a:xfrm>
+            <a:off x="594360" y="1389888"/>
+            <a:ext cx="10789920" cy="1170432"/>
+          </a:xfrm>
+          <a:prstGeom prst="rect">
+            <a:avLst/>
+          </a:prstGeom>
+          <a:noFill/>
+        </p:spPr>
+        <p:txBody>
+          <a:bodyPr wrap="square" lIns="18288" rIns="18288" tIns="18288" bIns="18288">
+            <a:spAutoFit/>
+          </a:bodyPr>
+          <a:lstStyle/>
+          <a:p>
+            <a:pPr>
+              <a:spcAft>
+                <a:spcPts val="1100"/>
+              </a:spcAft>
+              <a:defRPr sz="3600" b="1">
+                <a:solidFill>
+                  <a:srgbClr val="0B253F"/>
+                </a:solidFill>
+                <a:latin typeface="Arial"/>
+              </a:defRPr>
+            </a:pPr>
+            <a:r>
+              <a:t>Condições claras,</a:t>
+            </a:r>
+          </a:p>
+          <a:p>
+            <a:pPr>
+              <a:spcAft>
+                <a:spcPts val="1100"/>
+              </a:spcAft>
+              <a:defRPr sz="3600" b="1">
+                <a:solidFill>
+                  <a:srgbClr val="0B253F"/>
+                </a:solidFill>
+                <a:latin typeface="Arial"/>
+              </a:defRPr>
+            </a:pPr>
+            <a:r>
+              <a:t>pagamento acompanhado.</a:t>
+            </a:r>
+          </a:p>
+        </p:txBody>
+      </p:sp>
+      <p:sp>
+        <p:nvSpPr>
+          <p:cNvPr id="7" name="TextBox 6"/>
+          <p:cNvSpPr txBox="1"/>
+          <p:nvPr/>
+        </p:nvSpPr>
+        <p:spPr>
+          <a:xfrm>
+            <a:off x="594360" y="2651760"/>
+            <a:ext cx="10789920" cy="658368"/>
+          </a:xfrm>
+          <a:prstGeom prst="rect">
+            <a:avLst/>
+          </a:prstGeom>
+          <a:noFill/>
+        </p:spPr>
+        <p:txBody>
+          <a:bodyPr wrap="square" lIns="18288" rIns="18288" tIns="18288" bIns="18288">
+            <a:spAutoFit/>
+          </a:bodyPr>
+          <a:lstStyle/>
+          <a:p>
+            <a:pPr>
+              <a:spcAft>
+                <a:spcPts val="1100"/>
+              </a:spcAft>
+              <a:defRPr sz="2000" b="0">
+                <a:solidFill>
+                  <a:srgbClr val="577084"/>
+                </a:solidFill>
+                <a:latin typeface="Arial"/>
+              </a:defRPr>
+            </a:pPr>
+            <a:r>
+              <a:t>Contrato, valores e vencimentos no mesmo ambiente.</a:t>
+            </a:r>
+          </a:p>
+        </p:txBody>
+      </p:sp>
+      <p:sp>
+        <p:nvSpPr>
+          <p:cNvPr id="8" name="TextBox 7"/>
+          <p:cNvSpPr txBox="1"/>
+          <p:nvPr/>
+        </p:nvSpPr>
+        <p:spPr>
+          <a:xfrm>
+            <a:off x="640080" y="3520440"/>
+            <a:ext cx="10789920" cy="2194560"/>
+          </a:xfrm>
+          <a:prstGeom prst="rect">
+            <a:avLst/>
+          </a:prstGeom>
+          <a:noFill/>
+        </p:spPr>
+        <p:txBody>
+          <a:bodyPr wrap="square" lIns="18288" rIns="18288" tIns="18288" bIns="18288">
+            <a:spAutoFit/>
+          </a:bodyPr>
+          <a:lstStyle/>
+          <a:p>
+            <a:pPr>
+              <a:spcAft>
+                <a:spcPts val="1100"/>
+              </a:spcAft>
+              <a:defRPr sz="1800" b="0">
+                <a:solidFill>
+                  <a:srgbClr val="0B253F"/>
+                </a:solidFill>
+                <a:latin typeface="Arial"/>
+              </a:defRPr>
+            </a:pPr>
+            <a:r>
+              <a:t>• Leitura e download do contrato antes do aceite por confirmação de e-mail.</a:t>
+            </a:r>
+          </a:p>
+          <a:p>
+            <a:pPr>
+              <a:spcAft>
+                <a:spcPts val="1100"/>
+              </a:spcAft>
+              <a:defRPr sz="1800" b="0">
+                <a:solidFill>
+                  <a:srgbClr val="0B253F"/>
+                </a:solidFill>
+                <a:latin typeface="Arial"/>
+              </a:defRPr>
+            </a:pPr>
+            <a:r>
+              <a:t>• Plano e valores preservados no documento; mudanças exigem novo aceite.</a:t>
+            </a:r>
+          </a:p>
+          <a:p>
+            <a:pPr>
+              <a:spcAft>
+                <a:spcPts val="1100"/>
+              </a:spcAft>
+              <a:defRPr sz="1800" b="0">
+                <a:solidFill>
+                  <a:srgbClr val="0B253F"/>
+                </a:solidFill>
+                <a:latin typeface="Arial"/>
+              </a:defRPr>
+            </a:pPr>
+            <a:r>
+              <a:t>• Financeiro com valor previsto, próximo vencimento e situação.</a:t>
+            </a:r>
+          </a:p>
+          <a:p>
+            <a:pPr>
+              <a:spcAft>
+                <a:spcPts val="1100"/>
+              </a:spcAft>
+              <a:defRPr sz="1800" b="0">
+                <a:solidFill>
+                  <a:srgbClr val="0B253F"/>
+                </a:solidFill>
+                <a:latin typeface="Arial"/>
+              </a:defRPr>
+            </a:pPr>
+            <a:r>
+              <a:t>• Link de pagamento e confirmação automática após aprovação.</a:t>
+            </a:r>
+          </a:p>
+        </p:txBody>
+      </p:sp>
+      <p:sp>
+        <p:nvSpPr>
+          <p:cNvPr id="9" name="TextBox 8"/>
+          <p:cNvSpPr txBox="1"/>
+          <p:nvPr/>
+        </p:nvSpPr>
+        <p:spPr>
+          <a:xfrm>
+            <a:off x="594360" y="6217920"/>
+            <a:ext cx="10972800" cy="411480"/>
+          </a:xfrm>
+          <a:prstGeom prst="rect">
+            <a:avLst/>
+          </a:prstGeom>
+          <a:noFill/>
+        </p:spPr>
+        <p:txBody>
+          <a:bodyPr wrap="square" lIns="18288" rIns="18288" tIns="18288" bIns="18288">
+            <a:spAutoFit/>
+          </a:bodyPr>
+          <a:lstStyle/>
+          <a:p>
+            <a:pPr>
+              <a:spcAft>
+                <a:spcPts val="1100"/>
+              </a:spcAft>
+              <a:defRPr sz="1100" b="0">
+                <a:solidFill>
+                  <a:srgbClr val="577084"/>
+                </a:solidFill>
+                <a:latin typeface="Arial"/>
+              </a:defRPr>
+            </a:pPr>
+            <a:r>
+              <a:t>O setup é separado; a mensalidade é cobrada ao final do ciclo de 30 dias.</a:t>
+            </a:r>
+          </a:p>
+        </p:txBody>
+      </p:sp>
+    </p:spTree>
+  </p:cSld>
+  <p:clrMapOvr>
+    <a:masterClrMapping/>
+  </p:clrMapOvr>
+</p:sld>
+</file>
+
+<file path=ppt/slides/slide24.xml><?xml version="1.0" encoding="utf-8"?>
+<p:sld xmlns:a="http://schemas.openxmlformats.org/drawingml/2006/main" xmlns:p="http://schemas.openxmlformats.org/presentationml/2006/main" xmlns:r="http://schemas.openxmlformats.org/officeDocument/2006/relationships">
+  <p:cSld>
+    <p:bg>
+      <p:bgPr>
+        <a:solidFill>
+          <a:srgbClr val="F4F7FA"/>
+        </a:solidFill>
+        <a:effectLst/>
+      </p:bgPr>
+    </p:bg>
+    <p:spTree>
+      <p:nvGrpSpPr>
+        <p:cNvPr id="1" name=""/>
+        <p:cNvGrpSpPr/>
+        <p:nvPr/>
+      </p:nvGrpSpPr>
+      <p:grpSpPr/>
+      <p:sp>
+        <p:nvSpPr>
+          <p:cNvPr id="2" name="Rectangle 1"/>
+          <p:cNvSpPr/>
+          <p:nvPr/>
+        </p:nvSpPr>
+        <p:spPr>
+          <a:xfrm>
+            <a:off x="0" y="0"/>
+            <a:ext cx="109728" cy="6858000"/>
+          </a:xfrm>
+          <a:prstGeom prst="rect">
+            <a:avLst/>
+          </a:prstGeom>
+          <a:solidFill>
+            <a:srgbClr val="0C7A76"/>
+          </a:solidFill>
+          <a:ln>
+            <a:noFill/>
+          </a:ln>
+        </p:spPr>
+        <p:style>
+          <a:lnRef idx="1">
+            <a:schemeClr val="accent1"/>
+          </a:lnRef>
+          <a:fillRef idx="3">
+            <a:schemeClr val="accent1"/>
+          </a:fillRef>
+          <a:effectRef idx="2">
+            <a:schemeClr val="accent1"/>
+          </a:effectRef>
+          <a:fontRef idx="minor">
+            <a:schemeClr val="lt1"/>
+          </a:fontRef>
+        </p:style>
+        <p:txBody>
+          <a:bodyPr rtlCol="0" anchor="ctr"/>
+          <a:lstStyle/>
+          <a:p>
+            <a:pPr algn="ctr"/>
+          </a:p>
+        </p:txBody>
+      </p:sp>
+      <p:sp>
+        <p:nvSpPr>
+          <p:cNvPr id="3" name="TextBox 2"/>
+          <p:cNvSpPr txBox="1"/>
+          <p:nvPr/>
+        </p:nvSpPr>
+        <p:spPr>
+          <a:xfrm>
+            <a:off x="594360" y="320040"/>
+            <a:ext cx="2743200" cy="365760"/>
+          </a:xfrm>
+          <a:prstGeom prst="rect">
+            <a:avLst/>
+          </a:prstGeom>
+          <a:noFill/>
+        </p:spPr>
+        <p:txBody>
+          <a:bodyPr wrap="square" lIns="18288" rIns="18288" tIns="18288" bIns="18288">
+            <a:spAutoFit/>
+          </a:bodyPr>
+          <a:lstStyle/>
+          <a:p>
+            <a:pPr>
+              <a:spcAft>
+                <a:spcPts val="1100"/>
+              </a:spcAft>
+              <a:defRPr sz="1800" b="1">
+                <a:solidFill>
+                  <a:srgbClr val="0B253F"/>
+                </a:solidFill>
+                <a:latin typeface="Arial"/>
+              </a:defRPr>
+            </a:pPr>
+            <a:r>
+              <a:t>rotafy.  /  NEXUS</a:t>
+            </a:r>
+          </a:p>
+        </p:txBody>
+      </p:sp>
+      <p:sp>
+        <p:nvSpPr>
+          <p:cNvPr id="4" name="TextBox 3"/>
+          <p:cNvSpPr txBox="1"/>
+          <p:nvPr/>
+        </p:nvSpPr>
+        <p:spPr>
+          <a:xfrm>
+            <a:off x="10424160" y="365760"/>
+            <a:ext cx="1188720" cy="320040"/>
+          </a:xfrm>
+          <a:prstGeom prst="rect">
+            <a:avLst/>
+          </a:prstGeom>
+          <a:noFill/>
+        </p:spPr>
+        <p:txBody>
+          <a:bodyPr wrap="square" lIns="18288" rIns="18288" tIns="18288" bIns="18288">
+            <a:spAutoFit/>
+          </a:bodyPr>
+          <a:lstStyle/>
+          <a:p>
+            <a:pPr>
+              <a:spcAft>
+                <a:spcPts val="1100"/>
+              </a:spcAft>
+              <a:defRPr sz="1200" b="0">
+                <a:solidFill>
+                  <a:srgbClr val="0B253F"/>
+                </a:solidFill>
+                <a:latin typeface="Arial"/>
+              </a:defRPr>
+            </a:pPr>
+            <a:r>
+              <a:t>24 / 25</a:t>
+            </a:r>
+          </a:p>
+        </p:txBody>
+      </p:sp>
+      <p:sp>
+        <p:nvSpPr>
+          <p:cNvPr id="5" name="TextBox 4"/>
+          <p:cNvSpPr txBox="1"/>
+          <p:nvPr/>
+        </p:nvSpPr>
+        <p:spPr>
+          <a:xfrm>
+            <a:off x="594360" y="914400"/>
+            <a:ext cx="10789920" cy="365760"/>
+          </a:xfrm>
+          <a:prstGeom prst="rect">
+            <a:avLst/>
+          </a:prstGeom>
+          <a:noFill/>
+        </p:spPr>
+        <p:txBody>
+          <a:bodyPr wrap="square" lIns="18288" rIns="18288" tIns="18288" bIns="18288">
+            <a:spAutoFit/>
+          </a:bodyPr>
+          <a:lstStyle/>
+          <a:p>
+            <a:pPr>
+              <a:spcAft>
+                <a:spcPts val="1100"/>
+              </a:spcAft>
+              <a:defRPr sz="1100" b="1">
+                <a:solidFill>
+                  <a:srgbClr val="0C7A76"/>
+                </a:solidFill>
+                <a:latin typeface="Arial"/>
+              </a:defRPr>
+            </a:pPr>
+            <a:r>
+              <a:t>COMPATÍVEL COM SUA OPERAÇÃO</a:t>
+            </a:r>
+          </a:p>
+        </p:txBody>
+      </p:sp>
+      <p:sp>
+        <p:nvSpPr>
+          <p:cNvPr id="6" name="TextBox 5"/>
+          <p:cNvSpPr txBox="1"/>
+          <p:nvPr/>
+        </p:nvSpPr>
+        <p:spPr>
+          <a:xfrm>
+            <a:off x="594360" y="1389888"/>
+            <a:ext cx="10789920" cy="1170432"/>
+          </a:xfrm>
+          <a:prstGeom prst="rect">
+            <a:avLst/>
+          </a:prstGeom>
+          <a:noFill/>
+        </p:spPr>
+        <p:txBody>
+          <a:bodyPr wrap="square" lIns="18288" rIns="18288" tIns="18288" bIns="18288">
+            <a:spAutoFit/>
+          </a:bodyPr>
+          <a:lstStyle/>
+          <a:p>
+            <a:pPr>
+              <a:spcAft>
+                <a:spcPts val="1100"/>
+              </a:spcAft>
+              <a:defRPr sz="3600" b="1">
+                <a:solidFill>
+                  <a:srgbClr val="0B253F"/>
+                </a:solidFill>
+                <a:latin typeface="Arial"/>
+              </a:defRPr>
+            </a:pPr>
+            <a:r>
+              <a:t>Use o sistema completo</a:t>
+            </a:r>
+          </a:p>
+          <a:p>
+            <a:pPr>
+              <a:spcAft>
+                <a:spcPts val="1100"/>
+              </a:spcAft>
+              <a:defRPr sz="3600" b="1">
+                <a:solidFill>
+                  <a:srgbClr val="0B253F"/>
+                </a:solidFill>
+                <a:latin typeface="Arial"/>
+              </a:defRPr>
+            </a:pPr>
+            <a:r>
+              <a:t>ou integre ao seu app.</a:t>
+            </a:r>
+          </a:p>
+        </p:txBody>
+      </p:sp>
+      <p:sp>
+        <p:nvSpPr>
+          <p:cNvPr id="7" name="TextBox 6"/>
+          <p:cNvSpPr txBox="1"/>
+          <p:nvPr/>
+        </p:nvSpPr>
+        <p:spPr>
+          <a:xfrm>
+            <a:off x="594360" y="2651760"/>
+            <a:ext cx="10789920" cy="658368"/>
+          </a:xfrm>
+          <a:prstGeom prst="rect">
+            <a:avLst/>
+          </a:prstGeom>
+          <a:noFill/>
+        </p:spPr>
+        <p:txBody>
+          <a:bodyPr wrap="square" lIns="18288" rIns="18288" tIns="18288" bIns="18288">
+            <a:spAutoFit/>
+          </a:bodyPr>
+          <a:lstStyle/>
+          <a:p>
+            <a:pPr>
+              <a:spcAft>
+                <a:spcPts val="1100"/>
+              </a:spcAft>
+              <a:defRPr sz="2000" b="0">
+                <a:solidFill>
+                  <a:srgbClr val="577084"/>
+                </a:solidFill>
+                <a:latin typeface="Arial"/>
+              </a:defRPr>
+            </a:pPr>
+            <a:r>
+              <a:t>Módulos adequados ao que a empresa precisa.</a:t>
+            </a:r>
+          </a:p>
+        </p:txBody>
+      </p:sp>
+      <p:sp>
+        <p:nvSpPr>
+          <p:cNvPr id="8" name="TextBox 7"/>
+          <p:cNvSpPr txBox="1"/>
+          <p:nvPr/>
+        </p:nvSpPr>
+        <p:spPr>
+          <a:xfrm>
+            <a:off x="640080" y="3520440"/>
+            <a:ext cx="10789920" cy="2194560"/>
+          </a:xfrm>
+          <a:prstGeom prst="rect">
+            <a:avLst/>
+          </a:prstGeom>
+          <a:noFill/>
+        </p:spPr>
+        <p:txBody>
+          <a:bodyPr wrap="square" lIns="18288" rIns="18288" tIns="18288" bIns="18288">
+            <a:spAutoFit/>
+          </a:bodyPr>
+          <a:lstStyle/>
+          <a:p>
+            <a:pPr>
+              <a:spcAft>
+                <a:spcPts val="1100"/>
+              </a:spcAft>
+              <a:defRPr sz="1800" b="0">
+                <a:solidFill>
+                  <a:srgbClr val="0B253F"/>
+                </a:solidFill>
+                <a:latin typeface="Arial"/>
+              </a:defRPr>
+            </a:pPr>
+            <a:r>
+              <a:t>• WhatsApp e bilhetes podem complementar um sistema de vendas parceiro.</a:t>
+            </a:r>
+          </a:p>
+          <a:p>
+            <a:pPr>
+              <a:spcAft>
+                <a:spcPts val="1100"/>
+              </a:spcAft>
+              <a:defRPr sz="1800" b="0">
+                <a:solidFill>
+                  <a:srgbClr val="0B253F"/>
+                </a:solidFill>
+                <a:latin typeface="Arial"/>
+              </a:defRPr>
+            </a:pPr>
+            <a:r>
+              <a:t>• Dados sincronizados apoiam a comunicação e a operação da viagem.</a:t>
+            </a:r>
+          </a:p>
+          <a:p>
+            <a:pPr>
+              <a:spcAft>
+                <a:spcPts val="1100"/>
+              </a:spcAft>
+              <a:defRPr sz="1800" b="0">
+                <a:solidFill>
+                  <a:srgbClr val="0B253F"/>
+                </a:solidFill>
+                <a:latin typeface="Arial"/>
+              </a:defRPr>
+            </a:pPr>
+            <a:r>
+              <a:t>• Motorista e guia registram embarque e desembarque no Android.</a:t>
+            </a:r>
+          </a:p>
+          <a:p>
+            <a:pPr>
+              <a:spcAft>
+                <a:spcPts val="1100"/>
+              </a:spcAft>
+              <a:defRPr sz="1800" b="0">
+                <a:solidFill>
+                  <a:srgbClr val="0B253F"/>
+                </a:solidFill>
+                <a:latin typeface="Arial"/>
+              </a:defRPr>
+            </a:pPr>
+            <a:r>
+              <a:t>• Permissões por empresa e credenciais de integração controladas.</a:t>
+            </a:r>
+          </a:p>
+        </p:txBody>
+      </p:sp>
+      <p:sp>
+        <p:nvSpPr>
+          <p:cNvPr id="9" name="TextBox 8"/>
+          <p:cNvSpPr txBox="1"/>
+          <p:nvPr/>
+        </p:nvSpPr>
+        <p:spPr>
+          <a:xfrm>
+            <a:off x="594360" y="6217920"/>
+            <a:ext cx="10972800" cy="411480"/>
+          </a:xfrm>
+          <a:prstGeom prst="rect">
+            <a:avLst/>
+          </a:prstGeom>
+          <a:noFill/>
+        </p:spPr>
+        <p:txBody>
+          <a:bodyPr wrap="square" lIns="18288" rIns="18288" tIns="18288" bIns="18288">
+            <a:spAutoFit/>
+          </a:bodyPr>
+          <a:lstStyle/>
+          <a:p>
+            <a:pPr>
+              <a:spcAft>
+                <a:spcPts val="1100"/>
+              </a:spcAft>
+              <a:defRPr sz="1100" b="0">
+                <a:solidFill>
+                  <a:srgbClr val="577084"/>
+                </a:solidFill>
+                <a:latin typeface="Arial"/>
+              </a:defRPr>
+            </a:pPr>
+            <a:r>
+              <a:t>O conjunto de módulos depende da configuração da empresa.</a:t>
+            </a:r>
+          </a:p>
+        </p:txBody>
+      </p:sp>
+    </p:spTree>
+  </p:cSld>
+  <p:clrMapOvr>
+    <a:masterClrMapping/>
+  </p:clrMapOvr>
+</p:sld>
+</file>
+
+<file path=ppt/slides/slide25.xml><?xml version="1.0" encoding="utf-8"?>
 <p:sld xmlns:a="http://schemas.openxmlformats.org/drawingml/2006/main" xmlns:p="http://schemas.openxmlformats.org/presentationml/2006/main" xmlns:r="http://schemas.openxmlformats.org/officeDocument/2006/relationships">
   <p:cSld>
     <p:bg>
@@ -9685,7 +12070,7 @@
               </a:defRPr>
             </a:pPr>
             <a:r>
-              <a:t>20 / 20</a:t>
+              <a:t>25 / 25</a:t>
             </a:r>
           </a:p>
         </p:txBody>
@@ -10075,7 +12460,7 @@
               </a:defRPr>
             </a:pPr>
             <a:r>
-              <a:t>03 / 20</a:t>
+              <a:t>03 / 25</a:t>
             </a:r>
           </a:p>
         </p:txBody>
@@ -10465,7 +12850,7 @@
               </a:defRPr>
             </a:pPr>
             <a:r>
-              <a:t>04 / 20</a:t>
+              <a:t>04 / 25</a:t>
             </a:r>
           </a:p>
         </p:txBody>
@@ -10855,7 +13240,7 @@
               </a:defRPr>
             </a:pPr>
             <a:r>
-              <a:t>05 / 20</a:t>
+              <a:t>05 / 25</a:t>
             </a:r>
           </a:p>
         </p:txBody>
@@ -11245,7 +13630,7 @@
               </a:defRPr>
             </a:pPr>
             <a:r>
-              <a:t>06 / 20</a:t>
+              <a:t>06 / 25</a:t>
             </a:r>
           </a:p>
         </p:txBody>
@@ -11433,7 +13818,7 @@
               </a:defRPr>
             </a:pPr>
             <a:r>
-              <a:t>• Motorista e guias definidos em cada alocação.</a:t>
+              <a:t>• Mais de um motorista e guia podem acompanhar o mesmo veículo.</a:t>
             </a:r>
           </a:p>
           <a:p>
@@ -11635,7 +14020,7 @@
               </a:defRPr>
             </a:pPr>
             <a:r>
-              <a:t>07 / 20</a:t>
+              <a:t>07 / 25</a:t>
             </a:r>
           </a:p>
         </p:txBody>
@@ -12049,7 +14434,7 @@
               </a:defRPr>
             </a:pPr>
             <a:r>
-              <a:t>08 / 20</a:t>
+              <a:t>08 / 25</a:t>
             </a:r>
           </a:p>
         </p:txBody>
@@ -12439,7 +14824,7 @@
               </a:defRPr>
             </a:pPr>
             <a:r>
-              <a:t>09 / 20</a:t>
+              <a:t>09 / 25</a:t>
             </a:r>
           </a:p>
         </p:txBody>

</xml_diff>

<commit_message>
docs: refresh help manuals and commercial presentation (#33)
Co-authored-by: cfartes <23644292+cfartes@users.noreply.github.com>
</commit_message>
<xml_diff>
--- a/frontend/public/documentacao/apresentacao.pptx
+++ b/frontend/public/documentacao/apresentacao.pptx
@@ -25,6 +25,11 @@
     <p:sldId id="273" r:id="rId25"/>
     <p:sldId id="274" r:id="rId26"/>
     <p:sldId id="275" r:id="rId27"/>
+    <p:sldId id="276" r:id="rId28"/>
+    <p:sldId id="277" r:id="rId29"/>
+    <p:sldId id="278" r:id="rId30"/>
+    <p:sldId id="279" r:id="rId31"/>
+    <p:sldId id="280" r:id="rId32"/>
   </p:sldIdLst>
   <p:sldSz cx="12191695" cy="6858000" type="screen4x3"/>
   <p:notesSz cx="6858000" cy="9144000"/>
@@ -521,7 +526,7 @@
           <a:lstStyle/>
           <a:p>
             <a:r>
-              <a:t>Nexus Rotafy Painel web para gestão e atendimento Android para motorista e guia Bilhete individual para o passageiro</a:t>
+              <a:t>Nexus Rotafy Painel web para gestão e atendimento Android para motorista e guia Bilhete individual para o passageiro Apresentação do sistema · Edição 2026.10 · 22/10/2026</a:t>
             </a:r>
           </a:p>
         </p:txBody>
@@ -591,7 +596,7 @@
           <a:lstStyle/>
           <a:p>
             <a:r>
-              <a:t>Um responsável, um telefone e vários passageiros. Menu Vender bilhete, sem abrir o cadastro da viagem. Disponibilidade por segmento e sugestão de veículo para o grupo. Bloqueios de 15 minutos, confirmação, cancelamento e realocação. Importação CSV/XLSX com prévia e validação do lote.</a:t>
+              <a:t>Um responsável, um telefone e vários passageiros. Menu Vender bilhete, sem abrir o cadastro da viagem. Disponibilidade por segmento e sugestão de veículo para o grupo. Bloqueios de 15 minutos, confirmação, cancelamento e realocação. Hotel ou endereço de embarque disponível para motorista e guia. CPF conforme roteiro e exceções; recebimento registrado manualmente como PAGO.</a:t>
             </a:r>
           </a:p>
         </p:txBody>
@@ -661,7 +666,7 @@
           <a:lstStyle/>
           <a:p>
             <a:r>
-              <a:t>O mesmo bilhete em todos os trechos contratados. Página privada com etapas, pontos, horários e veículos. Impressão/PDF, download do QR e compartilhamento do link. Envio do link pelo WhatsApp ao telefone da reserva. Reemissão e revogação para todos os trechos do passageiro.</a:t>
+              <a:t>O mesmo bilhete em todos os trechos contratados. Página privada com etapas, pontos, horários e veículos. Impressão/PDF, download do QR e compartilhamento do link. Envio do link pelo WhatsApp ao telefone da reserva. Reemissão e revogação para todos os trechos do passageiro. A leitura identifica o passageiro; o operador confirma o embarque.</a:t>
             </a:r>
           </a:p>
         </p:txBody>
@@ -731,7 +736,7 @@
           <a:lstStyle/>
           <a:p>
             <a:r>
-              <a:t>WhatsApp e e-mail aproximam sua equipe dos clientes. Confirmação, cancelamento e registro de pagamento por WhatsApp. Resumo da reserva e link do bilhete enviados pelo atendimento. Convites da equipe por WhatsApp, e-mail ou ambos. Histórico de mensagens para acompanhar o atendimento.</a:t>
+              <a:t>WhatsApp e e-mail aproximam sua equipe dos clientes. Confirmação, cancelamento e registro de pagamento por WhatsApp. Conversas, respostas e anexos diretamente no painel da empresa. Menu numerado personalizado com reserva, veículo e embarque. Atendimento humano com pausa das respostas automáticas. O administrador conecta o número da empresa por QR Code no próprio painel; cada empresa mantém sua sessão exclusiva.</a:t>
             </a:r>
           </a:p>
         </p:txBody>
@@ -801,7 +806,7 @@
           <a:lstStyle/>
           <a:p>
             <a:r>
-              <a:t>A viagem na mão de quem executa a operação. Viagens atribuídas e agenda dos próximos sete dias. QR pela câmera, lista e filtros de passageiros. Iniciar viagem, desembarcar todos e registrar chegada. Login biométrico opcional em aparelhos compatíveis.</a:t>
+              <a:t>A viagem na mão de quem executa a operação. Viagens atribuídas e agenda dos próximos sete dias. QR pela câmera, lista e filtros de passageiros. Iniciar viagem, desembarcar todos e registrar chegada. Login biométrico opcional em aparelhos compatíveis. APK por empresa; no perfil operacional, guia não é obrigatório.</a:t>
             </a:r>
           </a:p>
         </p:txBody>
@@ -871,7 +876,7 @@
           <a:lstStyle/>
           <a:p>
             <a:r>
-              <a:t>Lista de passageiros disponível durante o percurso. Prepare a lista do veículo antes de sair. Registre embarques e desembarques mesmo sem conexão. Sincronize os registros ao recuperar a internet. Inicie e finalize o deslocamento com conexão disponível.</a:t>
+              <a:t>Lista de passageiros disponível durante o percurso. Prepare a lista do veículo antes de sair. Registre embarques e desembarques mesmo sem conexão. Sincronize os registros ao recuperar a internet. Inicie e finalize o deslocamento com conexão disponível. Dados locais pendentes não equivalem a confirmação no sistema.</a:t>
             </a:r>
           </a:p>
         </p:txBody>
@@ -941,7 +946,7 @@
           <a:lstStyle/>
           <a:p>
             <a:r>
-              <a:t>Finalização consultável por veículo e trecho. Saída, chegada, responsável e horários registrados. GPS pontual: coordenadas, precisão e horário da captura. Link para consultar o ponto da chegada no Maps. Conclusão geral após todos os veículos e etapas previstos.</a:t>
+              <a:t>Finalização consultável por veículo e trecho. Saída, chegada, responsável e horários registrados. GPS pontual: coordenadas, precisão e horário da captura. Link para consultar o ponto da chegada no Maps. Conclusão geral após todos os veículos e etapas previstos. O registro da chegada fica disponível nos detalhes da viagem.</a:t>
             </a:r>
           </a:p>
         </p:txBody>
@@ -1011,7 +1016,7 @@
           <a:lstStyle/>
           <a:p>
             <a:r>
-              <a:t>Período, situação, veículo e viagem em uma visão integrada. Deslocamentos diários e viagens comerciais iniciadas. Ocupação máxima confirmada por veículo/deslocamento. Valores confirmados, PAGO, ticket médio e produtos vendidos. Baixa ocupação, presença, franquia e exportação CSV.</a:t>
+              <a:t>Período, situação, veículo e viagem em uma visão integrada. Deslocamentos diários e viagens comerciais iniciadas. Ocupação máxima confirmada por veículo/deslocamento. Valores confirmados, PAGO, ticket médio e produtos vendidos. Baixa ocupação, presença, franquia e exportação CSV. Valores nominais e marcação manual; não representam conciliação bancária, fluxo de caixa ou lucro.</a:t>
             </a:r>
           </a:p>
         </p:txBody>
@@ -1081,7 +1086,7 @@
           <a:lstStyle/>
           <a:p>
             <a:r>
-              <a:t>Empresas, planos e assinaturas em um só painel. Basic, Professional, Enterprise e planos adicionais configuráveis. Franquia mensal, mensalidade e valor da unidade extra. Uma viagem simples = uma unidade; pacote = destinos comerciais. Cancelamento estorna o consumo no ciclo original.</a:t>
+              <a:t>Empresas, planos e assinaturas em um só painel. Basic, Professional, Enterprise e planos adicionais configuráveis. Teste inicial, setup separado e mensalidade após cada ciclo de 30 dias, com confirmação automática por link. Uma viagem simples = uma unidade; pacote = destinos comerciais. Cancelamento estorna o consumo no ciclo original. Quatro destinos = quatro unidades, sem acréscimo por retorno, paradas ou quantidade de veículos.</a:t>
             </a:r>
           </a:p>
         </p:txBody>
@@ -1151,7 +1156,7 @@
           <a:lstStyle/>
           <a:p>
             <a:r>
-              <a:t>Um roteiro simples para colocar a equipe em funcionamento. 1 · Empresa, plano, equipe e veículo cadastrados. 2 · Rota criada e viagem agendada com equipe atribuída. 3 · Reserva confirmada, PAGO conferido e bilhete enviado. 4 · Manifesto preparado, embarque realizado e chegada registrada.</a:t>
+              <a:t>Um roteiro simples para colocar a equipe em funcionamento. 1 · Empresa, plano, equipe e veículo cadastrados. 2 · Rota criada e viagem agendada com equipe atribuída. 3 · Reserva confirmada, PAGO conferido e bilhete enviado. 4 · Manifesto preparado, embarque realizado e chegada registrada. O manual traz instruções por perfil, exemplos, checklists e solução de problemas.</a:t>
             </a:r>
           </a:p>
         </p:txBody>
@@ -1221,7 +1226,7 @@
           <a:lstStyle/>
           <a:p>
             <a:r>
-              <a:t>Da preparação do roteiro à análise dos resultados. Reutilize rotas e pacotes para organizar novas saídas. Centralize passageiros, reservas e disponibilidade de lugares. Conecte atendimento, motorista e guia na mesma operação. Acompanhe ocupação, vendas e execução das viagens.</a:t>
+              <a:t>Da preparação do roteiro à análise dos resultados. Reutilize rotas e pacotes para organizar novas saídas. Centralize passageiros, reservas e disponibilidade de lugares. Conecte atendimento, motorista e guia na mesma operação. Acompanhe ocupação, vendas e execução das viagens. Uma visão compartilhada para tomar decisões com mais clareza.</a:t>
             </a:r>
           </a:p>
         </p:txBody>
@@ -1291,7 +1296,7 @@
           <a:lstStyle/>
           <a:p>
             <a:r>
-              <a:t>Planejar → vender → embarcar → concluir → analisar Rotas e pacotes reutilizáveis reduzem o recadastro. Reservas conectam famílias, lugares e deslocamentos. QR e manifestos ligam o atendimento à equipe na estrada. Chegadas e relatórios dão visibilidade ao gestor.</a:t>
+              <a:t>Planejar → vender → embarcar → concluir → analisar Rotas e pacotes reutilizáveis reduzem o recadastro. Reservas conectam famílias, lugares e deslocamentos. QR e manifestos ligam o atendimento à equipe na estrada. Chegadas e relatórios dão visibilidade ao gestor. A operação é validada por empresa, usuário, veículo e trecho.</a:t>
             </a:r>
           </a:p>
         </p:txBody>
@@ -1361,7 +1366,357 @@
           <a:lstStyle/>
           <a:p>
             <a:r>
-              <a:t>Planejamento, atendimento e equipe conectados. Conheça o sistema: rotafy.nexusdataanalytics.tech Manual e downloads: /ajuda Central com HTML, PDF e apresentação editável</a:t>
+              <a:t>Informações úteis no próprio WhatsApp. Qualquer texto abre um menu com saudação personalizada. O passageiro consulta seus bilhetes, reserva, veículo e embarque. A equipe assume a conversa quando necessário. O atendimento automático encerra após um minuto de inatividade. A consulta utiliza o telefone vinculado à reserva.</a:t>
+            </a:r>
+          </a:p>
+        </p:txBody>
+      </p:sp>
+      <p:sp>
+        <p:nvSpPr>
+          <p:cNvPr id="4" name="Slide Number Placeholder 3"/>
+          <p:cNvSpPr>
+            <a:spLocks noGrp="1"/>
+          </p:cNvSpPr>
+          <p:nvPr>
+            <p:ph type="sldNum" idx="5" sz="quarter"/>
+          </p:nvPr>
+        </p:nvSpPr>
+        <p:spPr/>
+      </p:sp>
+    </p:spTree>
+  </p:cSld>
+  <p:clrMapOvr>
+    <a:masterClrMapping/>
+  </p:clrMapOvr>
+</p:notes>
+</file>
+
+<file path=ppt/notesSlides/notesSlide21.xml><?xml version="1.0" encoding="utf-8"?>
+<p:notes xmlns:a="http://schemas.openxmlformats.org/drawingml/2006/main" xmlns:p="http://schemas.openxmlformats.org/presentationml/2006/main" xmlns:r="http://schemas.openxmlformats.org/officeDocument/2006/relationships">
+  <p:cSld>
+    <p:spTree>
+      <p:nvGrpSpPr>
+        <p:cNvPr id="1" name=""/>
+        <p:cNvGrpSpPr/>
+        <p:nvPr/>
+      </p:nvGrpSpPr>
+      <p:grpSpPr>
+        <a:xfrm>
+          <a:off x="0" y="0"/>
+          <a:ext cx="0" cy="0"/>
+          <a:chOff x="0" y="0"/>
+          <a:chExt cx="0" cy="0"/>
+        </a:xfrm>
+      </p:grpSpPr>
+      <p:sp>
+        <p:nvSpPr>
+          <p:cNvPr id="2" name="Slide Image Placeholder 1"/>
+          <p:cNvSpPr>
+            <a:spLocks noGrp="1"/>
+          </p:cNvSpPr>
+          <p:nvPr>
+            <p:ph type="sldImg" idx="2"/>
+          </p:nvPr>
+        </p:nvSpPr>
+        <p:spPr/>
+      </p:sp>
+      <p:sp>
+        <p:nvSpPr>
+          <p:cNvPr id="3" name="Notes Placeholder 2"/>
+          <p:cNvSpPr>
+            <a:spLocks noGrp="1"/>
+          </p:cNvSpPr>
+          <p:nvPr>
+            <p:ph type="body" idx="3" sz="quarter"/>
+          </p:nvPr>
+        </p:nvSpPr>
+        <p:spPr/>
+        <p:txBody>
+          <a:bodyPr/>
+          <a:lstStyle/>
+          <a:p>
+            <a:r>
+              <a:t>Ative o envio automático antes do primeiro embarque. Reservas confirmadas entram na fila até 24 horas antes. Um bilhete por passageiro, válido para todos os trechos contratados. Intervalo mínimo de três minutos entre os envios automáticos. O envio manual permanece disponível para o atendimento. A entrada na fila não garante o horário exato de entrega; acompanhe os envios.</a:t>
+            </a:r>
+          </a:p>
+        </p:txBody>
+      </p:sp>
+      <p:sp>
+        <p:nvSpPr>
+          <p:cNvPr id="4" name="Slide Number Placeholder 3"/>
+          <p:cNvSpPr>
+            <a:spLocks noGrp="1"/>
+          </p:cNvSpPr>
+          <p:nvPr>
+            <p:ph type="sldNum" idx="5" sz="quarter"/>
+          </p:nvPr>
+        </p:nvSpPr>
+        <p:spPr/>
+      </p:sp>
+    </p:spTree>
+  </p:cSld>
+  <p:clrMapOvr>
+    <a:masterClrMapping/>
+  </p:clrMapOvr>
+</p:notes>
+</file>
+
+<file path=ppt/notesSlides/notesSlide22.xml><?xml version="1.0" encoding="utf-8"?>
+<p:notes xmlns:a="http://schemas.openxmlformats.org/drawingml/2006/main" xmlns:p="http://schemas.openxmlformats.org/presentationml/2006/main" xmlns:r="http://schemas.openxmlformats.org/officeDocument/2006/relationships">
+  <p:cSld>
+    <p:spTree>
+      <p:nvGrpSpPr>
+        <p:cNvPr id="1" name=""/>
+        <p:cNvGrpSpPr/>
+        <p:nvPr/>
+      </p:nvGrpSpPr>
+      <p:grpSpPr>
+        <a:xfrm>
+          <a:off x="0" y="0"/>
+          <a:ext cx="0" cy="0"/>
+          <a:chOff x="0" y="0"/>
+          <a:chExt cx="0" cy="0"/>
+        </a:xfrm>
+      </p:grpSpPr>
+      <p:sp>
+        <p:nvSpPr>
+          <p:cNvPr id="2" name="Slide Image Placeholder 1"/>
+          <p:cNvSpPr>
+            <a:spLocks noGrp="1"/>
+          </p:cNvSpPr>
+          <p:nvPr>
+            <p:ph type="sldImg" idx="2"/>
+          </p:nvPr>
+        </p:nvSpPr>
+        <p:spPr/>
+      </p:sp>
+      <p:sp>
+        <p:nvSpPr>
+          <p:cNvPr id="3" name="Notes Placeholder 2"/>
+          <p:cNvSpPr>
+            <a:spLocks noGrp="1"/>
+          </p:cNvSpPr>
+          <p:nvPr>
+            <p:ph type="body" idx="3" sz="quarter"/>
+          </p:nvPr>
+        </p:nvSpPr>
+        <p:spPr/>
+        <p:txBody>
+          <a:bodyPr/>
+          <a:lstStyle/>
+          <a:p>
+            <a:r>
+              <a:t>Rastreamento e avisos configuráveis pela empresa. Posições do celular responsável coletadas a cada cinco minutos. Mapa com última posição e trilha das amostras durante o trecho. Aviso de proximidade para embarques confirmados no mapa. Lembrete de saída na ida e na volta pelo WhatsApp. Localização aproximada; depende de conexão, GPS e permissões.</a:t>
+            </a:r>
+          </a:p>
+        </p:txBody>
+      </p:sp>
+      <p:sp>
+        <p:nvSpPr>
+          <p:cNvPr id="4" name="Slide Number Placeholder 3"/>
+          <p:cNvSpPr>
+            <a:spLocks noGrp="1"/>
+          </p:cNvSpPr>
+          <p:nvPr>
+            <p:ph type="sldNum" idx="5" sz="quarter"/>
+          </p:nvPr>
+        </p:nvSpPr>
+        <p:spPr/>
+      </p:sp>
+    </p:spTree>
+  </p:cSld>
+  <p:clrMapOvr>
+    <a:masterClrMapping/>
+  </p:clrMapOvr>
+</p:notes>
+</file>
+
+<file path=ppt/notesSlides/notesSlide23.xml><?xml version="1.0" encoding="utf-8"?>
+<p:notes xmlns:a="http://schemas.openxmlformats.org/drawingml/2006/main" xmlns:p="http://schemas.openxmlformats.org/presentationml/2006/main" xmlns:r="http://schemas.openxmlformats.org/officeDocument/2006/relationships">
+  <p:cSld>
+    <p:spTree>
+      <p:nvGrpSpPr>
+        <p:cNvPr id="1" name=""/>
+        <p:cNvGrpSpPr/>
+        <p:nvPr/>
+      </p:nvGrpSpPr>
+      <p:grpSpPr>
+        <a:xfrm>
+          <a:off x="0" y="0"/>
+          <a:ext cx="0" cy="0"/>
+          <a:chOff x="0" y="0"/>
+          <a:chExt cx="0" cy="0"/>
+        </a:xfrm>
+      </p:grpSpPr>
+      <p:sp>
+        <p:nvSpPr>
+          <p:cNvPr id="2" name="Slide Image Placeholder 1"/>
+          <p:cNvSpPr>
+            <a:spLocks noGrp="1"/>
+          </p:cNvSpPr>
+          <p:nvPr>
+            <p:ph type="sldImg" idx="2"/>
+          </p:nvPr>
+        </p:nvSpPr>
+        <p:spPr/>
+      </p:sp>
+      <p:sp>
+        <p:nvSpPr>
+          <p:cNvPr id="3" name="Notes Placeholder 2"/>
+          <p:cNvSpPr>
+            <a:spLocks noGrp="1"/>
+          </p:cNvSpPr>
+          <p:nvPr>
+            <p:ph type="body" idx="3" sz="quarter"/>
+          </p:nvPr>
+        </p:nvSpPr>
+        <p:spPr/>
+        <p:txBody>
+          <a:bodyPr/>
+          <a:lstStyle/>
+          <a:p>
+            <a:r>
+              <a:t>Contrato, valores e vencimentos no mesmo ambiente. Leitura e download do contrato antes do aceite por confirmação de e-mail. Plano e valores preservados no documento; mudanças exigem novo aceite. Financeiro com valor previsto, próximo vencimento e situação. Link de pagamento e confirmação automática após aprovação. O setup é separado; a mensalidade é cobrada ao final do ciclo de 30 dias.</a:t>
+            </a:r>
+          </a:p>
+        </p:txBody>
+      </p:sp>
+      <p:sp>
+        <p:nvSpPr>
+          <p:cNvPr id="4" name="Slide Number Placeholder 3"/>
+          <p:cNvSpPr>
+            <a:spLocks noGrp="1"/>
+          </p:cNvSpPr>
+          <p:nvPr>
+            <p:ph type="sldNum" idx="5" sz="quarter"/>
+          </p:nvPr>
+        </p:nvSpPr>
+        <p:spPr/>
+      </p:sp>
+    </p:spTree>
+  </p:cSld>
+  <p:clrMapOvr>
+    <a:masterClrMapping/>
+  </p:clrMapOvr>
+</p:notes>
+</file>
+
+<file path=ppt/notesSlides/notesSlide24.xml><?xml version="1.0" encoding="utf-8"?>
+<p:notes xmlns:a="http://schemas.openxmlformats.org/drawingml/2006/main" xmlns:p="http://schemas.openxmlformats.org/presentationml/2006/main" xmlns:r="http://schemas.openxmlformats.org/officeDocument/2006/relationships">
+  <p:cSld>
+    <p:spTree>
+      <p:nvGrpSpPr>
+        <p:cNvPr id="1" name=""/>
+        <p:cNvGrpSpPr/>
+        <p:nvPr/>
+      </p:nvGrpSpPr>
+      <p:grpSpPr>
+        <a:xfrm>
+          <a:off x="0" y="0"/>
+          <a:ext cx="0" cy="0"/>
+          <a:chOff x="0" y="0"/>
+          <a:chExt cx="0" cy="0"/>
+        </a:xfrm>
+      </p:grpSpPr>
+      <p:sp>
+        <p:nvSpPr>
+          <p:cNvPr id="2" name="Slide Image Placeholder 1"/>
+          <p:cNvSpPr>
+            <a:spLocks noGrp="1"/>
+          </p:cNvSpPr>
+          <p:nvPr>
+            <p:ph type="sldImg" idx="2"/>
+          </p:nvPr>
+        </p:nvSpPr>
+        <p:spPr/>
+      </p:sp>
+      <p:sp>
+        <p:nvSpPr>
+          <p:cNvPr id="3" name="Notes Placeholder 2"/>
+          <p:cNvSpPr>
+            <a:spLocks noGrp="1"/>
+          </p:cNvSpPr>
+          <p:nvPr>
+            <p:ph type="body" idx="3" sz="quarter"/>
+          </p:nvPr>
+        </p:nvSpPr>
+        <p:spPr/>
+        <p:txBody>
+          <a:bodyPr/>
+          <a:lstStyle/>
+          <a:p>
+            <a:r>
+              <a:t>Módulos adequados ao que a empresa precisa. WhatsApp e bilhetes podem complementar um sistema de vendas parceiro. Dados sincronizados apoiam a comunicação e a operação da viagem. Motorista e guia registram embarque e desembarque no Android. Permissões por empresa e credenciais de integração controladas. O conjunto de módulos depende da configuração da empresa.</a:t>
+            </a:r>
+          </a:p>
+        </p:txBody>
+      </p:sp>
+      <p:sp>
+        <p:nvSpPr>
+          <p:cNvPr id="4" name="Slide Number Placeholder 3"/>
+          <p:cNvSpPr>
+            <a:spLocks noGrp="1"/>
+          </p:cNvSpPr>
+          <p:nvPr>
+            <p:ph type="sldNum" idx="5" sz="quarter"/>
+          </p:nvPr>
+        </p:nvSpPr>
+        <p:spPr/>
+      </p:sp>
+    </p:spTree>
+  </p:cSld>
+  <p:clrMapOvr>
+    <a:masterClrMapping/>
+  </p:clrMapOvr>
+</p:notes>
+</file>
+
+<file path=ppt/notesSlides/notesSlide25.xml><?xml version="1.0" encoding="utf-8"?>
+<p:notes xmlns:a="http://schemas.openxmlformats.org/drawingml/2006/main" xmlns:p="http://schemas.openxmlformats.org/presentationml/2006/main" xmlns:r="http://schemas.openxmlformats.org/officeDocument/2006/relationships">
+  <p:cSld>
+    <p:spTree>
+      <p:nvGrpSpPr>
+        <p:cNvPr id="1" name=""/>
+        <p:cNvGrpSpPr/>
+        <p:nvPr/>
+      </p:nvGrpSpPr>
+      <p:grpSpPr>
+        <a:xfrm>
+          <a:off x="0" y="0"/>
+          <a:ext cx="0" cy="0"/>
+          <a:chOff x="0" y="0"/>
+          <a:chExt cx="0" cy="0"/>
+        </a:xfrm>
+      </p:grpSpPr>
+      <p:sp>
+        <p:nvSpPr>
+          <p:cNvPr id="2" name="Slide Image Placeholder 1"/>
+          <p:cNvSpPr>
+            <a:spLocks noGrp="1"/>
+          </p:cNvSpPr>
+          <p:nvPr>
+            <p:ph type="sldImg" idx="2"/>
+          </p:nvPr>
+        </p:nvSpPr>
+        <p:spPr/>
+      </p:sp>
+      <p:sp>
+        <p:nvSpPr>
+          <p:cNvPr id="3" name="Notes Placeholder 2"/>
+          <p:cNvSpPr>
+            <a:spLocks noGrp="1"/>
+          </p:cNvSpPr>
+          <p:nvPr>
+            <p:ph type="body" idx="3" sz="quarter"/>
+          </p:nvPr>
+        </p:nvSpPr>
+        <p:spPr/>
+        <p:txBody>
+          <a:bodyPr/>
+          <a:lstStyle/>
+          <a:p>
+            <a:r>
+              <a:t>Planejamento, atendimento e equipe conectados. Conheça o sistema: rotafy.nexusdataanalytics.tech Manual e downloads: /ajuda Central com HTML, PDF e apresentação editável Nexus Data Analytics · Edição 2026.10</a:t>
             </a:r>
           </a:p>
         </p:txBody>
@@ -1431,7 +1786,7 @@
           <a:lstStyle/>
           <a:p>
             <a:r>
-              <a:t>Uma plataforma compartilhada, com operação segregada. Cadastros, viagens, reservas e históricos pertencem à empresa. Acesso definido pelo identificador da empresa e pelo perfil do usuário. Um profissional de várias empresas possui um cadastro em cada uma. Nexus administra empresas, planos e configurações da plataforma.</a:t>
+              <a:t>Uma plataforma compartilhada, com operação segregada. Cadastros, viagens, reservas e históricos pertencem à empresa. Acesso definido pelo identificador da empresa e pelo perfil do usuário. Um profissional de várias empresas possui um cadastro em cada uma. Nexus administra empresas, planos e configurações da plataforma. Guias e motoristas acessam somente os deslocamentos atribuídos.</a:t>
             </a:r>
           </a:p>
         </p:txBody>
@@ -1501,7 +1856,7 @@
           <a:lstStyle/>
           <a:p>
             <a:r>
-              <a:t>O cadastro inicial orienta a experiência da empresa. Turismo: viagens simples, transfers e pacotes com vários destinos. Regular: viagens simples, Rotas, frota, reservas e embarque. Os menus turísticos ficam ocultos no perfil Regular. Perfil operacional e plano comercial são escolhas independentes.</a:t>
+              <a:t>O cadastro inicial orienta a experiência da empresa. Turismo: viagens simples, transfers e pacotes com vários destinos. Regular: viagens simples, Rotas, frota, reservas e embarque. Os menus turísticos ficam ocultos no perfil Regular. Perfil operacional e plano comercial são escolhas independentes. Uma experiência organizada para cada tipo de operação.</a:t>
             </a:r>
           </a:p>
         </p:txBody>
@@ -1571,7 +1926,7 @@
           <a:lstStyle/>
           <a:p>
             <a:r>
-              <a:t>Administrador, atendente, motorista e guia. Cadastro, ativação e suspensão de colaboradores. Convite por e-mail, WhatsApp ou pelos dois canais. Link de 24 horas para definir a própria senha. Recuperação de acesso e registro de atividades.</a:t>
+              <a:t>Administrador, atendente, motorista e guia. Cadastro, ativação e suspensão de colaboradores. Convite por e-mail, WhatsApp ou pelos dois canais. Link de 24 horas para definir a própria senha. Recuperação de acesso e registro de atividades. Motorista e guia compartilham os recursos operacionais; o guia é opcional.</a:t>
             </a:r>
           </a:p>
         </p:txBody>
@@ -1641,7 +1996,7 @@
           <a:lstStyle/>
           <a:p>
             <a:r>
-              <a:t>Capacidade e equipe conectadas ao planejamento. Cadastro de veículo, placa e quantidade de lugares. Vários veículos na mesma viagem ou deslocamento. Motorista e guias definidos em cada alocação. Conflitos de horários e capacidade verificados ao salvar.</a:t>
+              <a:t>Capacidade e equipe conectadas ao planejamento. Cadastro de veículo, placa e quantidade de lugares. Vários veículos na mesma viagem ou deslocamento. Mais de um motorista e guia podem acompanhar o mesmo veículo. Conflitos de horários e capacidade verificados ao salvar. A distribuição considera quantidade de lugares; não há escolha de poltrona numerada.</a:t>
             </a:r>
           </a:p>
         </p:txBody>
@@ -1711,7 +2066,7 @@
           <a:lstStyle/>
           <a:p>
             <a:r>
-              <a:t>Cidades, endereços, paradas e duração estimada. UF e cidade para origem e destino. Paradas ordenadas de embarque, desembarque ou ambos. Somente ida ou ida e volta, com sugestão de retorno invertido. Navegação abre o Google Maps externo.</a:t>
+              <a:t>Cidades, endereços, paradas e duração estimada. UF e cidade para origem e destino. Paradas ordenadas de embarque, desembarque ou ambos. Somente ida ou ida e volta, com sugestão de retorno invertido. Navegação abre o Google Maps externo. Duração manual. Atualizar uma Rota não altera automaticamente viagens já criadas.</a:t>
             </a:r>
           </a:p>
         </p:txBody>
@@ -1781,7 +2136,7 @@
           <a:lstStyle/>
           <a:p>
             <a:r>
-              <a:t>Dois formatos para simplificar o roteiro. Passeios: cada dia retorna à mesma cidade-base. Sequência: várias cidades, com permanência e dias livres. Modelo com dias relativos; datas reais são definidas na saída. Venda do pacote completo, com retorno incluído.</a:t>
+              <a:t>Dois formatos para simplificar o roteiro. Passeios: cada dia retorna à mesma cidade-base. Sequência: várias cidades, com permanência e dias livres. Modelo com dias relativos; datas reais são definidas na saída. Venda do pacote completo, com retorno incluído. Exemplos: Maceió ↔ Maragogi / Gunga; ou Maceió → Fortaleza → Natal → Maceió.</a:t>
             </a:r>
           </a:p>
         </p:txBody>
@@ -1851,7 +2206,7 @@
           <a:lstStyle/>
           <a:p>
             <a:r>
-              <a:t>Rota ou pacote + data + horários + veículos + equipe. Viagem simples com trecho único ou ida e volta. Saída de pacote com todas as etapas e chegadas previstas. Troca de veículo e equipe entre deslocamentos do roteiro. Filtros de situação, edição protegida, duplicação e cancelamento.</a:t>
+              <a:t>Rota ou pacote + data + horários + veículos + equipe. Viagem simples com trecho único ou ida e volta. Saída de pacote com todas as etapas e chegadas previstas. Troca de veículo e equipe entre deslocamentos do roteiro. Filtros de situação, edição protegida, duplicação e cancelamento. A saída preserva sua versão de percurso, preço e capacidade.</a:t>
             </a:r>
           </a:p>
         </p:txBody>
@@ -4981,7 +5336,7 @@
               </a:defRPr>
             </a:pPr>
             <a:r>
-              <a:t>01 / 20</a:t>
+              <a:t>01 / 25</a:t>
             </a:r>
           </a:p>
         </p:txBody>
@@ -5224,7 +5579,7 @@
               </a:defRPr>
             </a:pPr>
             <a:r>
-              <a:t>Apresentação do sistema · Edição 2026.10 · 09/10/2026</a:t>
+              <a:t>Apresentação do sistema · Edição 2026.10 · 22/10/2026</a:t>
             </a:r>
           </a:p>
         </p:txBody>
@@ -5371,7 +5726,7 @@
               </a:defRPr>
             </a:pPr>
             <a:r>
-              <a:t>10 / 20</a:t>
+              <a:t>10 / 25</a:t>
             </a:r>
           </a:p>
         </p:txBody>
@@ -5575,7 +5930,7 @@
               </a:defRPr>
             </a:pPr>
             <a:r>
-              <a:t>• Importação CSV/XLSX com prévia e validação do lote.</a:t>
+              <a:t>• Hotel ou endereço de embarque disponível para motorista e guia.</a:t>
             </a:r>
           </a:p>
         </p:txBody>
@@ -5761,7 +6116,7 @@
               </a:defRPr>
             </a:pPr>
             <a:r>
-              <a:t>11 / 20</a:t>
+              <a:t>11 / 25</a:t>
             </a:r>
           </a:p>
         </p:txBody>
@@ -6151,7 +6506,7 @@
               </a:defRPr>
             </a:pPr>
             <a:r>
-              <a:t>12 / 20</a:t>
+              <a:t>12 / 25</a:t>
             </a:r>
           </a:p>
         </p:txBody>
@@ -6323,7 +6678,7 @@
               </a:defRPr>
             </a:pPr>
             <a:r>
-              <a:t>• Resumo da reserva e link do bilhete enviados pelo atendimento.</a:t>
+              <a:t>• Conversas, respostas e anexos diretamente no painel da empresa.</a:t>
             </a:r>
           </a:p>
           <a:p>
@@ -6339,7 +6694,7 @@
               </a:defRPr>
             </a:pPr>
             <a:r>
-              <a:t>• Convites da equipe por WhatsApp, e-mail ou ambos.</a:t>
+              <a:t>• Menu numerado personalizado com reserva, veículo e embarque.</a:t>
             </a:r>
           </a:p>
           <a:p>
@@ -6355,7 +6710,7 @@
               </a:defRPr>
             </a:pPr>
             <a:r>
-              <a:t>• Histórico de mensagens para acompanhar o atendimento.</a:t>
+              <a:t>• Atendimento humano com pausa das respostas automáticas.</a:t>
             </a:r>
           </a:p>
         </p:txBody>
@@ -6541,7 +6896,7 @@
               </a:defRPr>
             </a:pPr>
             <a:r>
-              <a:t>13 / 20</a:t>
+              <a:t>13 / 25</a:t>
             </a:r>
           </a:p>
         </p:txBody>
@@ -6931,7 +7286,7 @@
               </a:defRPr>
             </a:pPr>
             <a:r>
-              <a:t>14 / 20</a:t>
+              <a:t>14 / 25</a:t>
             </a:r>
           </a:p>
         </p:txBody>
@@ -7321,7 +7676,7 @@
               </a:defRPr>
             </a:pPr>
             <a:r>
-              <a:t>15 / 20</a:t>
+              <a:t>15 / 25</a:t>
             </a:r>
           </a:p>
         </p:txBody>
@@ -7711,7 +8066,7 @@
               </a:defRPr>
             </a:pPr>
             <a:r>
-              <a:t>16 / 20</a:t>
+              <a:t>16 / 25</a:t>
             </a:r>
           </a:p>
         </p:txBody>
@@ -8125,7 +8480,7 @@
               </a:defRPr>
             </a:pPr>
             <a:r>
-              <a:t>17 / 20</a:t>
+              <a:t>17 / 25</a:t>
             </a:r>
           </a:p>
         </p:txBody>
@@ -8515,7 +8870,7 @@
               </a:defRPr>
             </a:pPr>
             <a:r>
-              <a:t>18 / 20</a:t>
+              <a:t>18 / 25</a:t>
             </a:r>
           </a:p>
         </p:txBody>
@@ -8905,7 +9260,7 @@
               </a:defRPr>
             </a:pPr>
             <a:r>
-              <a:t>19 / 20</a:t>
+              <a:t>19 / 25</a:t>
             </a:r>
           </a:p>
         </p:txBody>
@@ -9295,7 +9650,7 @@
               </a:defRPr>
             </a:pPr>
             <a:r>
-              <a:t>02 / 20</a:t>
+              <a:t>02 / 25</a:t>
             </a:r>
           </a:p>
         </p:txBody>
@@ -9552,6 +9907,2036 @@
 </file>
 
 <file path=ppt/slides/slide20.xml><?xml version="1.0" encoding="utf-8"?>
+<p:sld xmlns:a="http://schemas.openxmlformats.org/drawingml/2006/main" xmlns:p="http://schemas.openxmlformats.org/presentationml/2006/main" xmlns:r="http://schemas.openxmlformats.org/officeDocument/2006/relationships">
+  <p:cSld>
+    <p:bg>
+      <p:bgPr>
+        <a:solidFill>
+          <a:srgbClr val="F4F7FA"/>
+        </a:solidFill>
+        <a:effectLst/>
+      </p:bgPr>
+    </p:bg>
+    <p:spTree>
+      <p:nvGrpSpPr>
+        <p:cNvPr id="1" name=""/>
+        <p:cNvGrpSpPr/>
+        <p:nvPr/>
+      </p:nvGrpSpPr>
+      <p:grpSpPr/>
+      <p:sp>
+        <p:nvSpPr>
+          <p:cNvPr id="2" name="Rectangle 1"/>
+          <p:cNvSpPr/>
+          <p:nvPr/>
+        </p:nvSpPr>
+        <p:spPr>
+          <a:xfrm>
+            <a:off x="0" y="0"/>
+            <a:ext cx="109728" cy="6858000"/>
+          </a:xfrm>
+          <a:prstGeom prst="rect">
+            <a:avLst/>
+          </a:prstGeom>
+          <a:solidFill>
+            <a:srgbClr val="0C7A76"/>
+          </a:solidFill>
+          <a:ln>
+            <a:noFill/>
+          </a:ln>
+        </p:spPr>
+        <p:style>
+          <a:lnRef idx="1">
+            <a:schemeClr val="accent1"/>
+          </a:lnRef>
+          <a:fillRef idx="3">
+            <a:schemeClr val="accent1"/>
+          </a:fillRef>
+          <a:effectRef idx="2">
+            <a:schemeClr val="accent1"/>
+          </a:effectRef>
+          <a:fontRef idx="minor">
+            <a:schemeClr val="lt1"/>
+          </a:fontRef>
+        </p:style>
+        <p:txBody>
+          <a:bodyPr rtlCol="0" anchor="ctr"/>
+          <a:lstStyle/>
+          <a:p>
+            <a:pPr algn="ctr"/>
+          </a:p>
+        </p:txBody>
+      </p:sp>
+      <p:sp>
+        <p:nvSpPr>
+          <p:cNvPr id="3" name="TextBox 2"/>
+          <p:cNvSpPr txBox="1"/>
+          <p:nvPr/>
+        </p:nvSpPr>
+        <p:spPr>
+          <a:xfrm>
+            <a:off x="594360" y="320040"/>
+            <a:ext cx="2743200" cy="365760"/>
+          </a:xfrm>
+          <a:prstGeom prst="rect">
+            <a:avLst/>
+          </a:prstGeom>
+          <a:noFill/>
+        </p:spPr>
+        <p:txBody>
+          <a:bodyPr wrap="square" lIns="18288" rIns="18288" tIns="18288" bIns="18288">
+            <a:spAutoFit/>
+          </a:bodyPr>
+          <a:lstStyle/>
+          <a:p>
+            <a:pPr>
+              <a:spcAft>
+                <a:spcPts val="1100"/>
+              </a:spcAft>
+              <a:defRPr sz="1800" b="1">
+                <a:solidFill>
+                  <a:srgbClr val="0B253F"/>
+                </a:solidFill>
+                <a:latin typeface="Arial"/>
+              </a:defRPr>
+            </a:pPr>
+            <a:r>
+              <a:t>rotafy.  /  NEXUS</a:t>
+            </a:r>
+          </a:p>
+        </p:txBody>
+      </p:sp>
+      <p:sp>
+        <p:nvSpPr>
+          <p:cNvPr id="4" name="TextBox 3"/>
+          <p:cNvSpPr txBox="1"/>
+          <p:nvPr/>
+        </p:nvSpPr>
+        <p:spPr>
+          <a:xfrm>
+            <a:off x="10424160" y="365760"/>
+            <a:ext cx="1188720" cy="320040"/>
+          </a:xfrm>
+          <a:prstGeom prst="rect">
+            <a:avLst/>
+          </a:prstGeom>
+          <a:noFill/>
+        </p:spPr>
+        <p:txBody>
+          <a:bodyPr wrap="square" lIns="18288" rIns="18288" tIns="18288" bIns="18288">
+            <a:spAutoFit/>
+          </a:bodyPr>
+          <a:lstStyle/>
+          <a:p>
+            <a:pPr>
+              <a:spcAft>
+                <a:spcPts val="1100"/>
+              </a:spcAft>
+              <a:defRPr sz="1200" b="0">
+                <a:solidFill>
+                  <a:srgbClr val="0B253F"/>
+                </a:solidFill>
+                <a:latin typeface="Arial"/>
+              </a:defRPr>
+            </a:pPr>
+            <a:r>
+              <a:t>20 / 25</a:t>
+            </a:r>
+          </a:p>
+        </p:txBody>
+      </p:sp>
+      <p:sp>
+        <p:nvSpPr>
+          <p:cNvPr id="5" name="TextBox 4"/>
+          <p:cNvSpPr txBox="1"/>
+          <p:nvPr/>
+        </p:nvSpPr>
+        <p:spPr>
+          <a:xfrm>
+            <a:off x="594360" y="914400"/>
+            <a:ext cx="10789920" cy="365760"/>
+          </a:xfrm>
+          <a:prstGeom prst="rect">
+            <a:avLst/>
+          </a:prstGeom>
+          <a:noFill/>
+        </p:spPr>
+        <p:txBody>
+          <a:bodyPr wrap="square" lIns="18288" rIns="18288" tIns="18288" bIns="18288">
+            <a:spAutoFit/>
+          </a:bodyPr>
+          <a:lstStyle/>
+          <a:p>
+            <a:pPr>
+              <a:spcAft>
+                <a:spcPts val="1100"/>
+              </a:spcAft>
+              <a:defRPr sz="1100" b="1">
+                <a:solidFill>
+                  <a:srgbClr val="0C7A76"/>
+                </a:solidFill>
+                <a:latin typeface="Arial"/>
+              </a:defRPr>
+            </a:pPr>
+            <a:r>
+              <a:t>ATENDIMENTO MAIS ÁGIL</a:t>
+            </a:r>
+          </a:p>
+        </p:txBody>
+      </p:sp>
+      <p:sp>
+        <p:nvSpPr>
+          <p:cNvPr id="6" name="TextBox 5"/>
+          <p:cNvSpPr txBox="1"/>
+          <p:nvPr/>
+        </p:nvSpPr>
+        <p:spPr>
+          <a:xfrm>
+            <a:off x="594360" y="1389888"/>
+            <a:ext cx="10789920" cy="1170432"/>
+          </a:xfrm>
+          <a:prstGeom prst="rect">
+            <a:avLst/>
+          </a:prstGeom>
+          <a:noFill/>
+        </p:spPr>
+        <p:txBody>
+          <a:bodyPr wrap="square" lIns="18288" rIns="18288" tIns="18288" bIns="18288">
+            <a:spAutoFit/>
+          </a:bodyPr>
+          <a:lstStyle/>
+          <a:p>
+            <a:pPr>
+              <a:spcAft>
+                <a:spcPts val="1100"/>
+              </a:spcAft>
+              <a:defRPr sz="3600" b="1">
+                <a:solidFill>
+                  <a:srgbClr val="0B253F"/>
+                </a:solidFill>
+                <a:latin typeface="Arial"/>
+              </a:defRPr>
+            </a:pPr>
+            <a:r>
+              <a:t>O passageiro pergunta.</a:t>
+            </a:r>
+          </a:p>
+          <a:p>
+            <a:pPr>
+              <a:spcAft>
+                <a:spcPts val="1100"/>
+              </a:spcAft>
+              <a:defRPr sz="3600" b="1">
+                <a:solidFill>
+                  <a:srgbClr val="0B253F"/>
+                </a:solidFill>
+                <a:latin typeface="Arial"/>
+              </a:defRPr>
+            </a:pPr>
+            <a:r>
+              <a:t>A empresa acompanha.</a:t>
+            </a:r>
+          </a:p>
+        </p:txBody>
+      </p:sp>
+      <p:sp>
+        <p:nvSpPr>
+          <p:cNvPr id="7" name="TextBox 6"/>
+          <p:cNvSpPr txBox="1"/>
+          <p:nvPr/>
+        </p:nvSpPr>
+        <p:spPr>
+          <a:xfrm>
+            <a:off x="594360" y="2651760"/>
+            <a:ext cx="10789920" cy="658368"/>
+          </a:xfrm>
+          <a:prstGeom prst="rect">
+            <a:avLst/>
+          </a:prstGeom>
+          <a:noFill/>
+        </p:spPr>
+        <p:txBody>
+          <a:bodyPr wrap="square" lIns="18288" rIns="18288" tIns="18288" bIns="18288">
+            <a:spAutoFit/>
+          </a:bodyPr>
+          <a:lstStyle/>
+          <a:p>
+            <a:pPr>
+              <a:spcAft>
+                <a:spcPts val="1100"/>
+              </a:spcAft>
+              <a:defRPr sz="2000" b="0">
+                <a:solidFill>
+                  <a:srgbClr val="577084"/>
+                </a:solidFill>
+                <a:latin typeface="Arial"/>
+              </a:defRPr>
+            </a:pPr>
+            <a:r>
+              <a:t>Informações úteis no próprio WhatsApp.</a:t>
+            </a:r>
+          </a:p>
+        </p:txBody>
+      </p:sp>
+      <p:sp>
+        <p:nvSpPr>
+          <p:cNvPr id="8" name="TextBox 7"/>
+          <p:cNvSpPr txBox="1"/>
+          <p:nvPr/>
+        </p:nvSpPr>
+        <p:spPr>
+          <a:xfrm>
+            <a:off x="640080" y="3520440"/>
+            <a:ext cx="10789920" cy="2194560"/>
+          </a:xfrm>
+          <a:prstGeom prst="rect">
+            <a:avLst/>
+          </a:prstGeom>
+          <a:noFill/>
+        </p:spPr>
+        <p:txBody>
+          <a:bodyPr wrap="square" lIns="18288" rIns="18288" tIns="18288" bIns="18288">
+            <a:spAutoFit/>
+          </a:bodyPr>
+          <a:lstStyle/>
+          <a:p>
+            <a:pPr>
+              <a:spcAft>
+                <a:spcPts val="1100"/>
+              </a:spcAft>
+              <a:defRPr sz="1800" b="0">
+                <a:solidFill>
+                  <a:srgbClr val="0B253F"/>
+                </a:solidFill>
+                <a:latin typeface="Arial"/>
+              </a:defRPr>
+            </a:pPr>
+            <a:r>
+              <a:t>• Qualquer texto abre um menu com saudação personalizada.</a:t>
+            </a:r>
+          </a:p>
+          <a:p>
+            <a:pPr>
+              <a:spcAft>
+                <a:spcPts val="1100"/>
+              </a:spcAft>
+              <a:defRPr sz="1800" b="0">
+                <a:solidFill>
+                  <a:srgbClr val="0B253F"/>
+                </a:solidFill>
+                <a:latin typeface="Arial"/>
+              </a:defRPr>
+            </a:pPr>
+            <a:r>
+              <a:t>• O passageiro consulta seus bilhetes, reserva, veículo e embarque.</a:t>
+            </a:r>
+          </a:p>
+          <a:p>
+            <a:pPr>
+              <a:spcAft>
+                <a:spcPts val="1100"/>
+              </a:spcAft>
+              <a:defRPr sz="1800" b="0">
+                <a:solidFill>
+                  <a:srgbClr val="0B253F"/>
+                </a:solidFill>
+                <a:latin typeface="Arial"/>
+              </a:defRPr>
+            </a:pPr>
+            <a:r>
+              <a:t>• A equipe assume a conversa quando necessário.</a:t>
+            </a:r>
+          </a:p>
+          <a:p>
+            <a:pPr>
+              <a:spcAft>
+                <a:spcPts val="1100"/>
+              </a:spcAft>
+              <a:defRPr sz="1800" b="0">
+                <a:solidFill>
+                  <a:srgbClr val="0B253F"/>
+                </a:solidFill>
+                <a:latin typeface="Arial"/>
+              </a:defRPr>
+            </a:pPr>
+            <a:r>
+              <a:t>• O atendimento automático encerra após um minuto de inatividade.</a:t>
+            </a:r>
+          </a:p>
+        </p:txBody>
+      </p:sp>
+      <p:sp>
+        <p:nvSpPr>
+          <p:cNvPr id="9" name="TextBox 8"/>
+          <p:cNvSpPr txBox="1"/>
+          <p:nvPr/>
+        </p:nvSpPr>
+        <p:spPr>
+          <a:xfrm>
+            <a:off x="594360" y="6217920"/>
+            <a:ext cx="10972800" cy="411480"/>
+          </a:xfrm>
+          <a:prstGeom prst="rect">
+            <a:avLst/>
+          </a:prstGeom>
+          <a:noFill/>
+        </p:spPr>
+        <p:txBody>
+          <a:bodyPr wrap="square" lIns="18288" rIns="18288" tIns="18288" bIns="18288">
+            <a:spAutoFit/>
+          </a:bodyPr>
+          <a:lstStyle/>
+          <a:p>
+            <a:pPr>
+              <a:spcAft>
+                <a:spcPts val="1100"/>
+              </a:spcAft>
+              <a:defRPr sz="1100" b="0">
+                <a:solidFill>
+                  <a:srgbClr val="577084"/>
+                </a:solidFill>
+                <a:latin typeface="Arial"/>
+              </a:defRPr>
+            </a:pPr>
+            <a:r>
+              <a:t>A consulta utiliza o telefone vinculado à reserva.</a:t>
+            </a:r>
+          </a:p>
+        </p:txBody>
+      </p:sp>
+    </p:spTree>
+  </p:cSld>
+  <p:clrMapOvr>
+    <a:masterClrMapping/>
+  </p:clrMapOvr>
+</p:sld>
+</file>
+
+<file path=ppt/slides/slide21.xml><?xml version="1.0" encoding="utf-8"?>
+<p:sld xmlns:a="http://schemas.openxmlformats.org/drawingml/2006/main" xmlns:p="http://schemas.openxmlformats.org/presentationml/2006/main" xmlns:r="http://schemas.openxmlformats.org/officeDocument/2006/relationships">
+  <p:cSld>
+    <p:bg>
+      <p:bgPr>
+        <a:solidFill>
+          <a:srgbClr val="F4F7FA"/>
+        </a:solidFill>
+        <a:effectLst/>
+      </p:bgPr>
+    </p:bg>
+    <p:spTree>
+      <p:nvGrpSpPr>
+        <p:cNvPr id="1" name=""/>
+        <p:cNvGrpSpPr/>
+        <p:nvPr/>
+      </p:nvGrpSpPr>
+      <p:grpSpPr/>
+      <p:sp>
+        <p:nvSpPr>
+          <p:cNvPr id="2" name="Rectangle 1"/>
+          <p:cNvSpPr/>
+          <p:nvPr/>
+        </p:nvSpPr>
+        <p:spPr>
+          <a:xfrm>
+            <a:off x="0" y="0"/>
+            <a:ext cx="109728" cy="6858000"/>
+          </a:xfrm>
+          <a:prstGeom prst="rect">
+            <a:avLst/>
+          </a:prstGeom>
+          <a:solidFill>
+            <a:srgbClr val="0C7A76"/>
+          </a:solidFill>
+          <a:ln>
+            <a:noFill/>
+          </a:ln>
+        </p:spPr>
+        <p:style>
+          <a:lnRef idx="1">
+            <a:schemeClr val="accent1"/>
+          </a:lnRef>
+          <a:fillRef idx="3">
+            <a:schemeClr val="accent1"/>
+          </a:fillRef>
+          <a:effectRef idx="2">
+            <a:schemeClr val="accent1"/>
+          </a:effectRef>
+          <a:fontRef idx="minor">
+            <a:schemeClr val="lt1"/>
+          </a:fontRef>
+        </p:style>
+        <p:txBody>
+          <a:bodyPr rtlCol="0" anchor="ctr"/>
+          <a:lstStyle/>
+          <a:p>
+            <a:pPr algn="ctr"/>
+          </a:p>
+        </p:txBody>
+      </p:sp>
+      <p:sp>
+        <p:nvSpPr>
+          <p:cNvPr id="3" name="TextBox 2"/>
+          <p:cNvSpPr txBox="1"/>
+          <p:nvPr/>
+        </p:nvSpPr>
+        <p:spPr>
+          <a:xfrm>
+            <a:off x="594360" y="320040"/>
+            <a:ext cx="2743200" cy="365760"/>
+          </a:xfrm>
+          <a:prstGeom prst="rect">
+            <a:avLst/>
+          </a:prstGeom>
+          <a:noFill/>
+        </p:spPr>
+        <p:txBody>
+          <a:bodyPr wrap="square" lIns="18288" rIns="18288" tIns="18288" bIns="18288">
+            <a:spAutoFit/>
+          </a:bodyPr>
+          <a:lstStyle/>
+          <a:p>
+            <a:pPr>
+              <a:spcAft>
+                <a:spcPts val="1100"/>
+              </a:spcAft>
+              <a:defRPr sz="1800" b="1">
+                <a:solidFill>
+                  <a:srgbClr val="0B253F"/>
+                </a:solidFill>
+                <a:latin typeface="Arial"/>
+              </a:defRPr>
+            </a:pPr>
+            <a:r>
+              <a:t>rotafy.  /  NEXUS</a:t>
+            </a:r>
+          </a:p>
+        </p:txBody>
+      </p:sp>
+      <p:sp>
+        <p:nvSpPr>
+          <p:cNvPr id="4" name="TextBox 3"/>
+          <p:cNvSpPr txBox="1"/>
+          <p:nvPr/>
+        </p:nvSpPr>
+        <p:spPr>
+          <a:xfrm>
+            <a:off x="10424160" y="365760"/>
+            <a:ext cx="1188720" cy="320040"/>
+          </a:xfrm>
+          <a:prstGeom prst="rect">
+            <a:avLst/>
+          </a:prstGeom>
+          <a:noFill/>
+        </p:spPr>
+        <p:txBody>
+          <a:bodyPr wrap="square" lIns="18288" rIns="18288" tIns="18288" bIns="18288">
+            <a:spAutoFit/>
+          </a:bodyPr>
+          <a:lstStyle/>
+          <a:p>
+            <a:pPr>
+              <a:spcAft>
+                <a:spcPts val="1100"/>
+              </a:spcAft>
+              <a:defRPr sz="1200" b="0">
+                <a:solidFill>
+                  <a:srgbClr val="0B253F"/>
+                </a:solidFill>
+                <a:latin typeface="Arial"/>
+              </a:defRPr>
+            </a:pPr>
+            <a:r>
+              <a:t>21 / 25</a:t>
+            </a:r>
+          </a:p>
+        </p:txBody>
+      </p:sp>
+      <p:sp>
+        <p:nvSpPr>
+          <p:cNvPr id="5" name="TextBox 4"/>
+          <p:cNvSpPr txBox="1"/>
+          <p:nvPr/>
+        </p:nvSpPr>
+        <p:spPr>
+          <a:xfrm>
+            <a:off x="594360" y="914400"/>
+            <a:ext cx="10789920" cy="365760"/>
+          </a:xfrm>
+          <a:prstGeom prst="rect">
+            <a:avLst/>
+          </a:prstGeom>
+          <a:noFill/>
+        </p:spPr>
+        <p:txBody>
+          <a:bodyPr wrap="square" lIns="18288" rIns="18288" tIns="18288" bIns="18288">
+            <a:spAutoFit/>
+          </a:bodyPr>
+          <a:lstStyle/>
+          <a:p>
+            <a:pPr>
+              <a:spcAft>
+                <a:spcPts val="1100"/>
+              </a:spcAft>
+              <a:defRPr sz="1100" b="1">
+                <a:solidFill>
+                  <a:srgbClr val="0C7A76"/>
+                </a:solidFill>
+                <a:latin typeface="Arial"/>
+              </a:defRPr>
+            </a:pPr>
+            <a:r>
+              <a:t>BILHETE NA HORA DE VIAJAR</a:t>
+            </a:r>
+          </a:p>
+        </p:txBody>
+      </p:sp>
+      <p:sp>
+        <p:nvSpPr>
+          <p:cNvPr id="6" name="TextBox 5"/>
+          <p:cNvSpPr txBox="1"/>
+          <p:nvPr/>
+        </p:nvSpPr>
+        <p:spPr>
+          <a:xfrm>
+            <a:off x="594360" y="1389888"/>
+            <a:ext cx="10789920" cy="1170432"/>
+          </a:xfrm>
+          <a:prstGeom prst="rect">
+            <a:avLst/>
+          </a:prstGeom>
+          <a:noFill/>
+        </p:spPr>
+        <p:txBody>
+          <a:bodyPr wrap="square" lIns="18288" rIns="18288" tIns="18288" bIns="18288">
+            <a:spAutoFit/>
+          </a:bodyPr>
+          <a:lstStyle/>
+          <a:p>
+            <a:pPr>
+              <a:spcAft>
+                <a:spcPts val="1100"/>
+              </a:spcAft>
+              <a:defRPr sz="3600" b="1">
+                <a:solidFill>
+                  <a:srgbClr val="0B253F"/>
+                </a:solidFill>
+                <a:latin typeface="Arial"/>
+              </a:defRPr>
+            </a:pPr>
+            <a:r>
+              <a:t>Envio antecipado,</a:t>
+            </a:r>
+          </a:p>
+          <a:p>
+            <a:pPr>
+              <a:spcAft>
+                <a:spcPts val="1100"/>
+              </a:spcAft>
+              <a:defRPr sz="3600" b="1">
+                <a:solidFill>
+                  <a:srgbClr val="0B253F"/>
+                </a:solidFill>
+                <a:latin typeface="Arial"/>
+              </a:defRPr>
+            </a:pPr>
+            <a:r>
+              <a:t>com acompanhamento.</a:t>
+            </a:r>
+          </a:p>
+        </p:txBody>
+      </p:sp>
+      <p:sp>
+        <p:nvSpPr>
+          <p:cNvPr id="7" name="TextBox 6"/>
+          <p:cNvSpPr txBox="1"/>
+          <p:nvPr/>
+        </p:nvSpPr>
+        <p:spPr>
+          <a:xfrm>
+            <a:off x="594360" y="2651760"/>
+            <a:ext cx="10789920" cy="658368"/>
+          </a:xfrm>
+          <a:prstGeom prst="rect">
+            <a:avLst/>
+          </a:prstGeom>
+          <a:noFill/>
+        </p:spPr>
+        <p:txBody>
+          <a:bodyPr wrap="square" lIns="18288" rIns="18288" tIns="18288" bIns="18288">
+            <a:spAutoFit/>
+          </a:bodyPr>
+          <a:lstStyle/>
+          <a:p>
+            <a:pPr>
+              <a:spcAft>
+                <a:spcPts val="1100"/>
+              </a:spcAft>
+              <a:defRPr sz="2000" b="0">
+                <a:solidFill>
+                  <a:srgbClr val="577084"/>
+                </a:solidFill>
+                <a:latin typeface="Arial"/>
+              </a:defRPr>
+            </a:pPr>
+            <a:r>
+              <a:t>Ative o envio automático antes do primeiro embarque.</a:t>
+            </a:r>
+          </a:p>
+        </p:txBody>
+      </p:sp>
+      <p:sp>
+        <p:nvSpPr>
+          <p:cNvPr id="8" name="TextBox 7"/>
+          <p:cNvSpPr txBox="1"/>
+          <p:nvPr/>
+        </p:nvSpPr>
+        <p:spPr>
+          <a:xfrm>
+            <a:off x="640080" y="3520440"/>
+            <a:ext cx="10789920" cy="2194560"/>
+          </a:xfrm>
+          <a:prstGeom prst="rect">
+            <a:avLst/>
+          </a:prstGeom>
+          <a:noFill/>
+        </p:spPr>
+        <p:txBody>
+          <a:bodyPr wrap="square" lIns="18288" rIns="18288" tIns="18288" bIns="18288">
+            <a:spAutoFit/>
+          </a:bodyPr>
+          <a:lstStyle/>
+          <a:p>
+            <a:pPr>
+              <a:spcAft>
+                <a:spcPts val="1100"/>
+              </a:spcAft>
+              <a:defRPr sz="1800" b="0">
+                <a:solidFill>
+                  <a:srgbClr val="0B253F"/>
+                </a:solidFill>
+                <a:latin typeface="Arial"/>
+              </a:defRPr>
+            </a:pPr>
+            <a:r>
+              <a:t>• Reservas confirmadas entram na fila até 24 horas antes.</a:t>
+            </a:r>
+          </a:p>
+          <a:p>
+            <a:pPr>
+              <a:spcAft>
+                <a:spcPts val="1100"/>
+              </a:spcAft>
+              <a:defRPr sz="1800" b="0">
+                <a:solidFill>
+                  <a:srgbClr val="0B253F"/>
+                </a:solidFill>
+                <a:latin typeface="Arial"/>
+              </a:defRPr>
+            </a:pPr>
+            <a:r>
+              <a:t>• Um bilhete por passageiro, válido para todos os trechos contratados.</a:t>
+            </a:r>
+          </a:p>
+          <a:p>
+            <a:pPr>
+              <a:spcAft>
+                <a:spcPts val="1100"/>
+              </a:spcAft>
+              <a:defRPr sz="1800" b="0">
+                <a:solidFill>
+                  <a:srgbClr val="0B253F"/>
+                </a:solidFill>
+                <a:latin typeface="Arial"/>
+              </a:defRPr>
+            </a:pPr>
+            <a:r>
+              <a:t>• Intervalo mínimo de três minutos entre os envios automáticos.</a:t>
+            </a:r>
+          </a:p>
+          <a:p>
+            <a:pPr>
+              <a:spcAft>
+                <a:spcPts val="1100"/>
+              </a:spcAft>
+              <a:defRPr sz="1800" b="0">
+                <a:solidFill>
+                  <a:srgbClr val="0B253F"/>
+                </a:solidFill>
+                <a:latin typeface="Arial"/>
+              </a:defRPr>
+            </a:pPr>
+            <a:r>
+              <a:t>• O envio manual permanece disponível para o atendimento.</a:t>
+            </a:r>
+          </a:p>
+        </p:txBody>
+      </p:sp>
+      <p:sp>
+        <p:nvSpPr>
+          <p:cNvPr id="9" name="TextBox 8"/>
+          <p:cNvSpPr txBox="1"/>
+          <p:nvPr/>
+        </p:nvSpPr>
+        <p:spPr>
+          <a:xfrm>
+            <a:off x="594360" y="6217920"/>
+            <a:ext cx="10972800" cy="411480"/>
+          </a:xfrm>
+          <a:prstGeom prst="rect">
+            <a:avLst/>
+          </a:prstGeom>
+          <a:noFill/>
+        </p:spPr>
+        <p:txBody>
+          <a:bodyPr wrap="square" lIns="18288" rIns="18288" tIns="18288" bIns="18288">
+            <a:spAutoFit/>
+          </a:bodyPr>
+          <a:lstStyle/>
+          <a:p>
+            <a:pPr>
+              <a:spcAft>
+                <a:spcPts val="1100"/>
+              </a:spcAft>
+              <a:defRPr sz="1100" b="0">
+                <a:solidFill>
+                  <a:srgbClr val="577084"/>
+                </a:solidFill>
+                <a:latin typeface="Arial"/>
+              </a:defRPr>
+            </a:pPr>
+            <a:r>
+              <a:t>A entrada na fila não garante o horário exato de entrega; acompanhe os envios.</a:t>
+            </a:r>
+          </a:p>
+        </p:txBody>
+      </p:sp>
+    </p:spTree>
+  </p:cSld>
+  <p:clrMapOvr>
+    <a:masterClrMapping/>
+  </p:clrMapOvr>
+</p:sld>
+</file>
+
+<file path=ppt/slides/slide22.xml><?xml version="1.0" encoding="utf-8"?>
+<p:sld xmlns:a="http://schemas.openxmlformats.org/drawingml/2006/main" xmlns:p="http://schemas.openxmlformats.org/presentationml/2006/main" xmlns:r="http://schemas.openxmlformats.org/officeDocument/2006/relationships">
+  <p:cSld>
+    <p:bg>
+      <p:bgPr>
+        <a:solidFill>
+          <a:srgbClr val="F4F7FA"/>
+        </a:solidFill>
+        <a:effectLst/>
+      </p:bgPr>
+    </p:bg>
+    <p:spTree>
+      <p:nvGrpSpPr>
+        <p:cNvPr id="1" name=""/>
+        <p:cNvGrpSpPr/>
+        <p:nvPr/>
+      </p:nvGrpSpPr>
+      <p:grpSpPr/>
+      <p:sp>
+        <p:nvSpPr>
+          <p:cNvPr id="2" name="Rectangle 1"/>
+          <p:cNvSpPr/>
+          <p:nvPr/>
+        </p:nvSpPr>
+        <p:spPr>
+          <a:xfrm>
+            <a:off x="0" y="0"/>
+            <a:ext cx="109728" cy="6858000"/>
+          </a:xfrm>
+          <a:prstGeom prst="rect">
+            <a:avLst/>
+          </a:prstGeom>
+          <a:solidFill>
+            <a:srgbClr val="0C7A76"/>
+          </a:solidFill>
+          <a:ln>
+            <a:noFill/>
+          </a:ln>
+        </p:spPr>
+        <p:style>
+          <a:lnRef idx="1">
+            <a:schemeClr val="accent1"/>
+          </a:lnRef>
+          <a:fillRef idx="3">
+            <a:schemeClr val="accent1"/>
+          </a:fillRef>
+          <a:effectRef idx="2">
+            <a:schemeClr val="accent1"/>
+          </a:effectRef>
+          <a:fontRef idx="minor">
+            <a:schemeClr val="lt1"/>
+          </a:fontRef>
+        </p:style>
+        <p:txBody>
+          <a:bodyPr rtlCol="0" anchor="ctr"/>
+          <a:lstStyle/>
+          <a:p>
+            <a:pPr algn="ctr"/>
+          </a:p>
+        </p:txBody>
+      </p:sp>
+      <p:sp>
+        <p:nvSpPr>
+          <p:cNvPr id="3" name="TextBox 2"/>
+          <p:cNvSpPr txBox="1"/>
+          <p:nvPr/>
+        </p:nvSpPr>
+        <p:spPr>
+          <a:xfrm>
+            <a:off x="594360" y="320040"/>
+            <a:ext cx="2743200" cy="365760"/>
+          </a:xfrm>
+          <a:prstGeom prst="rect">
+            <a:avLst/>
+          </a:prstGeom>
+          <a:noFill/>
+        </p:spPr>
+        <p:txBody>
+          <a:bodyPr wrap="square" lIns="18288" rIns="18288" tIns="18288" bIns="18288">
+            <a:spAutoFit/>
+          </a:bodyPr>
+          <a:lstStyle/>
+          <a:p>
+            <a:pPr>
+              <a:spcAft>
+                <a:spcPts val="1100"/>
+              </a:spcAft>
+              <a:defRPr sz="1800" b="1">
+                <a:solidFill>
+                  <a:srgbClr val="0B253F"/>
+                </a:solidFill>
+                <a:latin typeface="Arial"/>
+              </a:defRPr>
+            </a:pPr>
+            <a:r>
+              <a:t>rotafy.  /  NEXUS</a:t>
+            </a:r>
+          </a:p>
+        </p:txBody>
+      </p:sp>
+      <p:sp>
+        <p:nvSpPr>
+          <p:cNvPr id="4" name="TextBox 3"/>
+          <p:cNvSpPr txBox="1"/>
+          <p:nvPr/>
+        </p:nvSpPr>
+        <p:spPr>
+          <a:xfrm>
+            <a:off x="10424160" y="365760"/>
+            <a:ext cx="1188720" cy="320040"/>
+          </a:xfrm>
+          <a:prstGeom prst="rect">
+            <a:avLst/>
+          </a:prstGeom>
+          <a:noFill/>
+        </p:spPr>
+        <p:txBody>
+          <a:bodyPr wrap="square" lIns="18288" rIns="18288" tIns="18288" bIns="18288">
+            <a:spAutoFit/>
+          </a:bodyPr>
+          <a:lstStyle/>
+          <a:p>
+            <a:pPr>
+              <a:spcAft>
+                <a:spcPts val="1100"/>
+              </a:spcAft>
+              <a:defRPr sz="1200" b="0">
+                <a:solidFill>
+                  <a:srgbClr val="0B253F"/>
+                </a:solidFill>
+                <a:latin typeface="Arial"/>
+              </a:defRPr>
+            </a:pPr>
+            <a:r>
+              <a:t>22 / 25</a:t>
+            </a:r>
+          </a:p>
+        </p:txBody>
+      </p:sp>
+      <p:sp>
+        <p:nvSpPr>
+          <p:cNvPr id="5" name="TextBox 4"/>
+          <p:cNvSpPr txBox="1"/>
+          <p:nvPr/>
+        </p:nvSpPr>
+        <p:spPr>
+          <a:xfrm>
+            <a:off x="594360" y="914400"/>
+            <a:ext cx="10789920" cy="365760"/>
+          </a:xfrm>
+          <a:prstGeom prst="rect">
+            <a:avLst/>
+          </a:prstGeom>
+          <a:noFill/>
+        </p:spPr>
+        <p:txBody>
+          <a:bodyPr wrap="square" lIns="18288" rIns="18288" tIns="18288" bIns="18288">
+            <a:spAutoFit/>
+          </a:bodyPr>
+          <a:lstStyle/>
+          <a:p>
+            <a:pPr>
+              <a:spcAft>
+                <a:spcPts val="1100"/>
+              </a:spcAft>
+              <a:defRPr sz="1100" b="1">
+                <a:solidFill>
+                  <a:srgbClr val="0C7A76"/>
+                </a:solidFill>
+                <a:latin typeface="Arial"/>
+              </a:defRPr>
+            </a:pPr>
+            <a:r>
+              <a:t>VISIBILIDADE DA OPERAÇÃO</a:t>
+            </a:r>
+          </a:p>
+        </p:txBody>
+      </p:sp>
+      <p:sp>
+        <p:nvSpPr>
+          <p:cNvPr id="6" name="TextBox 5"/>
+          <p:cNvSpPr txBox="1"/>
+          <p:nvPr/>
+        </p:nvSpPr>
+        <p:spPr>
+          <a:xfrm>
+            <a:off x="594360" y="1389888"/>
+            <a:ext cx="10789920" cy="1170432"/>
+          </a:xfrm>
+          <a:prstGeom prst="rect">
+            <a:avLst/>
+          </a:prstGeom>
+          <a:noFill/>
+        </p:spPr>
+        <p:txBody>
+          <a:bodyPr wrap="square" lIns="18288" rIns="18288" tIns="18288" bIns="18288">
+            <a:spAutoFit/>
+          </a:bodyPr>
+          <a:lstStyle/>
+          <a:p>
+            <a:pPr>
+              <a:spcAft>
+                <a:spcPts val="1100"/>
+              </a:spcAft>
+              <a:defRPr sz="3600" b="1">
+                <a:solidFill>
+                  <a:srgbClr val="0B253F"/>
+                </a:solidFill>
+                <a:latin typeface="Arial"/>
+              </a:defRPr>
+            </a:pPr>
+            <a:r>
+              <a:t>Acompanhe o veículo.</a:t>
+            </a:r>
+          </a:p>
+          <a:p>
+            <a:pPr>
+              <a:spcAft>
+                <a:spcPts val="1100"/>
+              </a:spcAft>
+              <a:defRPr sz="3600" b="1">
+                <a:solidFill>
+                  <a:srgbClr val="0B253F"/>
+                </a:solidFill>
+                <a:latin typeface="Arial"/>
+              </a:defRPr>
+            </a:pPr>
+            <a:r>
+              <a:t>Oriente o passageiro.</a:t>
+            </a:r>
+          </a:p>
+        </p:txBody>
+      </p:sp>
+      <p:sp>
+        <p:nvSpPr>
+          <p:cNvPr id="7" name="TextBox 6"/>
+          <p:cNvSpPr txBox="1"/>
+          <p:nvPr/>
+        </p:nvSpPr>
+        <p:spPr>
+          <a:xfrm>
+            <a:off x="594360" y="2651760"/>
+            <a:ext cx="10789920" cy="658368"/>
+          </a:xfrm>
+          <a:prstGeom prst="rect">
+            <a:avLst/>
+          </a:prstGeom>
+          <a:noFill/>
+        </p:spPr>
+        <p:txBody>
+          <a:bodyPr wrap="square" lIns="18288" rIns="18288" tIns="18288" bIns="18288">
+            <a:spAutoFit/>
+          </a:bodyPr>
+          <a:lstStyle/>
+          <a:p>
+            <a:pPr>
+              <a:spcAft>
+                <a:spcPts val="1100"/>
+              </a:spcAft>
+              <a:defRPr sz="2000" b="0">
+                <a:solidFill>
+                  <a:srgbClr val="577084"/>
+                </a:solidFill>
+                <a:latin typeface="Arial"/>
+              </a:defRPr>
+            </a:pPr>
+            <a:r>
+              <a:t>Rastreamento e avisos configuráveis pela empresa.</a:t>
+            </a:r>
+          </a:p>
+        </p:txBody>
+      </p:sp>
+      <p:sp>
+        <p:nvSpPr>
+          <p:cNvPr id="8" name="TextBox 7"/>
+          <p:cNvSpPr txBox="1"/>
+          <p:nvPr/>
+        </p:nvSpPr>
+        <p:spPr>
+          <a:xfrm>
+            <a:off x="640080" y="3520440"/>
+            <a:ext cx="10789920" cy="2194560"/>
+          </a:xfrm>
+          <a:prstGeom prst="rect">
+            <a:avLst/>
+          </a:prstGeom>
+          <a:noFill/>
+        </p:spPr>
+        <p:txBody>
+          <a:bodyPr wrap="square" lIns="18288" rIns="18288" tIns="18288" bIns="18288">
+            <a:spAutoFit/>
+          </a:bodyPr>
+          <a:lstStyle/>
+          <a:p>
+            <a:pPr>
+              <a:spcAft>
+                <a:spcPts val="1100"/>
+              </a:spcAft>
+              <a:defRPr sz="1800" b="0">
+                <a:solidFill>
+                  <a:srgbClr val="0B253F"/>
+                </a:solidFill>
+                <a:latin typeface="Arial"/>
+              </a:defRPr>
+            </a:pPr>
+            <a:r>
+              <a:t>• Posições do celular responsável coletadas a cada cinco minutos.</a:t>
+            </a:r>
+          </a:p>
+          <a:p>
+            <a:pPr>
+              <a:spcAft>
+                <a:spcPts val="1100"/>
+              </a:spcAft>
+              <a:defRPr sz="1800" b="0">
+                <a:solidFill>
+                  <a:srgbClr val="0B253F"/>
+                </a:solidFill>
+                <a:latin typeface="Arial"/>
+              </a:defRPr>
+            </a:pPr>
+            <a:r>
+              <a:t>• Mapa com última posição e trilha das amostras durante o trecho.</a:t>
+            </a:r>
+          </a:p>
+          <a:p>
+            <a:pPr>
+              <a:spcAft>
+                <a:spcPts val="1100"/>
+              </a:spcAft>
+              <a:defRPr sz="1800" b="0">
+                <a:solidFill>
+                  <a:srgbClr val="0B253F"/>
+                </a:solidFill>
+                <a:latin typeface="Arial"/>
+              </a:defRPr>
+            </a:pPr>
+            <a:r>
+              <a:t>• Aviso de proximidade para embarques confirmados no mapa.</a:t>
+            </a:r>
+          </a:p>
+          <a:p>
+            <a:pPr>
+              <a:spcAft>
+                <a:spcPts val="1100"/>
+              </a:spcAft>
+              <a:defRPr sz="1800" b="0">
+                <a:solidFill>
+                  <a:srgbClr val="0B253F"/>
+                </a:solidFill>
+                <a:latin typeface="Arial"/>
+              </a:defRPr>
+            </a:pPr>
+            <a:r>
+              <a:t>• Lembrete de saída na ida e na volta pelo WhatsApp.</a:t>
+            </a:r>
+          </a:p>
+        </p:txBody>
+      </p:sp>
+      <p:sp>
+        <p:nvSpPr>
+          <p:cNvPr id="9" name="TextBox 8"/>
+          <p:cNvSpPr txBox="1"/>
+          <p:nvPr/>
+        </p:nvSpPr>
+        <p:spPr>
+          <a:xfrm>
+            <a:off x="594360" y="6217920"/>
+            <a:ext cx="10972800" cy="411480"/>
+          </a:xfrm>
+          <a:prstGeom prst="rect">
+            <a:avLst/>
+          </a:prstGeom>
+          <a:noFill/>
+        </p:spPr>
+        <p:txBody>
+          <a:bodyPr wrap="square" lIns="18288" rIns="18288" tIns="18288" bIns="18288">
+            <a:spAutoFit/>
+          </a:bodyPr>
+          <a:lstStyle/>
+          <a:p>
+            <a:pPr>
+              <a:spcAft>
+                <a:spcPts val="1100"/>
+              </a:spcAft>
+              <a:defRPr sz="1100" b="0">
+                <a:solidFill>
+                  <a:srgbClr val="577084"/>
+                </a:solidFill>
+                <a:latin typeface="Arial"/>
+              </a:defRPr>
+            </a:pPr>
+            <a:r>
+              <a:t>Localização aproximada; depende de conexão, GPS e permissões.</a:t>
+            </a:r>
+          </a:p>
+        </p:txBody>
+      </p:sp>
+    </p:spTree>
+  </p:cSld>
+  <p:clrMapOvr>
+    <a:masterClrMapping/>
+  </p:clrMapOvr>
+</p:sld>
+</file>
+
+<file path=ppt/slides/slide23.xml><?xml version="1.0" encoding="utf-8"?>
+<p:sld xmlns:a="http://schemas.openxmlformats.org/drawingml/2006/main" xmlns:p="http://schemas.openxmlformats.org/presentationml/2006/main" xmlns:r="http://schemas.openxmlformats.org/officeDocument/2006/relationships">
+  <p:cSld>
+    <p:bg>
+      <p:bgPr>
+        <a:solidFill>
+          <a:srgbClr val="F4F7FA"/>
+        </a:solidFill>
+        <a:effectLst/>
+      </p:bgPr>
+    </p:bg>
+    <p:spTree>
+      <p:nvGrpSpPr>
+        <p:cNvPr id="1" name=""/>
+        <p:cNvGrpSpPr/>
+        <p:nvPr/>
+      </p:nvGrpSpPr>
+      <p:grpSpPr/>
+      <p:sp>
+        <p:nvSpPr>
+          <p:cNvPr id="2" name="Rectangle 1"/>
+          <p:cNvSpPr/>
+          <p:nvPr/>
+        </p:nvSpPr>
+        <p:spPr>
+          <a:xfrm>
+            <a:off x="0" y="0"/>
+            <a:ext cx="109728" cy="6858000"/>
+          </a:xfrm>
+          <a:prstGeom prst="rect">
+            <a:avLst/>
+          </a:prstGeom>
+          <a:solidFill>
+            <a:srgbClr val="0C7A76"/>
+          </a:solidFill>
+          <a:ln>
+            <a:noFill/>
+          </a:ln>
+        </p:spPr>
+        <p:style>
+          <a:lnRef idx="1">
+            <a:schemeClr val="accent1"/>
+          </a:lnRef>
+          <a:fillRef idx="3">
+            <a:schemeClr val="accent1"/>
+          </a:fillRef>
+          <a:effectRef idx="2">
+            <a:schemeClr val="accent1"/>
+          </a:effectRef>
+          <a:fontRef idx="minor">
+            <a:schemeClr val="lt1"/>
+          </a:fontRef>
+        </p:style>
+        <p:txBody>
+          <a:bodyPr rtlCol="0" anchor="ctr"/>
+          <a:lstStyle/>
+          <a:p>
+            <a:pPr algn="ctr"/>
+          </a:p>
+        </p:txBody>
+      </p:sp>
+      <p:sp>
+        <p:nvSpPr>
+          <p:cNvPr id="3" name="TextBox 2"/>
+          <p:cNvSpPr txBox="1"/>
+          <p:nvPr/>
+        </p:nvSpPr>
+        <p:spPr>
+          <a:xfrm>
+            <a:off x="594360" y="320040"/>
+            <a:ext cx="2743200" cy="365760"/>
+          </a:xfrm>
+          <a:prstGeom prst="rect">
+            <a:avLst/>
+          </a:prstGeom>
+          <a:noFill/>
+        </p:spPr>
+        <p:txBody>
+          <a:bodyPr wrap="square" lIns="18288" rIns="18288" tIns="18288" bIns="18288">
+            <a:spAutoFit/>
+          </a:bodyPr>
+          <a:lstStyle/>
+          <a:p>
+            <a:pPr>
+              <a:spcAft>
+                <a:spcPts val="1100"/>
+              </a:spcAft>
+              <a:defRPr sz="1800" b="1">
+                <a:solidFill>
+                  <a:srgbClr val="0B253F"/>
+                </a:solidFill>
+                <a:latin typeface="Arial"/>
+              </a:defRPr>
+            </a:pPr>
+            <a:r>
+              <a:t>rotafy.  /  NEXUS</a:t>
+            </a:r>
+          </a:p>
+        </p:txBody>
+      </p:sp>
+      <p:sp>
+        <p:nvSpPr>
+          <p:cNvPr id="4" name="TextBox 3"/>
+          <p:cNvSpPr txBox="1"/>
+          <p:nvPr/>
+        </p:nvSpPr>
+        <p:spPr>
+          <a:xfrm>
+            <a:off x="10424160" y="365760"/>
+            <a:ext cx="1188720" cy="320040"/>
+          </a:xfrm>
+          <a:prstGeom prst="rect">
+            <a:avLst/>
+          </a:prstGeom>
+          <a:noFill/>
+        </p:spPr>
+        <p:txBody>
+          <a:bodyPr wrap="square" lIns="18288" rIns="18288" tIns="18288" bIns="18288">
+            <a:spAutoFit/>
+          </a:bodyPr>
+          <a:lstStyle/>
+          <a:p>
+            <a:pPr>
+              <a:spcAft>
+                <a:spcPts val="1100"/>
+              </a:spcAft>
+              <a:defRPr sz="1200" b="0">
+                <a:solidFill>
+                  <a:srgbClr val="0B253F"/>
+                </a:solidFill>
+                <a:latin typeface="Arial"/>
+              </a:defRPr>
+            </a:pPr>
+            <a:r>
+              <a:t>23 / 25</a:t>
+            </a:r>
+          </a:p>
+        </p:txBody>
+      </p:sp>
+      <p:sp>
+        <p:nvSpPr>
+          <p:cNvPr id="5" name="TextBox 4"/>
+          <p:cNvSpPr txBox="1"/>
+          <p:nvPr/>
+        </p:nvSpPr>
+        <p:spPr>
+          <a:xfrm>
+            <a:off x="594360" y="914400"/>
+            <a:ext cx="10789920" cy="365760"/>
+          </a:xfrm>
+          <a:prstGeom prst="rect">
+            <a:avLst/>
+          </a:prstGeom>
+          <a:noFill/>
+        </p:spPr>
+        <p:txBody>
+          <a:bodyPr wrap="square" lIns="18288" rIns="18288" tIns="18288" bIns="18288">
+            <a:spAutoFit/>
+          </a:bodyPr>
+          <a:lstStyle/>
+          <a:p>
+            <a:pPr>
+              <a:spcAft>
+                <a:spcPts val="1100"/>
+              </a:spcAft>
+              <a:defRPr sz="1100" b="1">
+                <a:solidFill>
+                  <a:srgbClr val="0C7A76"/>
+                </a:solidFill>
+                <a:latin typeface="Arial"/>
+              </a:defRPr>
+            </a:pPr>
+            <a:r>
+              <a:t>GESTÃO DA ASSINATURA</a:t>
+            </a:r>
+          </a:p>
+        </p:txBody>
+      </p:sp>
+      <p:sp>
+        <p:nvSpPr>
+          <p:cNvPr id="6" name="TextBox 5"/>
+          <p:cNvSpPr txBox="1"/>
+          <p:nvPr/>
+        </p:nvSpPr>
+        <p:spPr>
+          <a:xfrm>
+            <a:off x="594360" y="1389888"/>
+            <a:ext cx="10789920" cy="1170432"/>
+          </a:xfrm>
+          <a:prstGeom prst="rect">
+            <a:avLst/>
+          </a:prstGeom>
+          <a:noFill/>
+        </p:spPr>
+        <p:txBody>
+          <a:bodyPr wrap="square" lIns="18288" rIns="18288" tIns="18288" bIns="18288">
+            <a:spAutoFit/>
+          </a:bodyPr>
+          <a:lstStyle/>
+          <a:p>
+            <a:pPr>
+              <a:spcAft>
+                <a:spcPts val="1100"/>
+              </a:spcAft>
+              <a:defRPr sz="3600" b="1">
+                <a:solidFill>
+                  <a:srgbClr val="0B253F"/>
+                </a:solidFill>
+                <a:latin typeface="Arial"/>
+              </a:defRPr>
+            </a:pPr>
+            <a:r>
+              <a:t>Condições claras,</a:t>
+            </a:r>
+          </a:p>
+          <a:p>
+            <a:pPr>
+              <a:spcAft>
+                <a:spcPts val="1100"/>
+              </a:spcAft>
+              <a:defRPr sz="3600" b="1">
+                <a:solidFill>
+                  <a:srgbClr val="0B253F"/>
+                </a:solidFill>
+                <a:latin typeface="Arial"/>
+              </a:defRPr>
+            </a:pPr>
+            <a:r>
+              <a:t>pagamento acompanhado.</a:t>
+            </a:r>
+          </a:p>
+        </p:txBody>
+      </p:sp>
+      <p:sp>
+        <p:nvSpPr>
+          <p:cNvPr id="7" name="TextBox 6"/>
+          <p:cNvSpPr txBox="1"/>
+          <p:nvPr/>
+        </p:nvSpPr>
+        <p:spPr>
+          <a:xfrm>
+            <a:off x="594360" y="2651760"/>
+            <a:ext cx="10789920" cy="658368"/>
+          </a:xfrm>
+          <a:prstGeom prst="rect">
+            <a:avLst/>
+          </a:prstGeom>
+          <a:noFill/>
+        </p:spPr>
+        <p:txBody>
+          <a:bodyPr wrap="square" lIns="18288" rIns="18288" tIns="18288" bIns="18288">
+            <a:spAutoFit/>
+          </a:bodyPr>
+          <a:lstStyle/>
+          <a:p>
+            <a:pPr>
+              <a:spcAft>
+                <a:spcPts val="1100"/>
+              </a:spcAft>
+              <a:defRPr sz="2000" b="0">
+                <a:solidFill>
+                  <a:srgbClr val="577084"/>
+                </a:solidFill>
+                <a:latin typeface="Arial"/>
+              </a:defRPr>
+            </a:pPr>
+            <a:r>
+              <a:t>Contrato, valores e vencimentos no mesmo ambiente.</a:t>
+            </a:r>
+          </a:p>
+        </p:txBody>
+      </p:sp>
+      <p:sp>
+        <p:nvSpPr>
+          <p:cNvPr id="8" name="TextBox 7"/>
+          <p:cNvSpPr txBox="1"/>
+          <p:nvPr/>
+        </p:nvSpPr>
+        <p:spPr>
+          <a:xfrm>
+            <a:off x="640080" y="3520440"/>
+            <a:ext cx="10789920" cy="2194560"/>
+          </a:xfrm>
+          <a:prstGeom prst="rect">
+            <a:avLst/>
+          </a:prstGeom>
+          <a:noFill/>
+        </p:spPr>
+        <p:txBody>
+          <a:bodyPr wrap="square" lIns="18288" rIns="18288" tIns="18288" bIns="18288">
+            <a:spAutoFit/>
+          </a:bodyPr>
+          <a:lstStyle/>
+          <a:p>
+            <a:pPr>
+              <a:spcAft>
+                <a:spcPts val="1100"/>
+              </a:spcAft>
+              <a:defRPr sz="1800" b="0">
+                <a:solidFill>
+                  <a:srgbClr val="0B253F"/>
+                </a:solidFill>
+                <a:latin typeface="Arial"/>
+              </a:defRPr>
+            </a:pPr>
+            <a:r>
+              <a:t>• Leitura e download do contrato antes do aceite por confirmação de e-mail.</a:t>
+            </a:r>
+          </a:p>
+          <a:p>
+            <a:pPr>
+              <a:spcAft>
+                <a:spcPts val="1100"/>
+              </a:spcAft>
+              <a:defRPr sz="1800" b="0">
+                <a:solidFill>
+                  <a:srgbClr val="0B253F"/>
+                </a:solidFill>
+                <a:latin typeface="Arial"/>
+              </a:defRPr>
+            </a:pPr>
+            <a:r>
+              <a:t>• Plano e valores preservados no documento; mudanças exigem novo aceite.</a:t>
+            </a:r>
+          </a:p>
+          <a:p>
+            <a:pPr>
+              <a:spcAft>
+                <a:spcPts val="1100"/>
+              </a:spcAft>
+              <a:defRPr sz="1800" b="0">
+                <a:solidFill>
+                  <a:srgbClr val="0B253F"/>
+                </a:solidFill>
+                <a:latin typeface="Arial"/>
+              </a:defRPr>
+            </a:pPr>
+            <a:r>
+              <a:t>• Financeiro com valor previsto, próximo vencimento e situação.</a:t>
+            </a:r>
+          </a:p>
+          <a:p>
+            <a:pPr>
+              <a:spcAft>
+                <a:spcPts val="1100"/>
+              </a:spcAft>
+              <a:defRPr sz="1800" b="0">
+                <a:solidFill>
+                  <a:srgbClr val="0B253F"/>
+                </a:solidFill>
+                <a:latin typeface="Arial"/>
+              </a:defRPr>
+            </a:pPr>
+            <a:r>
+              <a:t>• Link de pagamento e confirmação automática após aprovação.</a:t>
+            </a:r>
+          </a:p>
+        </p:txBody>
+      </p:sp>
+      <p:sp>
+        <p:nvSpPr>
+          <p:cNvPr id="9" name="TextBox 8"/>
+          <p:cNvSpPr txBox="1"/>
+          <p:nvPr/>
+        </p:nvSpPr>
+        <p:spPr>
+          <a:xfrm>
+            <a:off x="594360" y="6217920"/>
+            <a:ext cx="10972800" cy="411480"/>
+          </a:xfrm>
+          <a:prstGeom prst="rect">
+            <a:avLst/>
+          </a:prstGeom>
+          <a:noFill/>
+        </p:spPr>
+        <p:txBody>
+          <a:bodyPr wrap="square" lIns="18288" rIns="18288" tIns="18288" bIns="18288">
+            <a:spAutoFit/>
+          </a:bodyPr>
+          <a:lstStyle/>
+          <a:p>
+            <a:pPr>
+              <a:spcAft>
+                <a:spcPts val="1100"/>
+              </a:spcAft>
+              <a:defRPr sz="1100" b="0">
+                <a:solidFill>
+                  <a:srgbClr val="577084"/>
+                </a:solidFill>
+                <a:latin typeface="Arial"/>
+              </a:defRPr>
+            </a:pPr>
+            <a:r>
+              <a:t>O setup é separado; a mensalidade é cobrada ao final do ciclo de 30 dias.</a:t>
+            </a:r>
+          </a:p>
+        </p:txBody>
+      </p:sp>
+    </p:spTree>
+  </p:cSld>
+  <p:clrMapOvr>
+    <a:masterClrMapping/>
+  </p:clrMapOvr>
+</p:sld>
+</file>
+
+<file path=ppt/slides/slide24.xml><?xml version="1.0" encoding="utf-8"?>
+<p:sld xmlns:a="http://schemas.openxmlformats.org/drawingml/2006/main" xmlns:p="http://schemas.openxmlformats.org/presentationml/2006/main" xmlns:r="http://schemas.openxmlformats.org/officeDocument/2006/relationships">
+  <p:cSld>
+    <p:bg>
+      <p:bgPr>
+        <a:solidFill>
+          <a:srgbClr val="F4F7FA"/>
+        </a:solidFill>
+        <a:effectLst/>
+      </p:bgPr>
+    </p:bg>
+    <p:spTree>
+      <p:nvGrpSpPr>
+        <p:cNvPr id="1" name=""/>
+        <p:cNvGrpSpPr/>
+        <p:nvPr/>
+      </p:nvGrpSpPr>
+      <p:grpSpPr/>
+      <p:sp>
+        <p:nvSpPr>
+          <p:cNvPr id="2" name="Rectangle 1"/>
+          <p:cNvSpPr/>
+          <p:nvPr/>
+        </p:nvSpPr>
+        <p:spPr>
+          <a:xfrm>
+            <a:off x="0" y="0"/>
+            <a:ext cx="109728" cy="6858000"/>
+          </a:xfrm>
+          <a:prstGeom prst="rect">
+            <a:avLst/>
+          </a:prstGeom>
+          <a:solidFill>
+            <a:srgbClr val="0C7A76"/>
+          </a:solidFill>
+          <a:ln>
+            <a:noFill/>
+          </a:ln>
+        </p:spPr>
+        <p:style>
+          <a:lnRef idx="1">
+            <a:schemeClr val="accent1"/>
+          </a:lnRef>
+          <a:fillRef idx="3">
+            <a:schemeClr val="accent1"/>
+          </a:fillRef>
+          <a:effectRef idx="2">
+            <a:schemeClr val="accent1"/>
+          </a:effectRef>
+          <a:fontRef idx="minor">
+            <a:schemeClr val="lt1"/>
+          </a:fontRef>
+        </p:style>
+        <p:txBody>
+          <a:bodyPr rtlCol="0" anchor="ctr"/>
+          <a:lstStyle/>
+          <a:p>
+            <a:pPr algn="ctr"/>
+          </a:p>
+        </p:txBody>
+      </p:sp>
+      <p:sp>
+        <p:nvSpPr>
+          <p:cNvPr id="3" name="TextBox 2"/>
+          <p:cNvSpPr txBox="1"/>
+          <p:nvPr/>
+        </p:nvSpPr>
+        <p:spPr>
+          <a:xfrm>
+            <a:off x="594360" y="320040"/>
+            <a:ext cx="2743200" cy="365760"/>
+          </a:xfrm>
+          <a:prstGeom prst="rect">
+            <a:avLst/>
+          </a:prstGeom>
+          <a:noFill/>
+        </p:spPr>
+        <p:txBody>
+          <a:bodyPr wrap="square" lIns="18288" rIns="18288" tIns="18288" bIns="18288">
+            <a:spAutoFit/>
+          </a:bodyPr>
+          <a:lstStyle/>
+          <a:p>
+            <a:pPr>
+              <a:spcAft>
+                <a:spcPts val="1100"/>
+              </a:spcAft>
+              <a:defRPr sz="1800" b="1">
+                <a:solidFill>
+                  <a:srgbClr val="0B253F"/>
+                </a:solidFill>
+                <a:latin typeface="Arial"/>
+              </a:defRPr>
+            </a:pPr>
+            <a:r>
+              <a:t>rotafy.  /  NEXUS</a:t>
+            </a:r>
+          </a:p>
+        </p:txBody>
+      </p:sp>
+      <p:sp>
+        <p:nvSpPr>
+          <p:cNvPr id="4" name="TextBox 3"/>
+          <p:cNvSpPr txBox="1"/>
+          <p:nvPr/>
+        </p:nvSpPr>
+        <p:spPr>
+          <a:xfrm>
+            <a:off x="10424160" y="365760"/>
+            <a:ext cx="1188720" cy="320040"/>
+          </a:xfrm>
+          <a:prstGeom prst="rect">
+            <a:avLst/>
+          </a:prstGeom>
+          <a:noFill/>
+        </p:spPr>
+        <p:txBody>
+          <a:bodyPr wrap="square" lIns="18288" rIns="18288" tIns="18288" bIns="18288">
+            <a:spAutoFit/>
+          </a:bodyPr>
+          <a:lstStyle/>
+          <a:p>
+            <a:pPr>
+              <a:spcAft>
+                <a:spcPts val="1100"/>
+              </a:spcAft>
+              <a:defRPr sz="1200" b="0">
+                <a:solidFill>
+                  <a:srgbClr val="0B253F"/>
+                </a:solidFill>
+                <a:latin typeface="Arial"/>
+              </a:defRPr>
+            </a:pPr>
+            <a:r>
+              <a:t>24 / 25</a:t>
+            </a:r>
+          </a:p>
+        </p:txBody>
+      </p:sp>
+      <p:sp>
+        <p:nvSpPr>
+          <p:cNvPr id="5" name="TextBox 4"/>
+          <p:cNvSpPr txBox="1"/>
+          <p:nvPr/>
+        </p:nvSpPr>
+        <p:spPr>
+          <a:xfrm>
+            <a:off x="594360" y="914400"/>
+            <a:ext cx="10789920" cy="365760"/>
+          </a:xfrm>
+          <a:prstGeom prst="rect">
+            <a:avLst/>
+          </a:prstGeom>
+          <a:noFill/>
+        </p:spPr>
+        <p:txBody>
+          <a:bodyPr wrap="square" lIns="18288" rIns="18288" tIns="18288" bIns="18288">
+            <a:spAutoFit/>
+          </a:bodyPr>
+          <a:lstStyle/>
+          <a:p>
+            <a:pPr>
+              <a:spcAft>
+                <a:spcPts val="1100"/>
+              </a:spcAft>
+              <a:defRPr sz="1100" b="1">
+                <a:solidFill>
+                  <a:srgbClr val="0C7A76"/>
+                </a:solidFill>
+                <a:latin typeface="Arial"/>
+              </a:defRPr>
+            </a:pPr>
+            <a:r>
+              <a:t>COMPATÍVEL COM SUA OPERAÇÃO</a:t>
+            </a:r>
+          </a:p>
+        </p:txBody>
+      </p:sp>
+      <p:sp>
+        <p:nvSpPr>
+          <p:cNvPr id="6" name="TextBox 5"/>
+          <p:cNvSpPr txBox="1"/>
+          <p:nvPr/>
+        </p:nvSpPr>
+        <p:spPr>
+          <a:xfrm>
+            <a:off x="594360" y="1389888"/>
+            <a:ext cx="10789920" cy="1170432"/>
+          </a:xfrm>
+          <a:prstGeom prst="rect">
+            <a:avLst/>
+          </a:prstGeom>
+          <a:noFill/>
+        </p:spPr>
+        <p:txBody>
+          <a:bodyPr wrap="square" lIns="18288" rIns="18288" tIns="18288" bIns="18288">
+            <a:spAutoFit/>
+          </a:bodyPr>
+          <a:lstStyle/>
+          <a:p>
+            <a:pPr>
+              <a:spcAft>
+                <a:spcPts val="1100"/>
+              </a:spcAft>
+              <a:defRPr sz="3600" b="1">
+                <a:solidFill>
+                  <a:srgbClr val="0B253F"/>
+                </a:solidFill>
+                <a:latin typeface="Arial"/>
+              </a:defRPr>
+            </a:pPr>
+            <a:r>
+              <a:t>Use o sistema completo</a:t>
+            </a:r>
+          </a:p>
+          <a:p>
+            <a:pPr>
+              <a:spcAft>
+                <a:spcPts val="1100"/>
+              </a:spcAft>
+              <a:defRPr sz="3600" b="1">
+                <a:solidFill>
+                  <a:srgbClr val="0B253F"/>
+                </a:solidFill>
+                <a:latin typeface="Arial"/>
+              </a:defRPr>
+            </a:pPr>
+            <a:r>
+              <a:t>ou integre ao seu app.</a:t>
+            </a:r>
+          </a:p>
+        </p:txBody>
+      </p:sp>
+      <p:sp>
+        <p:nvSpPr>
+          <p:cNvPr id="7" name="TextBox 6"/>
+          <p:cNvSpPr txBox="1"/>
+          <p:nvPr/>
+        </p:nvSpPr>
+        <p:spPr>
+          <a:xfrm>
+            <a:off x="594360" y="2651760"/>
+            <a:ext cx="10789920" cy="658368"/>
+          </a:xfrm>
+          <a:prstGeom prst="rect">
+            <a:avLst/>
+          </a:prstGeom>
+          <a:noFill/>
+        </p:spPr>
+        <p:txBody>
+          <a:bodyPr wrap="square" lIns="18288" rIns="18288" tIns="18288" bIns="18288">
+            <a:spAutoFit/>
+          </a:bodyPr>
+          <a:lstStyle/>
+          <a:p>
+            <a:pPr>
+              <a:spcAft>
+                <a:spcPts val="1100"/>
+              </a:spcAft>
+              <a:defRPr sz="2000" b="0">
+                <a:solidFill>
+                  <a:srgbClr val="577084"/>
+                </a:solidFill>
+                <a:latin typeface="Arial"/>
+              </a:defRPr>
+            </a:pPr>
+            <a:r>
+              <a:t>Módulos adequados ao que a empresa precisa.</a:t>
+            </a:r>
+          </a:p>
+        </p:txBody>
+      </p:sp>
+      <p:sp>
+        <p:nvSpPr>
+          <p:cNvPr id="8" name="TextBox 7"/>
+          <p:cNvSpPr txBox="1"/>
+          <p:nvPr/>
+        </p:nvSpPr>
+        <p:spPr>
+          <a:xfrm>
+            <a:off x="640080" y="3520440"/>
+            <a:ext cx="10789920" cy="2194560"/>
+          </a:xfrm>
+          <a:prstGeom prst="rect">
+            <a:avLst/>
+          </a:prstGeom>
+          <a:noFill/>
+        </p:spPr>
+        <p:txBody>
+          <a:bodyPr wrap="square" lIns="18288" rIns="18288" tIns="18288" bIns="18288">
+            <a:spAutoFit/>
+          </a:bodyPr>
+          <a:lstStyle/>
+          <a:p>
+            <a:pPr>
+              <a:spcAft>
+                <a:spcPts val="1100"/>
+              </a:spcAft>
+              <a:defRPr sz="1800" b="0">
+                <a:solidFill>
+                  <a:srgbClr val="0B253F"/>
+                </a:solidFill>
+                <a:latin typeface="Arial"/>
+              </a:defRPr>
+            </a:pPr>
+            <a:r>
+              <a:t>• WhatsApp e bilhetes podem complementar um sistema de vendas parceiro.</a:t>
+            </a:r>
+          </a:p>
+          <a:p>
+            <a:pPr>
+              <a:spcAft>
+                <a:spcPts val="1100"/>
+              </a:spcAft>
+              <a:defRPr sz="1800" b="0">
+                <a:solidFill>
+                  <a:srgbClr val="0B253F"/>
+                </a:solidFill>
+                <a:latin typeface="Arial"/>
+              </a:defRPr>
+            </a:pPr>
+            <a:r>
+              <a:t>• Dados sincronizados apoiam a comunicação e a operação da viagem.</a:t>
+            </a:r>
+          </a:p>
+          <a:p>
+            <a:pPr>
+              <a:spcAft>
+                <a:spcPts val="1100"/>
+              </a:spcAft>
+              <a:defRPr sz="1800" b="0">
+                <a:solidFill>
+                  <a:srgbClr val="0B253F"/>
+                </a:solidFill>
+                <a:latin typeface="Arial"/>
+              </a:defRPr>
+            </a:pPr>
+            <a:r>
+              <a:t>• Motorista e guia registram embarque e desembarque no Android.</a:t>
+            </a:r>
+          </a:p>
+          <a:p>
+            <a:pPr>
+              <a:spcAft>
+                <a:spcPts val="1100"/>
+              </a:spcAft>
+              <a:defRPr sz="1800" b="0">
+                <a:solidFill>
+                  <a:srgbClr val="0B253F"/>
+                </a:solidFill>
+                <a:latin typeface="Arial"/>
+              </a:defRPr>
+            </a:pPr>
+            <a:r>
+              <a:t>• Permissões por empresa e credenciais de integração controladas.</a:t>
+            </a:r>
+          </a:p>
+        </p:txBody>
+      </p:sp>
+      <p:sp>
+        <p:nvSpPr>
+          <p:cNvPr id="9" name="TextBox 8"/>
+          <p:cNvSpPr txBox="1"/>
+          <p:nvPr/>
+        </p:nvSpPr>
+        <p:spPr>
+          <a:xfrm>
+            <a:off x="594360" y="6217920"/>
+            <a:ext cx="10972800" cy="411480"/>
+          </a:xfrm>
+          <a:prstGeom prst="rect">
+            <a:avLst/>
+          </a:prstGeom>
+          <a:noFill/>
+        </p:spPr>
+        <p:txBody>
+          <a:bodyPr wrap="square" lIns="18288" rIns="18288" tIns="18288" bIns="18288">
+            <a:spAutoFit/>
+          </a:bodyPr>
+          <a:lstStyle/>
+          <a:p>
+            <a:pPr>
+              <a:spcAft>
+                <a:spcPts val="1100"/>
+              </a:spcAft>
+              <a:defRPr sz="1100" b="0">
+                <a:solidFill>
+                  <a:srgbClr val="577084"/>
+                </a:solidFill>
+                <a:latin typeface="Arial"/>
+              </a:defRPr>
+            </a:pPr>
+            <a:r>
+              <a:t>O conjunto de módulos depende da configuração da empresa.</a:t>
+            </a:r>
+          </a:p>
+        </p:txBody>
+      </p:sp>
+    </p:spTree>
+  </p:cSld>
+  <p:clrMapOvr>
+    <a:masterClrMapping/>
+  </p:clrMapOvr>
+</p:sld>
+</file>
+
+<file path=ppt/slides/slide25.xml><?xml version="1.0" encoding="utf-8"?>
 <p:sld xmlns:a="http://schemas.openxmlformats.org/drawingml/2006/main" xmlns:p="http://schemas.openxmlformats.org/presentationml/2006/main" xmlns:r="http://schemas.openxmlformats.org/officeDocument/2006/relationships">
   <p:cSld>
     <p:bg>
@@ -9685,7 +12070,7 @@
               </a:defRPr>
             </a:pPr>
             <a:r>
-              <a:t>20 / 20</a:t>
+              <a:t>25 / 25</a:t>
             </a:r>
           </a:p>
         </p:txBody>
@@ -10075,7 +12460,7 @@
               </a:defRPr>
             </a:pPr>
             <a:r>
-              <a:t>03 / 20</a:t>
+              <a:t>03 / 25</a:t>
             </a:r>
           </a:p>
         </p:txBody>
@@ -10465,7 +12850,7 @@
               </a:defRPr>
             </a:pPr>
             <a:r>
-              <a:t>04 / 20</a:t>
+              <a:t>04 / 25</a:t>
             </a:r>
           </a:p>
         </p:txBody>
@@ -10855,7 +13240,7 @@
               </a:defRPr>
             </a:pPr>
             <a:r>
-              <a:t>05 / 20</a:t>
+              <a:t>05 / 25</a:t>
             </a:r>
           </a:p>
         </p:txBody>
@@ -11245,7 +13630,7 @@
               </a:defRPr>
             </a:pPr>
             <a:r>
-              <a:t>06 / 20</a:t>
+              <a:t>06 / 25</a:t>
             </a:r>
           </a:p>
         </p:txBody>
@@ -11433,7 +13818,7 @@
               </a:defRPr>
             </a:pPr>
             <a:r>
-              <a:t>• Motorista e guias definidos em cada alocação.</a:t>
+              <a:t>• Mais de um motorista e guia podem acompanhar o mesmo veículo.</a:t>
             </a:r>
           </a:p>
           <a:p>
@@ -11635,7 +14020,7 @@
               </a:defRPr>
             </a:pPr>
             <a:r>
-              <a:t>07 / 20</a:t>
+              <a:t>07 / 25</a:t>
             </a:r>
           </a:p>
         </p:txBody>
@@ -12049,7 +14434,7 @@
               </a:defRPr>
             </a:pPr>
             <a:r>
-              <a:t>08 / 20</a:t>
+              <a:t>08 / 25</a:t>
             </a:r>
           </a:p>
         </p:txBody>
@@ -12439,7 +14824,7 @@
               </a:defRPr>
             </a:pPr>
             <a:r>
-              <a:t>09 / 20</a:t>
+              <a:t>09 / 25</a:t>
             </a:r>
           </a:p>
         </p:txBody>

</xml_diff>

<commit_message>
feat: add WhatsApp NPS surveys and satisfaction reporting
</commit_message>
<xml_diff>
--- a/frontend/public/documentacao/apresentacao.pptx
+++ b/frontend/public/documentacao/apresentacao.pptx
@@ -30,6 +30,7 @@
     <p:sldId id="278" r:id="rId30"/>
     <p:sldId id="279" r:id="rId31"/>
     <p:sldId id="280" r:id="rId32"/>
+    <p:sldId id="281" r:id="rId33"/>
   </p:sldIdLst>
   <p:sldSz cx="12191695" cy="6858000" type="screen4x3"/>
   <p:notesSz cx="6858000" cy="9144000"/>
@@ -1672,6 +1673,76 @@
 </file>
 
 <file path=ppt/notesSlides/notesSlide25.xml><?xml version="1.0" encoding="utf-8"?>
+<p:notes xmlns:a="http://schemas.openxmlformats.org/drawingml/2006/main" xmlns:p="http://schemas.openxmlformats.org/presentationml/2006/main" xmlns:r="http://schemas.openxmlformats.org/officeDocument/2006/relationships">
+  <p:cSld>
+    <p:spTree>
+      <p:nvGrpSpPr>
+        <p:cNvPr id="1" name=""/>
+        <p:cNvGrpSpPr/>
+        <p:nvPr/>
+      </p:nvGrpSpPr>
+      <p:grpSpPr>
+        <a:xfrm>
+          <a:off x="0" y="0"/>
+          <a:ext cx="0" cy="0"/>
+          <a:chOff x="0" y="0"/>
+          <a:chExt cx="0" cy="0"/>
+        </a:xfrm>
+      </p:grpSpPr>
+      <p:sp>
+        <p:nvSpPr>
+          <p:cNvPr id="2" name="Slide Image Placeholder 1"/>
+          <p:cNvSpPr>
+            <a:spLocks noGrp="1"/>
+          </p:cNvSpPr>
+          <p:nvPr>
+            <p:ph type="sldImg" idx="2"/>
+          </p:nvPr>
+        </p:nvSpPr>
+        <p:spPr/>
+      </p:sp>
+      <p:sp>
+        <p:nvSpPr>
+          <p:cNvPr id="3" name="Notes Placeholder 2"/>
+          <p:cNvSpPr>
+            <a:spLocks noGrp="1"/>
+          </p:cNvSpPr>
+          <p:nvPr>
+            <p:ph type="body" idx="3" sz="quarter"/>
+          </p:nvPr>
+        </p:nvSpPr>
+        <p:spPr/>
+        <p:txBody>
+          <a:bodyPr/>
+          <a:lstStyle/>
+          <a:p>
+            <a:r>
+              <a:t>O cliente avalia pelo próprio WhatsApp. A equipe consulta indicadores e comentários para orientar melhorias.</a:t>
+            </a:r>
+          </a:p>
+        </p:txBody>
+      </p:sp>
+      <p:sp>
+        <p:nvSpPr>
+          <p:cNvPr id="4" name="Slide Number Placeholder 3"/>
+          <p:cNvSpPr>
+            <a:spLocks noGrp="1"/>
+          </p:cNvSpPr>
+          <p:nvPr>
+            <p:ph type="sldNum" idx="5" sz="quarter"/>
+          </p:nvPr>
+        </p:nvSpPr>
+        <p:spPr/>
+      </p:sp>
+    </p:spTree>
+  </p:cSld>
+  <p:clrMapOvr>
+    <a:masterClrMapping/>
+  </p:clrMapOvr>
+</p:notes>
+</file>
+
+<file path=ppt/notesSlides/notesSlide26.xml><?xml version="1.0" encoding="utf-8"?>
 <p:notes xmlns:a="http://schemas.openxmlformats.org/drawingml/2006/main" xmlns:p="http://schemas.openxmlformats.org/presentationml/2006/main" xmlns:r="http://schemas.openxmlformats.org/officeDocument/2006/relationships">
   <p:cSld>
     <p:spTree>
@@ -5336,7 +5407,7 @@
               </a:defRPr>
             </a:pPr>
             <a:r>
-              <a:t>01 / 25</a:t>
+              <a:t>01 / 26</a:t>
             </a:r>
           </a:p>
         </p:txBody>
@@ -5726,7 +5797,7 @@
               </a:defRPr>
             </a:pPr>
             <a:r>
-              <a:t>10 / 25</a:t>
+              <a:t>10 / 26</a:t>
             </a:r>
           </a:p>
         </p:txBody>
@@ -6116,7 +6187,7 @@
               </a:defRPr>
             </a:pPr>
             <a:r>
-              <a:t>11 / 25</a:t>
+              <a:t>11 / 26</a:t>
             </a:r>
           </a:p>
         </p:txBody>
@@ -6506,7 +6577,7 @@
               </a:defRPr>
             </a:pPr>
             <a:r>
-              <a:t>12 / 25</a:t>
+              <a:t>12 / 26</a:t>
             </a:r>
           </a:p>
         </p:txBody>
@@ -6896,7 +6967,7 @@
               </a:defRPr>
             </a:pPr>
             <a:r>
-              <a:t>13 / 25</a:t>
+              <a:t>13 / 26</a:t>
             </a:r>
           </a:p>
         </p:txBody>
@@ -7286,7 +7357,7 @@
               </a:defRPr>
             </a:pPr>
             <a:r>
-              <a:t>14 / 25</a:t>
+              <a:t>14 / 26</a:t>
             </a:r>
           </a:p>
         </p:txBody>
@@ -7676,7 +7747,7 @@
               </a:defRPr>
             </a:pPr>
             <a:r>
-              <a:t>15 / 25</a:t>
+              <a:t>15 / 26</a:t>
             </a:r>
           </a:p>
         </p:txBody>
@@ -8066,7 +8137,7 @@
               </a:defRPr>
             </a:pPr>
             <a:r>
-              <a:t>16 / 25</a:t>
+              <a:t>16 / 26</a:t>
             </a:r>
           </a:p>
         </p:txBody>
@@ -8480,7 +8551,7 @@
               </a:defRPr>
             </a:pPr>
             <a:r>
-              <a:t>17 / 25</a:t>
+              <a:t>17 / 26</a:t>
             </a:r>
           </a:p>
         </p:txBody>
@@ -8870,7 +8941,7 @@
               </a:defRPr>
             </a:pPr>
             <a:r>
-              <a:t>18 / 25</a:t>
+              <a:t>18 / 26</a:t>
             </a:r>
           </a:p>
         </p:txBody>
@@ -9260,7 +9331,7 @@
               </a:defRPr>
             </a:pPr>
             <a:r>
-              <a:t>19 / 25</a:t>
+              <a:t>19 / 26</a:t>
             </a:r>
           </a:p>
         </p:txBody>
@@ -9650,7 +9721,7 @@
               </a:defRPr>
             </a:pPr>
             <a:r>
-              <a:t>02 / 25</a:t>
+              <a:t>02 / 26</a:t>
             </a:r>
           </a:p>
         </p:txBody>
@@ -10040,7 +10111,7 @@
               </a:defRPr>
             </a:pPr>
             <a:r>
-              <a:t>20 / 25</a:t>
+              <a:t>20 / 26</a:t>
             </a:r>
           </a:p>
         </p:txBody>
@@ -10446,7 +10517,7 @@
               </a:defRPr>
             </a:pPr>
             <a:r>
-              <a:t>21 / 25</a:t>
+              <a:t>21 / 26</a:t>
             </a:r>
           </a:p>
         </p:txBody>
@@ -10852,7 +10923,7 @@
               </a:defRPr>
             </a:pPr>
             <a:r>
-              <a:t>22 / 25</a:t>
+              <a:t>22 / 26</a:t>
             </a:r>
           </a:p>
         </p:txBody>
@@ -11258,7 +11329,7 @@
               </a:defRPr>
             </a:pPr>
             <a:r>
-              <a:t>23 / 25</a:t>
+              <a:t>23 / 26</a:t>
             </a:r>
           </a:p>
         </p:txBody>
@@ -11664,7 +11735,7 @@
               </a:defRPr>
             </a:pPr>
             <a:r>
-              <a:t>24 / 25</a:t>
+              <a:t>24 / 26</a:t>
             </a:r>
           </a:p>
         </p:txBody>
@@ -11937,6 +12008,412 @@
 </file>
 
 <file path=ppt/slides/slide25.xml><?xml version="1.0" encoding="utf-8"?>
+<p:sld xmlns:a="http://schemas.openxmlformats.org/drawingml/2006/main" xmlns:p="http://schemas.openxmlformats.org/presentationml/2006/main" xmlns:r="http://schemas.openxmlformats.org/officeDocument/2006/relationships">
+  <p:cSld>
+    <p:bg>
+      <p:bgPr>
+        <a:solidFill>
+          <a:srgbClr val="F4F7FA"/>
+        </a:solidFill>
+        <a:effectLst/>
+      </p:bgPr>
+    </p:bg>
+    <p:spTree>
+      <p:nvGrpSpPr>
+        <p:cNvPr id="1" name=""/>
+        <p:cNvGrpSpPr/>
+        <p:nvPr/>
+      </p:nvGrpSpPr>
+      <p:grpSpPr/>
+      <p:sp>
+        <p:nvSpPr>
+          <p:cNvPr id="2" name="Rectangle 1"/>
+          <p:cNvSpPr/>
+          <p:nvPr/>
+        </p:nvSpPr>
+        <p:spPr>
+          <a:xfrm>
+            <a:off x="0" y="0"/>
+            <a:ext cx="109728" cy="6858000"/>
+          </a:xfrm>
+          <a:prstGeom prst="rect">
+            <a:avLst/>
+          </a:prstGeom>
+          <a:solidFill>
+            <a:srgbClr val="0C7A76"/>
+          </a:solidFill>
+          <a:ln>
+            <a:noFill/>
+          </a:ln>
+        </p:spPr>
+        <p:style>
+          <a:lnRef idx="1">
+            <a:schemeClr val="accent1"/>
+          </a:lnRef>
+          <a:fillRef idx="3">
+            <a:schemeClr val="accent1"/>
+          </a:fillRef>
+          <a:effectRef idx="2">
+            <a:schemeClr val="accent1"/>
+          </a:effectRef>
+          <a:fontRef idx="minor">
+            <a:schemeClr val="lt1"/>
+          </a:fontRef>
+        </p:style>
+        <p:txBody>
+          <a:bodyPr rtlCol="0" anchor="ctr"/>
+          <a:lstStyle/>
+          <a:p>
+            <a:pPr algn="ctr"/>
+          </a:p>
+        </p:txBody>
+      </p:sp>
+      <p:sp>
+        <p:nvSpPr>
+          <p:cNvPr id="3" name="TextBox 2"/>
+          <p:cNvSpPr txBox="1"/>
+          <p:nvPr/>
+        </p:nvSpPr>
+        <p:spPr>
+          <a:xfrm>
+            <a:off x="594360" y="320040"/>
+            <a:ext cx="2743200" cy="365760"/>
+          </a:xfrm>
+          <a:prstGeom prst="rect">
+            <a:avLst/>
+          </a:prstGeom>
+          <a:noFill/>
+        </p:spPr>
+        <p:txBody>
+          <a:bodyPr wrap="square" lIns="18288" rIns="18288" tIns="18288" bIns="18288">
+            <a:spAutoFit/>
+          </a:bodyPr>
+          <a:lstStyle/>
+          <a:p>
+            <a:pPr>
+              <a:spcAft>
+                <a:spcPts val="1100"/>
+              </a:spcAft>
+              <a:defRPr sz="1800" b="1">
+                <a:solidFill>
+                  <a:srgbClr val="0B253F"/>
+                </a:solidFill>
+                <a:latin typeface="Arial"/>
+              </a:defRPr>
+            </a:pPr>
+            <a:r>
+              <a:t>rotafy.  /  NEXUS</a:t>
+            </a:r>
+          </a:p>
+        </p:txBody>
+      </p:sp>
+      <p:sp>
+        <p:nvSpPr>
+          <p:cNvPr id="4" name="TextBox 3"/>
+          <p:cNvSpPr txBox="1"/>
+          <p:nvPr/>
+        </p:nvSpPr>
+        <p:spPr>
+          <a:xfrm>
+            <a:off x="10424160" y="365760"/>
+            <a:ext cx="1188720" cy="320040"/>
+          </a:xfrm>
+          <a:prstGeom prst="rect">
+            <a:avLst/>
+          </a:prstGeom>
+          <a:noFill/>
+        </p:spPr>
+        <p:txBody>
+          <a:bodyPr wrap="square" lIns="18288" rIns="18288" tIns="18288" bIns="18288">
+            <a:spAutoFit/>
+          </a:bodyPr>
+          <a:lstStyle/>
+          <a:p>
+            <a:pPr>
+              <a:spcAft>
+                <a:spcPts val="1100"/>
+              </a:spcAft>
+              <a:defRPr sz="1200" b="0">
+                <a:solidFill>
+                  <a:srgbClr val="0B253F"/>
+                </a:solidFill>
+                <a:latin typeface="Arial"/>
+              </a:defRPr>
+            </a:pPr>
+            <a:r>
+              <a:t>25 / 26</a:t>
+            </a:r>
+          </a:p>
+        </p:txBody>
+      </p:sp>
+      <p:sp>
+        <p:nvSpPr>
+          <p:cNvPr id="5" name="TextBox 4"/>
+          <p:cNvSpPr txBox="1"/>
+          <p:nvPr/>
+        </p:nvSpPr>
+        <p:spPr>
+          <a:xfrm>
+            <a:off x="594360" y="914400"/>
+            <a:ext cx="10789920" cy="365760"/>
+          </a:xfrm>
+          <a:prstGeom prst="rect">
+            <a:avLst/>
+          </a:prstGeom>
+          <a:noFill/>
+        </p:spPr>
+        <p:txBody>
+          <a:bodyPr wrap="square" lIns="18288" rIns="18288" tIns="18288" bIns="18288">
+            <a:spAutoFit/>
+          </a:bodyPr>
+          <a:lstStyle/>
+          <a:p>
+            <a:pPr>
+              <a:spcAft>
+                <a:spcPts val="1100"/>
+              </a:spcAft>
+              <a:defRPr sz="1100" b="1">
+                <a:solidFill>
+                  <a:srgbClr val="0C7A76"/>
+                </a:solidFill>
+                <a:latin typeface="Arial"/>
+              </a:defRPr>
+            </a:pPr>
+            <a:r>
+              <a:t>A VOZ DO CLIENTE</a:t>
+            </a:r>
+          </a:p>
+        </p:txBody>
+      </p:sp>
+      <p:sp>
+        <p:nvSpPr>
+          <p:cNvPr id="6" name="TextBox 5"/>
+          <p:cNvSpPr txBox="1"/>
+          <p:nvPr/>
+        </p:nvSpPr>
+        <p:spPr>
+          <a:xfrm>
+            <a:off x="594360" y="1389888"/>
+            <a:ext cx="10789920" cy="1170432"/>
+          </a:xfrm>
+          <a:prstGeom prst="rect">
+            <a:avLst/>
+          </a:prstGeom>
+          <a:noFill/>
+        </p:spPr>
+        <p:txBody>
+          <a:bodyPr wrap="square" lIns="18288" rIns="18288" tIns="18288" bIns="18288">
+            <a:spAutoFit/>
+          </a:bodyPr>
+          <a:lstStyle/>
+          <a:p>
+            <a:pPr>
+              <a:spcAft>
+                <a:spcPts val="1100"/>
+              </a:spcAft>
+              <a:defRPr sz="3600" b="1">
+                <a:solidFill>
+                  <a:srgbClr val="0B253F"/>
+                </a:solidFill>
+                <a:latin typeface="Arial"/>
+              </a:defRPr>
+            </a:pPr>
+            <a:r>
+              <a:t>Ouça. Meça.</a:t>
+            </a:r>
+          </a:p>
+          <a:p>
+            <a:pPr>
+              <a:spcAft>
+                <a:spcPts val="1100"/>
+              </a:spcAft>
+              <a:defRPr sz="3600" b="1">
+                <a:solidFill>
+                  <a:srgbClr val="0B253F"/>
+                </a:solidFill>
+                <a:latin typeface="Arial"/>
+              </a:defRPr>
+            </a:pPr>
+            <a:r>
+              <a:t>Melhore a experiência.</a:t>
+            </a:r>
+          </a:p>
+        </p:txBody>
+      </p:sp>
+      <p:sp>
+        <p:nvSpPr>
+          <p:cNvPr id="7" name="TextBox 6"/>
+          <p:cNvSpPr txBox="1"/>
+          <p:nvPr/>
+        </p:nvSpPr>
+        <p:spPr>
+          <a:xfrm>
+            <a:off x="594360" y="2651760"/>
+            <a:ext cx="10789920" cy="658368"/>
+          </a:xfrm>
+          <a:prstGeom prst="rect">
+            <a:avLst/>
+          </a:prstGeom>
+          <a:noFill/>
+        </p:spPr>
+        <p:txBody>
+          <a:bodyPr wrap="square" lIns="18288" rIns="18288" tIns="18288" bIns="18288">
+            <a:spAutoFit/>
+          </a:bodyPr>
+          <a:lstStyle/>
+          <a:p>
+            <a:pPr>
+              <a:spcAft>
+                <a:spcPts val="1100"/>
+              </a:spcAft>
+              <a:defRPr sz="2000" b="0">
+                <a:solidFill>
+                  <a:srgbClr val="577084"/>
+                </a:solidFill>
+                <a:latin typeface="Arial"/>
+              </a:defRPr>
+            </a:pPr>
+            <a:r>
+              <a:t>NPS integrado ao atendimento e às viagens.</a:t>
+            </a:r>
+          </a:p>
+        </p:txBody>
+      </p:sp>
+      <p:sp>
+        <p:nvSpPr>
+          <p:cNvPr id="8" name="TextBox 7"/>
+          <p:cNvSpPr txBox="1"/>
+          <p:nvPr/>
+        </p:nvSpPr>
+        <p:spPr>
+          <a:xfrm>
+            <a:off x="640080" y="3520440"/>
+            <a:ext cx="10789920" cy="2194560"/>
+          </a:xfrm>
+          <a:prstGeom prst="rect">
+            <a:avLst/>
+          </a:prstGeom>
+          <a:noFill/>
+        </p:spPr>
+        <p:txBody>
+          <a:bodyPr wrap="square" lIns="18288" rIns="18288" tIns="18288" bIns="18288">
+            <a:spAutoFit/>
+          </a:bodyPr>
+          <a:lstStyle/>
+          <a:p>
+            <a:pPr>
+              <a:spcAft>
+                <a:spcPts val="1100"/>
+              </a:spcAft>
+              <a:defRPr sz="1800" b="0">
+                <a:solidFill>
+                  <a:srgbClr val="0B253F"/>
+                </a:solidFill>
+                <a:latin typeface="Arial"/>
+              </a:defRPr>
+            </a:pPr>
+            <a:r>
+              <a:t>• Pesquisa pelo WhatsApp após atendimento humano e viagem concluída.</a:t>
+            </a:r>
+          </a:p>
+          <a:p>
+            <a:pPr>
+              <a:spcAft>
+                <a:spcPts val="1100"/>
+              </a:spcAft>
+              <a:defRPr sz="1800" b="0">
+                <a:solidFill>
+                  <a:srgbClr val="0B253F"/>
+                </a:solidFill>
+                <a:latin typeface="Arial"/>
+              </a:defRPr>
+            </a:pPr>
+            <a:r>
+              <a:t>• Nota de recomendação e comentário opcional, sem abrir links.</a:t>
+            </a:r>
+          </a:p>
+          <a:p>
+            <a:pPr>
+              <a:spcAft>
+                <a:spcPts val="1100"/>
+              </a:spcAft>
+              <a:defRPr sz="1800" b="0">
+                <a:solidFill>
+                  <a:srgbClr val="0B253F"/>
+                </a:solidFill>
+                <a:latin typeface="Arial"/>
+              </a:defRPr>
+            </a:pPr>
+            <a:r>
+              <a:t>• Indicadores de satisfação, promotores, neutros e detratores.</a:t>
+            </a:r>
+          </a:p>
+          <a:p>
+            <a:pPr>
+              <a:spcAft>
+                <a:spcPts val="1100"/>
+              </a:spcAft>
+              <a:defRPr sz="1800" b="0">
+                <a:solidFill>
+                  <a:srgbClr val="0B253F"/>
+                </a:solidFill>
+                <a:latin typeface="Arial"/>
+              </a:defRPr>
+            </a:pPr>
+            <a:r>
+              <a:t>• Filtros por período e viagem, com relatórios CSV e PDF.</a:t>
+            </a:r>
+          </a:p>
+        </p:txBody>
+      </p:sp>
+      <p:sp>
+        <p:nvSpPr>
+          <p:cNvPr id="9" name="TextBox 8"/>
+          <p:cNvSpPr txBox="1"/>
+          <p:nvPr/>
+        </p:nvSpPr>
+        <p:spPr>
+          <a:xfrm>
+            <a:off x="594360" y="6217920"/>
+            <a:ext cx="10972800" cy="411480"/>
+          </a:xfrm>
+          <a:prstGeom prst="rect">
+            <a:avLst/>
+          </a:prstGeom>
+          <a:noFill/>
+        </p:spPr>
+        <p:txBody>
+          <a:bodyPr wrap="square" lIns="18288" rIns="18288" tIns="18288" bIns="18288">
+            <a:spAutoFit/>
+          </a:bodyPr>
+          <a:lstStyle/>
+          <a:p>
+            <a:pPr>
+              <a:spcAft>
+                <a:spcPts val="1100"/>
+              </a:spcAft>
+              <a:defRPr sz="1100" b="0">
+                <a:solidFill>
+                  <a:srgbClr val="577084"/>
+                </a:solidFill>
+                <a:latin typeface="Arial"/>
+              </a:defRPr>
+            </a:pPr>
+            <a:r>
+              <a:t>Pesquisas habilitadas pelo administrador; cada avaliação pertence à empresa.</a:t>
+            </a:r>
+          </a:p>
+        </p:txBody>
+      </p:sp>
+    </p:spTree>
+  </p:cSld>
+  <p:clrMapOvr>
+    <a:masterClrMapping/>
+  </p:clrMapOvr>
+</p:sld>
+</file>
+
+<file path=ppt/slides/slide26.xml><?xml version="1.0" encoding="utf-8"?>
 <p:sld xmlns:a="http://schemas.openxmlformats.org/drawingml/2006/main" xmlns:p="http://schemas.openxmlformats.org/presentationml/2006/main" xmlns:r="http://schemas.openxmlformats.org/officeDocument/2006/relationships">
   <p:cSld>
     <p:bg>
@@ -12070,7 +12547,7 @@
               </a:defRPr>
             </a:pPr>
             <a:r>
-              <a:t>25 / 25</a:t>
+              <a:t>26 / 26</a:t>
             </a:r>
           </a:p>
         </p:txBody>
@@ -12460,7 +12937,7 @@
               </a:defRPr>
             </a:pPr>
             <a:r>
-              <a:t>03 / 25</a:t>
+              <a:t>03 / 26</a:t>
             </a:r>
           </a:p>
         </p:txBody>
@@ -12850,7 +13327,7 @@
               </a:defRPr>
             </a:pPr>
             <a:r>
-              <a:t>04 / 25</a:t>
+              <a:t>04 / 26</a:t>
             </a:r>
           </a:p>
         </p:txBody>
@@ -13240,7 +13717,7 @@
               </a:defRPr>
             </a:pPr>
             <a:r>
-              <a:t>05 / 25</a:t>
+              <a:t>05 / 26</a:t>
             </a:r>
           </a:p>
         </p:txBody>
@@ -13630,7 +14107,7 @@
               </a:defRPr>
             </a:pPr>
             <a:r>
-              <a:t>06 / 25</a:t>
+              <a:t>06 / 26</a:t>
             </a:r>
           </a:p>
         </p:txBody>
@@ -14020,7 +14497,7 @@
               </a:defRPr>
             </a:pPr>
             <a:r>
-              <a:t>07 / 25</a:t>
+              <a:t>07 / 26</a:t>
             </a:r>
           </a:p>
         </p:txBody>
@@ -14434,7 +14911,7 @@
               </a:defRPr>
             </a:pPr>
             <a:r>
-              <a:t>08 / 25</a:t>
+              <a:t>08 / 26</a:t>
             </a:r>
           </a:p>
         </p:txBody>
@@ -14824,7 +15301,7 @@
               </a:defRPr>
             </a:pPr>
             <a:r>
-              <a:t>09 / 25</a:t>
+              <a:t>09 / 26</a:t>
             </a:r>
           </a:p>
         </p:txBody>

</xml_diff>

<commit_message>
feat: add WhatsApp NPS surveys and satisfaction reporting (#35)
Co-authored-by: cfartes <23644292+cfartes@users.noreply.github.com>
</commit_message>
<xml_diff>
--- a/frontend/public/documentacao/apresentacao.pptx
+++ b/frontend/public/documentacao/apresentacao.pptx
@@ -30,6 +30,7 @@
     <p:sldId id="278" r:id="rId30"/>
     <p:sldId id="279" r:id="rId31"/>
     <p:sldId id="280" r:id="rId32"/>
+    <p:sldId id="281" r:id="rId33"/>
   </p:sldIdLst>
   <p:sldSz cx="12191695" cy="6858000" type="screen4x3"/>
   <p:notesSz cx="6858000" cy="9144000"/>
@@ -1672,6 +1673,76 @@
 </file>
 
 <file path=ppt/notesSlides/notesSlide25.xml><?xml version="1.0" encoding="utf-8"?>
+<p:notes xmlns:a="http://schemas.openxmlformats.org/drawingml/2006/main" xmlns:p="http://schemas.openxmlformats.org/presentationml/2006/main" xmlns:r="http://schemas.openxmlformats.org/officeDocument/2006/relationships">
+  <p:cSld>
+    <p:spTree>
+      <p:nvGrpSpPr>
+        <p:cNvPr id="1" name=""/>
+        <p:cNvGrpSpPr/>
+        <p:nvPr/>
+      </p:nvGrpSpPr>
+      <p:grpSpPr>
+        <a:xfrm>
+          <a:off x="0" y="0"/>
+          <a:ext cx="0" cy="0"/>
+          <a:chOff x="0" y="0"/>
+          <a:chExt cx="0" cy="0"/>
+        </a:xfrm>
+      </p:grpSpPr>
+      <p:sp>
+        <p:nvSpPr>
+          <p:cNvPr id="2" name="Slide Image Placeholder 1"/>
+          <p:cNvSpPr>
+            <a:spLocks noGrp="1"/>
+          </p:cNvSpPr>
+          <p:nvPr>
+            <p:ph type="sldImg" idx="2"/>
+          </p:nvPr>
+        </p:nvSpPr>
+        <p:spPr/>
+      </p:sp>
+      <p:sp>
+        <p:nvSpPr>
+          <p:cNvPr id="3" name="Notes Placeholder 2"/>
+          <p:cNvSpPr>
+            <a:spLocks noGrp="1"/>
+          </p:cNvSpPr>
+          <p:nvPr>
+            <p:ph type="body" idx="3" sz="quarter"/>
+          </p:nvPr>
+        </p:nvSpPr>
+        <p:spPr/>
+        <p:txBody>
+          <a:bodyPr/>
+          <a:lstStyle/>
+          <a:p>
+            <a:r>
+              <a:t>O cliente avalia pelo próprio WhatsApp. A equipe consulta indicadores e comentários para orientar melhorias.</a:t>
+            </a:r>
+          </a:p>
+        </p:txBody>
+      </p:sp>
+      <p:sp>
+        <p:nvSpPr>
+          <p:cNvPr id="4" name="Slide Number Placeholder 3"/>
+          <p:cNvSpPr>
+            <a:spLocks noGrp="1"/>
+          </p:cNvSpPr>
+          <p:nvPr>
+            <p:ph type="sldNum" idx="5" sz="quarter"/>
+          </p:nvPr>
+        </p:nvSpPr>
+        <p:spPr/>
+      </p:sp>
+    </p:spTree>
+  </p:cSld>
+  <p:clrMapOvr>
+    <a:masterClrMapping/>
+  </p:clrMapOvr>
+</p:notes>
+</file>
+
+<file path=ppt/notesSlides/notesSlide26.xml><?xml version="1.0" encoding="utf-8"?>
 <p:notes xmlns:a="http://schemas.openxmlformats.org/drawingml/2006/main" xmlns:p="http://schemas.openxmlformats.org/presentationml/2006/main" xmlns:r="http://schemas.openxmlformats.org/officeDocument/2006/relationships">
   <p:cSld>
     <p:spTree>
@@ -5336,7 +5407,7 @@
               </a:defRPr>
             </a:pPr>
             <a:r>
-              <a:t>01 / 25</a:t>
+              <a:t>01 / 26</a:t>
             </a:r>
           </a:p>
         </p:txBody>
@@ -5726,7 +5797,7 @@
               </a:defRPr>
             </a:pPr>
             <a:r>
-              <a:t>10 / 25</a:t>
+              <a:t>10 / 26</a:t>
             </a:r>
           </a:p>
         </p:txBody>
@@ -6116,7 +6187,7 @@
               </a:defRPr>
             </a:pPr>
             <a:r>
-              <a:t>11 / 25</a:t>
+              <a:t>11 / 26</a:t>
             </a:r>
           </a:p>
         </p:txBody>
@@ -6506,7 +6577,7 @@
               </a:defRPr>
             </a:pPr>
             <a:r>
-              <a:t>12 / 25</a:t>
+              <a:t>12 / 26</a:t>
             </a:r>
           </a:p>
         </p:txBody>
@@ -6896,7 +6967,7 @@
               </a:defRPr>
             </a:pPr>
             <a:r>
-              <a:t>13 / 25</a:t>
+              <a:t>13 / 26</a:t>
             </a:r>
           </a:p>
         </p:txBody>
@@ -7286,7 +7357,7 @@
               </a:defRPr>
             </a:pPr>
             <a:r>
-              <a:t>14 / 25</a:t>
+              <a:t>14 / 26</a:t>
             </a:r>
           </a:p>
         </p:txBody>
@@ -7676,7 +7747,7 @@
               </a:defRPr>
             </a:pPr>
             <a:r>
-              <a:t>15 / 25</a:t>
+              <a:t>15 / 26</a:t>
             </a:r>
           </a:p>
         </p:txBody>
@@ -8066,7 +8137,7 @@
               </a:defRPr>
             </a:pPr>
             <a:r>
-              <a:t>16 / 25</a:t>
+              <a:t>16 / 26</a:t>
             </a:r>
           </a:p>
         </p:txBody>
@@ -8480,7 +8551,7 @@
               </a:defRPr>
             </a:pPr>
             <a:r>
-              <a:t>17 / 25</a:t>
+              <a:t>17 / 26</a:t>
             </a:r>
           </a:p>
         </p:txBody>
@@ -8870,7 +8941,7 @@
               </a:defRPr>
             </a:pPr>
             <a:r>
-              <a:t>18 / 25</a:t>
+              <a:t>18 / 26</a:t>
             </a:r>
           </a:p>
         </p:txBody>
@@ -9260,7 +9331,7 @@
               </a:defRPr>
             </a:pPr>
             <a:r>
-              <a:t>19 / 25</a:t>
+              <a:t>19 / 26</a:t>
             </a:r>
           </a:p>
         </p:txBody>
@@ -9650,7 +9721,7 @@
               </a:defRPr>
             </a:pPr>
             <a:r>
-              <a:t>02 / 25</a:t>
+              <a:t>02 / 26</a:t>
             </a:r>
           </a:p>
         </p:txBody>
@@ -10040,7 +10111,7 @@
               </a:defRPr>
             </a:pPr>
             <a:r>
-              <a:t>20 / 25</a:t>
+              <a:t>20 / 26</a:t>
             </a:r>
           </a:p>
         </p:txBody>
@@ -10446,7 +10517,7 @@
               </a:defRPr>
             </a:pPr>
             <a:r>
-              <a:t>21 / 25</a:t>
+              <a:t>21 / 26</a:t>
             </a:r>
           </a:p>
         </p:txBody>
@@ -10852,7 +10923,7 @@
               </a:defRPr>
             </a:pPr>
             <a:r>
-              <a:t>22 / 25</a:t>
+              <a:t>22 / 26</a:t>
             </a:r>
           </a:p>
         </p:txBody>
@@ -11258,7 +11329,7 @@
               </a:defRPr>
             </a:pPr>
             <a:r>
-              <a:t>23 / 25</a:t>
+              <a:t>23 / 26</a:t>
             </a:r>
           </a:p>
         </p:txBody>
@@ -11664,7 +11735,7 @@
               </a:defRPr>
             </a:pPr>
             <a:r>
-              <a:t>24 / 25</a:t>
+              <a:t>24 / 26</a:t>
             </a:r>
           </a:p>
         </p:txBody>
@@ -11937,6 +12008,412 @@
 </file>
 
 <file path=ppt/slides/slide25.xml><?xml version="1.0" encoding="utf-8"?>
+<p:sld xmlns:a="http://schemas.openxmlformats.org/drawingml/2006/main" xmlns:p="http://schemas.openxmlformats.org/presentationml/2006/main" xmlns:r="http://schemas.openxmlformats.org/officeDocument/2006/relationships">
+  <p:cSld>
+    <p:bg>
+      <p:bgPr>
+        <a:solidFill>
+          <a:srgbClr val="F4F7FA"/>
+        </a:solidFill>
+        <a:effectLst/>
+      </p:bgPr>
+    </p:bg>
+    <p:spTree>
+      <p:nvGrpSpPr>
+        <p:cNvPr id="1" name=""/>
+        <p:cNvGrpSpPr/>
+        <p:nvPr/>
+      </p:nvGrpSpPr>
+      <p:grpSpPr/>
+      <p:sp>
+        <p:nvSpPr>
+          <p:cNvPr id="2" name="Rectangle 1"/>
+          <p:cNvSpPr/>
+          <p:nvPr/>
+        </p:nvSpPr>
+        <p:spPr>
+          <a:xfrm>
+            <a:off x="0" y="0"/>
+            <a:ext cx="109728" cy="6858000"/>
+          </a:xfrm>
+          <a:prstGeom prst="rect">
+            <a:avLst/>
+          </a:prstGeom>
+          <a:solidFill>
+            <a:srgbClr val="0C7A76"/>
+          </a:solidFill>
+          <a:ln>
+            <a:noFill/>
+          </a:ln>
+        </p:spPr>
+        <p:style>
+          <a:lnRef idx="1">
+            <a:schemeClr val="accent1"/>
+          </a:lnRef>
+          <a:fillRef idx="3">
+            <a:schemeClr val="accent1"/>
+          </a:fillRef>
+          <a:effectRef idx="2">
+            <a:schemeClr val="accent1"/>
+          </a:effectRef>
+          <a:fontRef idx="minor">
+            <a:schemeClr val="lt1"/>
+          </a:fontRef>
+        </p:style>
+        <p:txBody>
+          <a:bodyPr rtlCol="0" anchor="ctr"/>
+          <a:lstStyle/>
+          <a:p>
+            <a:pPr algn="ctr"/>
+          </a:p>
+        </p:txBody>
+      </p:sp>
+      <p:sp>
+        <p:nvSpPr>
+          <p:cNvPr id="3" name="TextBox 2"/>
+          <p:cNvSpPr txBox="1"/>
+          <p:nvPr/>
+        </p:nvSpPr>
+        <p:spPr>
+          <a:xfrm>
+            <a:off x="594360" y="320040"/>
+            <a:ext cx="2743200" cy="365760"/>
+          </a:xfrm>
+          <a:prstGeom prst="rect">
+            <a:avLst/>
+          </a:prstGeom>
+          <a:noFill/>
+        </p:spPr>
+        <p:txBody>
+          <a:bodyPr wrap="square" lIns="18288" rIns="18288" tIns="18288" bIns="18288">
+            <a:spAutoFit/>
+          </a:bodyPr>
+          <a:lstStyle/>
+          <a:p>
+            <a:pPr>
+              <a:spcAft>
+                <a:spcPts val="1100"/>
+              </a:spcAft>
+              <a:defRPr sz="1800" b="1">
+                <a:solidFill>
+                  <a:srgbClr val="0B253F"/>
+                </a:solidFill>
+                <a:latin typeface="Arial"/>
+              </a:defRPr>
+            </a:pPr>
+            <a:r>
+              <a:t>rotafy.  /  NEXUS</a:t>
+            </a:r>
+          </a:p>
+        </p:txBody>
+      </p:sp>
+      <p:sp>
+        <p:nvSpPr>
+          <p:cNvPr id="4" name="TextBox 3"/>
+          <p:cNvSpPr txBox="1"/>
+          <p:nvPr/>
+        </p:nvSpPr>
+        <p:spPr>
+          <a:xfrm>
+            <a:off x="10424160" y="365760"/>
+            <a:ext cx="1188720" cy="320040"/>
+          </a:xfrm>
+          <a:prstGeom prst="rect">
+            <a:avLst/>
+          </a:prstGeom>
+          <a:noFill/>
+        </p:spPr>
+        <p:txBody>
+          <a:bodyPr wrap="square" lIns="18288" rIns="18288" tIns="18288" bIns="18288">
+            <a:spAutoFit/>
+          </a:bodyPr>
+          <a:lstStyle/>
+          <a:p>
+            <a:pPr>
+              <a:spcAft>
+                <a:spcPts val="1100"/>
+              </a:spcAft>
+              <a:defRPr sz="1200" b="0">
+                <a:solidFill>
+                  <a:srgbClr val="0B253F"/>
+                </a:solidFill>
+                <a:latin typeface="Arial"/>
+              </a:defRPr>
+            </a:pPr>
+            <a:r>
+              <a:t>25 / 26</a:t>
+            </a:r>
+          </a:p>
+        </p:txBody>
+      </p:sp>
+      <p:sp>
+        <p:nvSpPr>
+          <p:cNvPr id="5" name="TextBox 4"/>
+          <p:cNvSpPr txBox="1"/>
+          <p:nvPr/>
+        </p:nvSpPr>
+        <p:spPr>
+          <a:xfrm>
+            <a:off x="594360" y="914400"/>
+            <a:ext cx="10789920" cy="365760"/>
+          </a:xfrm>
+          <a:prstGeom prst="rect">
+            <a:avLst/>
+          </a:prstGeom>
+          <a:noFill/>
+        </p:spPr>
+        <p:txBody>
+          <a:bodyPr wrap="square" lIns="18288" rIns="18288" tIns="18288" bIns="18288">
+            <a:spAutoFit/>
+          </a:bodyPr>
+          <a:lstStyle/>
+          <a:p>
+            <a:pPr>
+              <a:spcAft>
+                <a:spcPts val="1100"/>
+              </a:spcAft>
+              <a:defRPr sz="1100" b="1">
+                <a:solidFill>
+                  <a:srgbClr val="0C7A76"/>
+                </a:solidFill>
+                <a:latin typeface="Arial"/>
+              </a:defRPr>
+            </a:pPr>
+            <a:r>
+              <a:t>A VOZ DO CLIENTE</a:t>
+            </a:r>
+          </a:p>
+        </p:txBody>
+      </p:sp>
+      <p:sp>
+        <p:nvSpPr>
+          <p:cNvPr id="6" name="TextBox 5"/>
+          <p:cNvSpPr txBox="1"/>
+          <p:nvPr/>
+        </p:nvSpPr>
+        <p:spPr>
+          <a:xfrm>
+            <a:off x="594360" y="1389888"/>
+            <a:ext cx="10789920" cy="1170432"/>
+          </a:xfrm>
+          <a:prstGeom prst="rect">
+            <a:avLst/>
+          </a:prstGeom>
+          <a:noFill/>
+        </p:spPr>
+        <p:txBody>
+          <a:bodyPr wrap="square" lIns="18288" rIns="18288" tIns="18288" bIns="18288">
+            <a:spAutoFit/>
+          </a:bodyPr>
+          <a:lstStyle/>
+          <a:p>
+            <a:pPr>
+              <a:spcAft>
+                <a:spcPts val="1100"/>
+              </a:spcAft>
+              <a:defRPr sz="3600" b="1">
+                <a:solidFill>
+                  <a:srgbClr val="0B253F"/>
+                </a:solidFill>
+                <a:latin typeface="Arial"/>
+              </a:defRPr>
+            </a:pPr>
+            <a:r>
+              <a:t>Ouça. Meça.</a:t>
+            </a:r>
+          </a:p>
+          <a:p>
+            <a:pPr>
+              <a:spcAft>
+                <a:spcPts val="1100"/>
+              </a:spcAft>
+              <a:defRPr sz="3600" b="1">
+                <a:solidFill>
+                  <a:srgbClr val="0B253F"/>
+                </a:solidFill>
+                <a:latin typeface="Arial"/>
+              </a:defRPr>
+            </a:pPr>
+            <a:r>
+              <a:t>Melhore a experiência.</a:t>
+            </a:r>
+          </a:p>
+        </p:txBody>
+      </p:sp>
+      <p:sp>
+        <p:nvSpPr>
+          <p:cNvPr id="7" name="TextBox 6"/>
+          <p:cNvSpPr txBox="1"/>
+          <p:nvPr/>
+        </p:nvSpPr>
+        <p:spPr>
+          <a:xfrm>
+            <a:off x="594360" y="2651760"/>
+            <a:ext cx="10789920" cy="658368"/>
+          </a:xfrm>
+          <a:prstGeom prst="rect">
+            <a:avLst/>
+          </a:prstGeom>
+          <a:noFill/>
+        </p:spPr>
+        <p:txBody>
+          <a:bodyPr wrap="square" lIns="18288" rIns="18288" tIns="18288" bIns="18288">
+            <a:spAutoFit/>
+          </a:bodyPr>
+          <a:lstStyle/>
+          <a:p>
+            <a:pPr>
+              <a:spcAft>
+                <a:spcPts val="1100"/>
+              </a:spcAft>
+              <a:defRPr sz="2000" b="0">
+                <a:solidFill>
+                  <a:srgbClr val="577084"/>
+                </a:solidFill>
+                <a:latin typeface="Arial"/>
+              </a:defRPr>
+            </a:pPr>
+            <a:r>
+              <a:t>NPS integrado ao atendimento e às viagens.</a:t>
+            </a:r>
+          </a:p>
+        </p:txBody>
+      </p:sp>
+      <p:sp>
+        <p:nvSpPr>
+          <p:cNvPr id="8" name="TextBox 7"/>
+          <p:cNvSpPr txBox="1"/>
+          <p:nvPr/>
+        </p:nvSpPr>
+        <p:spPr>
+          <a:xfrm>
+            <a:off x="640080" y="3520440"/>
+            <a:ext cx="10789920" cy="2194560"/>
+          </a:xfrm>
+          <a:prstGeom prst="rect">
+            <a:avLst/>
+          </a:prstGeom>
+          <a:noFill/>
+        </p:spPr>
+        <p:txBody>
+          <a:bodyPr wrap="square" lIns="18288" rIns="18288" tIns="18288" bIns="18288">
+            <a:spAutoFit/>
+          </a:bodyPr>
+          <a:lstStyle/>
+          <a:p>
+            <a:pPr>
+              <a:spcAft>
+                <a:spcPts val="1100"/>
+              </a:spcAft>
+              <a:defRPr sz="1800" b="0">
+                <a:solidFill>
+                  <a:srgbClr val="0B253F"/>
+                </a:solidFill>
+                <a:latin typeface="Arial"/>
+              </a:defRPr>
+            </a:pPr>
+            <a:r>
+              <a:t>• Pesquisa pelo WhatsApp após atendimento humano e viagem concluída.</a:t>
+            </a:r>
+          </a:p>
+          <a:p>
+            <a:pPr>
+              <a:spcAft>
+                <a:spcPts val="1100"/>
+              </a:spcAft>
+              <a:defRPr sz="1800" b="0">
+                <a:solidFill>
+                  <a:srgbClr val="0B253F"/>
+                </a:solidFill>
+                <a:latin typeface="Arial"/>
+              </a:defRPr>
+            </a:pPr>
+            <a:r>
+              <a:t>• Nota de recomendação e comentário opcional, sem abrir links.</a:t>
+            </a:r>
+          </a:p>
+          <a:p>
+            <a:pPr>
+              <a:spcAft>
+                <a:spcPts val="1100"/>
+              </a:spcAft>
+              <a:defRPr sz="1800" b="0">
+                <a:solidFill>
+                  <a:srgbClr val="0B253F"/>
+                </a:solidFill>
+                <a:latin typeface="Arial"/>
+              </a:defRPr>
+            </a:pPr>
+            <a:r>
+              <a:t>• Indicadores de satisfação, promotores, neutros e detratores.</a:t>
+            </a:r>
+          </a:p>
+          <a:p>
+            <a:pPr>
+              <a:spcAft>
+                <a:spcPts val="1100"/>
+              </a:spcAft>
+              <a:defRPr sz="1800" b="0">
+                <a:solidFill>
+                  <a:srgbClr val="0B253F"/>
+                </a:solidFill>
+                <a:latin typeface="Arial"/>
+              </a:defRPr>
+            </a:pPr>
+            <a:r>
+              <a:t>• Filtros por período e viagem, com relatórios CSV e PDF.</a:t>
+            </a:r>
+          </a:p>
+        </p:txBody>
+      </p:sp>
+      <p:sp>
+        <p:nvSpPr>
+          <p:cNvPr id="9" name="TextBox 8"/>
+          <p:cNvSpPr txBox="1"/>
+          <p:nvPr/>
+        </p:nvSpPr>
+        <p:spPr>
+          <a:xfrm>
+            <a:off x="594360" y="6217920"/>
+            <a:ext cx="10972800" cy="411480"/>
+          </a:xfrm>
+          <a:prstGeom prst="rect">
+            <a:avLst/>
+          </a:prstGeom>
+          <a:noFill/>
+        </p:spPr>
+        <p:txBody>
+          <a:bodyPr wrap="square" lIns="18288" rIns="18288" tIns="18288" bIns="18288">
+            <a:spAutoFit/>
+          </a:bodyPr>
+          <a:lstStyle/>
+          <a:p>
+            <a:pPr>
+              <a:spcAft>
+                <a:spcPts val="1100"/>
+              </a:spcAft>
+              <a:defRPr sz="1100" b="0">
+                <a:solidFill>
+                  <a:srgbClr val="577084"/>
+                </a:solidFill>
+                <a:latin typeface="Arial"/>
+              </a:defRPr>
+            </a:pPr>
+            <a:r>
+              <a:t>Pesquisas habilitadas pelo administrador; cada avaliação pertence à empresa.</a:t>
+            </a:r>
+          </a:p>
+        </p:txBody>
+      </p:sp>
+    </p:spTree>
+  </p:cSld>
+  <p:clrMapOvr>
+    <a:masterClrMapping/>
+  </p:clrMapOvr>
+</p:sld>
+</file>
+
+<file path=ppt/slides/slide26.xml><?xml version="1.0" encoding="utf-8"?>
 <p:sld xmlns:a="http://schemas.openxmlformats.org/drawingml/2006/main" xmlns:p="http://schemas.openxmlformats.org/presentationml/2006/main" xmlns:r="http://schemas.openxmlformats.org/officeDocument/2006/relationships">
   <p:cSld>
     <p:bg>
@@ -12070,7 +12547,7 @@
               </a:defRPr>
             </a:pPr>
             <a:r>
-              <a:t>25 / 25</a:t>
+              <a:t>26 / 26</a:t>
             </a:r>
           </a:p>
         </p:txBody>
@@ -12460,7 +12937,7 @@
               </a:defRPr>
             </a:pPr>
             <a:r>
-              <a:t>03 / 25</a:t>
+              <a:t>03 / 26</a:t>
             </a:r>
           </a:p>
         </p:txBody>
@@ -12850,7 +13327,7 @@
               </a:defRPr>
             </a:pPr>
             <a:r>
-              <a:t>04 / 25</a:t>
+              <a:t>04 / 26</a:t>
             </a:r>
           </a:p>
         </p:txBody>
@@ -13240,7 +13717,7 @@
               </a:defRPr>
             </a:pPr>
             <a:r>
-              <a:t>05 / 25</a:t>
+              <a:t>05 / 26</a:t>
             </a:r>
           </a:p>
         </p:txBody>
@@ -13630,7 +14107,7 @@
               </a:defRPr>
             </a:pPr>
             <a:r>
-              <a:t>06 / 25</a:t>
+              <a:t>06 / 26</a:t>
             </a:r>
           </a:p>
         </p:txBody>
@@ -14020,7 +14497,7 @@
               </a:defRPr>
             </a:pPr>
             <a:r>
-              <a:t>07 / 25</a:t>
+              <a:t>07 / 26</a:t>
             </a:r>
           </a:p>
         </p:txBody>
@@ -14434,7 +14911,7 @@
               </a:defRPr>
             </a:pPr>
             <a:r>
-              <a:t>08 / 25</a:t>
+              <a:t>08 / 26</a:t>
             </a:r>
           </a:p>
         </p:txBody>
@@ -14824,7 +15301,7 @@
               </a:defRPr>
             </a:pPr>
             <a:r>
-              <a:t>09 / 25</a:t>
+              <a:t>09 / 26</a:t>
             </a:r>
           </a:p>
         </p:txBody>

</xml_diff>

<commit_message>
feat: humanize NPS feedback and configure company service hours
</commit_message>
<xml_diff>
--- a/frontend/public/documentacao/apresentacao.pptx
+++ b/frontend/public/documentacao/apresentacao.pptx
@@ -1717,7 +1717,7 @@
           <a:lstStyle/>
           <a:p>
             <a:r>
-              <a:t>O cliente avalia pelo próprio WhatsApp. A equipe consulta indicadores e comentários para orientar melhorias.</a:t>
+              <a:t>O NPS diferencia o retorno para promotores, neutros e detratores. Avaliações negativas chegam à equipe de qualidade no app; os relatórios preservam as notas e os comentários.</a:t>
             </a:r>
           </a:p>
         </p:txBody>
@@ -6781,7 +6781,7 @@
               </a:defRPr>
             </a:pPr>
             <a:r>
-              <a:t>• Atendimento humano com pausa das respostas automáticas.</a:t>
+              <a:t>• Atendimento humano com horários informados e pausa da automação.</a:t>
             </a:r>
           </a:p>
         </p:txBody>
@@ -12329,7 +12329,7 @@
               </a:defRPr>
             </a:pPr>
             <a:r>
-              <a:t>• Nota de recomendação e comentário opcional, sem abrir links.</a:t>
+              <a:t>• Respostas acolhedoras conforme a nota e espaço para sugestões.</a:t>
             </a:r>
           </a:p>
           <a:p>

</xml_diff>

<commit_message>
feat: humanize NPS feedback and configure company service hours (#36)
Co-authored-by: cfartes <23644292+cfartes@users.noreply.github.com>
</commit_message>
<xml_diff>
--- a/frontend/public/documentacao/apresentacao.pptx
+++ b/frontend/public/documentacao/apresentacao.pptx
@@ -1717,7 +1717,7 @@
           <a:lstStyle/>
           <a:p>
             <a:r>
-              <a:t>O cliente avalia pelo próprio WhatsApp. A equipe consulta indicadores e comentários para orientar melhorias.</a:t>
+              <a:t>O NPS diferencia o retorno para promotores, neutros e detratores. Avaliações negativas chegam à equipe de qualidade no app; os relatórios preservam as notas e os comentários.</a:t>
             </a:r>
           </a:p>
         </p:txBody>
@@ -6781,7 +6781,7 @@
               </a:defRPr>
             </a:pPr>
             <a:r>
-              <a:t>• Atendimento humano com pausa das respostas automáticas.</a:t>
+              <a:t>• Atendimento humano com horários informados e pausa da automação.</a:t>
             </a:r>
           </a:p>
         </p:txBody>
@@ -12329,7 +12329,7 @@
               </a:defRPr>
             </a:pPr>
             <a:r>
-              <a:t>• Nota de recomendação e comentário opcional, sem abrir links.</a:t>
+              <a:t>• Respostas acolhedoras conforme a nota e espaço para sugestões.</a:t>
             </a:r>
           </a:p>
           <a:p>

</xml_diff>

<commit_message>
fix: preserve NPS on handoff closure and extend inactivity to ten minutes
</commit_message>
<xml_diff>
--- a/frontend/public/documentacao/apresentacao.pptx
+++ b/frontend/public/documentacao/apresentacao.pptx
@@ -1367,7 +1367,7 @@
           <a:lstStyle/>
           <a:p>
             <a:r>
-              <a:t>Informações úteis no próprio WhatsApp. Qualquer texto abre um menu com saudação personalizada. O passageiro consulta seus bilhetes, reserva, veículo e embarque. A equipe assume a conversa quando necessário. O atendimento automático encerra após um minuto de inatividade. A consulta utiliza o telefone vinculado à reserva.</a:t>
+              <a:t>Informações úteis no próprio WhatsApp. Qualquer texto abre um menu com saudação personalizada. O passageiro consulta seus bilhetes, reserva, veículo e embarque. A equipe assume a conversa quando necessário. O atendimento automático encerra após dez minutos de inatividade. A consulta utiliza o telefone vinculado à reserva.</a:t>
             </a:r>
           </a:p>
         </p:txBody>
@@ -10331,7 +10331,7 @@
               </a:defRPr>
             </a:pPr>
             <a:r>
-              <a:t>• O atendimento automático encerra após um minuto de inatividade.</a:t>
+              <a:t>• O atendimento automático encerra após dez minutos de inatividade.</a:t>
             </a:r>
           </a:p>
         </p:txBody>

</xml_diff>

<commit_message>
fix: preserve NPS on handoff closure and extend inactivity to ten minutes (#37)
Co-authored-by: cfartes <23644292+cfartes@users.noreply.github.com>
</commit_message>
<xml_diff>
--- a/frontend/public/documentacao/apresentacao.pptx
+++ b/frontend/public/documentacao/apresentacao.pptx
@@ -1367,7 +1367,7 @@
           <a:lstStyle/>
           <a:p>
             <a:r>
-              <a:t>Informações úteis no próprio WhatsApp. Qualquer texto abre um menu com saudação personalizada. O passageiro consulta seus bilhetes, reserva, veículo e embarque. A equipe assume a conversa quando necessário. O atendimento automático encerra após um minuto de inatividade. A consulta utiliza o telefone vinculado à reserva.</a:t>
+              <a:t>Informações úteis no próprio WhatsApp. Qualquer texto abre um menu com saudação personalizada. O passageiro consulta seus bilhetes, reserva, veículo e embarque. A equipe assume a conversa quando necessário. O atendimento automático encerra após dez minutos de inatividade. A consulta utiliza o telefone vinculado à reserva.</a:t>
             </a:r>
           </a:p>
         </p:txBody>
@@ -10331,7 +10331,7 @@
               </a:defRPr>
             </a:pPr>
             <a:r>
-              <a:t>• O atendimento automático encerra após um minuto de inatividade.</a:t>
+              <a:t>• O atendimento automático encerra após dez minutos de inatividade.</a:t>
             </a:r>
           </a:p>
         </p:txBody>

</xml_diff>

<commit_message>
feat: configure WhatsApp queue interval in Superadmin with 30-second default
</commit_message>
<xml_diff>
--- a/frontend/public/documentacao/apresentacao.pptx
+++ b/frontend/public/documentacao/apresentacao.pptx
@@ -1437,7 +1437,7 @@
           <a:lstStyle/>
           <a:p>
             <a:r>
-              <a:t>Ative o envio automático antes do primeiro embarque. Reservas confirmadas entram na fila até 24 horas antes. Um bilhete por passageiro, válido para todos os trechos contratados. Intervalo mínimo de três minutos entre os envios automáticos. O envio manual permanece disponível para o atendimento. A entrada na fila não garante o horário exato de entrega; acompanhe os envios.</a:t>
+              <a:t>Ative o envio automático antes do primeiro embarque. Reservas confirmadas entram na fila até 24 horas antes. Um bilhete por passageiro, válido para todos os trechos contratados. Intervalo configurado pela Nexus (padrão: 30 segundos) entre os envios automáticos. O envio manual permanece disponível para o atendimento. A entrada na fila não garante o horário exato de entrega; acompanhe os envios.</a:t>
             </a:r>
           </a:p>
         </p:txBody>
@@ -10721,7 +10721,7 @@
               </a:defRPr>
             </a:pPr>
             <a:r>
-              <a:t>• Intervalo mínimo de três minutos entre os envios automáticos.</a:t>
+              <a:t>• Intervalo configurado pela Nexus (padrão: 30 segundos) entre os envios automáticos.</a:t>
             </a:r>
           </a:p>
           <a:p>

</xml_diff>

<commit_message>
feat: configure WhatsApp queue interval in Superadmin with 30-second default (#38)
Co-authored-by: cfartes <23644292+cfartes@users.noreply.github.com>
</commit_message>
<xml_diff>
--- a/frontend/public/documentacao/apresentacao.pptx
+++ b/frontend/public/documentacao/apresentacao.pptx
@@ -1437,7 +1437,7 @@
           <a:lstStyle/>
           <a:p>
             <a:r>
-              <a:t>Ative o envio automático antes do primeiro embarque. Reservas confirmadas entram na fila até 24 horas antes. Um bilhete por passageiro, válido para todos os trechos contratados. Intervalo mínimo de três minutos entre os envios automáticos. O envio manual permanece disponível para o atendimento. A entrada na fila não garante o horário exato de entrega; acompanhe os envios.</a:t>
+              <a:t>Ative o envio automático antes do primeiro embarque. Reservas confirmadas entram na fila até 24 horas antes. Um bilhete por passageiro, válido para todos os trechos contratados. Intervalo configurado pela Nexus (padrão: 30 segundos) entre os envios automáticos. O envio manual permanece disponível para o atendimento. A entrada na fila não garante o horário exato de entrega; acompanhe os envios.</a:t>
             </a:r>
           </a:p>
         </p:txBody>
@@ -10721,7 +10721,7 @@
               </a:defRPr>
             </a:pPr>
             <a:r>
-              <a:t>• Intervalo mínimo de três minutos entre os envios automáticos.</a:t>
+              <a:t>• Intervalo configurado pela Nexus (padrão: 30 segundos) entre os envios automáticos.</a:t>
             </a:r>
           </a:p>
           <a:p>

</xml_diff>